<commit_message>
Fix source accuracy issues and add connections grid to Workshop 3
- Pitch deck: revert <2% stat to "pay for premium" to match Reuters source
- Pitch deck: restore "developers" scope on 19% longer stat (Addy Osmani study)
- Workshop 3: add 6-box connections grid (Web/Email/Calendar/Docs/Data/Custom)
  before research exercise — closes gap identified in REVIEW.md
- Add REVIEW.md: full deck flow analysis and quality assessment of all AI Academy decks

Co-Authored-By: Claude Sonnet 4.6 <noreply@anthropic.com>
</commit_message>
<xml_diff>
--- a/decks/ai-academy-pitch/ai-academy-pitch.pptx
+++ b/decks/ai-academy-pitch/ai-academy-pitch.pptx
@@ -2275,7 +2275,7 @@
                 <a:ea typeface="Calibri" pitchFamily="34" charset="-122"/>
                 <a:cs typeface="Calibri" pitchFamily="34" charset="-120"/>
               </a:rPr>
-              <a:t>use AI tools monthly. Less than 2% use them well.</a:t>
+              <a:t>use AI tools monthly. Fewer than 2% pay for premium.</a:t>
             </a:r>
             <a:endParaRPr lang="en-US" sz="2800" dirty="0"/>
           </a:p>
@@ -2505,7 +2505,7 @@
                 <a:ea typeface="Calibri" pitchFamily="34" charset="-122"/>
                 <a:cs typeface="Calibri" pitchFamily="34" charset="-120"/>
               </a:rPr>
-              <a:t>when you rely on AI without understanding it</a:t>
+              <a:t>when developers rely on AI without understanding it</a:t>
             </a:r>
             <a:endParaRPr lang="en-US" sz="2800" dirty="0"/>
           </a:p>

</xml_diff>

<commit_message>
Migrate all decks to Structured Gradient design system
Deep navy #0A2540 bg, indigo #635BFF accent, warm pink #FF6B8A danger,
Georgia headings + Verdana body. Stripe-inspired aesthetic. Applied to
all 7 decks with fixes for:
- Muted text contrast (#8B95A5 passes WCAG AA at 5.13:1)
- Spectrum label font size reduced for Verdana width (15pt -> 12pt)
- Icon colors updated to match new accent

Co-Authored-By: Claude Opus 4.6 (1M context) <noreply@anthropic.com>
</commit_message>
<xml_diff>
--- a/decks/ai-academy-pitch/ai-academy-pitch.pptx
+++ b/decks/ai-academy-pitch/ai-academy-pitch.pptx
@@ -1662,7 +1662,7 @@
     <p:bg>
       <p:bgPr>
         <a:solidFill>
-          <a:srgbClr val="0F0F1A"/>
+          <a:srgbClr val="0A2540"/>
         </a:solidFill>
       </p:bgPr>
     </p:bg>
@@ -1695,7 +1695,7 @@
             <a:avLst/>
           </a:prstGeom>
           <a:solidFill>
-            <a:srgbClr val="00B4D8">
+            <a:srgbClr val="635BFF">
               <a:alpha val="4000"/>
             </a:srgbClr>
           </a:solidFill>
@@ -1768,11 +1768,11 @@
             <a:r>
               <a:rPr lang="en-US" sz="2200" i="1" dirty="0">
                 <a:solidFill>
-                  <a:srgbClr val="94A3B8"/>
-                </a:solidFill>
-                <a:latin typeface="Calibri" pitchFamily="34" charset="0"/>
-                <a:ea typeface="Calibri" pitchFamily="34" charset="-122"/>
-                <a:cs typeface="Calibri" pitchFamily="34" charset="-120"/>
+                  <a:srgbClr val="8B95A5"/>
+                </a:solidFill>
+                <a:latin typeface="Verdana" pitchFamily="34" charset="0"/>
+                <a:ea typeface="Verdana" pitchFamily="34" charset="-122"/>
+                <a:cs typeface="Verdana" pitchFamily="34" charset="-120"/>
               </a:rPr>
               <a:t>From Explorer to Orchestrator in four lunch hours</a:t>
             </a:r>
@@ -1794,7 +1794,7 @@
     <p:bg>
       <p:bgPr>
         <a:solidFill>
-          <a:srgbClr val="0F0F1A"/>
+          <a:srgbClr val="0A2540"/>
         </a:solidFill>
       </p:bgPr>
     </p:bg>
@@ -1827,7 +1827,7 @@
             <a:avLst/>
           </a:prstGeom>
           <a:solidFill>
-            <a:srgbClr val="00B4D8">
+            <a:srgbClr val="635BFF">
               <a:alpha val="4000"/>
             </a:srgbClr>
           </a:solidFill>
@@ -1900,11 +1900,11 @@
             <a:r>
               <a:rPr lang="en-US" sz="2800" dirty="0">
                 <a:solidFill>
-                  <a:srgbClr val="94A3B8"/>
-                </a:solidFill>
-                <a:latin typeface="Calibri" pitchFamily="34" charset="0"/>
-                <a:ea typeface="Calibri" pitchFamily="34" charset="-122"/>
-                <a:cs typeface="Calibri" pitchFamily="34" charset="-120"/>
+                  <a:srgbClr val="8B95A5"/>
+                </a:solidFill>
+                <a:latin typeface="Verdana" pitchFamily="34" charset="0"/>
+                <a:ea typeface="Verdana" pitchFamily="34" charset="-122"/>
+                <a:cs typeface="Verdana" pitchFamily="34" charset="-120"/>
               </a:rPr>
               <a:t>Bring your laptop and a task you do every week.</a:t>
             </a:r>
@@ -1926,7 +1926,7 @@
     <p:bg>
       <p:bgPr>
         <a:solidFill>
-          <a:srgbClr val="0F0F1A"/>
+          <a:srgbClr val="0A2540"/>
         </a:solidFill>
       </p:bgPr>
     </p:bg>
@@ -1959,7 +1959,7 @@
             <a:avLst/>
           </a:prstGeom>
           <a:solidFill>
-            <a:srgbClr val="00B4D8">
+            <a:srgbClr val="635BFF">
               <a:alpha val="4000"/>
             </a:srgbClr>
           </a:solidFill>
@@ -1993,11 +1993,11 @@
             <a:r>
               <a:rPr lang="en-US" sz="2800" b="1" dirty="0">
                 <a:solidFill>
-                  <a:srgbClr val="E0E4E8"/>
-                </a:solidFill>
-                <a:latin typeface="Calibri" pitchFamily="34" charset="0"/>
-                <a:ea typeface="Calibri" pitchFamily="34" charset="-122"/>
-                <a:cs typeface="Calibri" pitchFamily="34" charset="-120"/>
+                  <a:srgbClr val="EDEDED"/>
+                </a:solidFill>
+                <a:latin typeface="Verdana" pitchFamily="34" charset="0"/>
+                <a:ea typeface="Verdana" pitchFamily="34" charset="-122"/>
+                <a:cs typeface="Verdana" pitchFamily="34" charset="-120"/>
               </a:rPr>
               <a:t>Last month, someone spent 45 minutes</a:t>
             </a:r>
@@ -2010,11 +2010,11 @@
             <a:r>
               <a:rPr lang="en-US" sz="2800" b="1" dirty="0">
                 <a:solidFill>
-                  <a:srgbClr val="E0E4E8"/>
-                </a:solidFill>
-                <a:latin typeface="Calibri" pitchFamily="34" charset="0"/>
-                <a:ea typeface="Calibri" pitchFamily="34" charset="-122"/>
-                <a:cs typeface="Calibri" pitchFamily="34" charset="-120"/>
+                  <a:srgbClr val="EDEDED"/>
+                </a:solidFill>
+                <a:latin typeface="Verdana" pitchFamily="34" charset="0"/>
+                <a:ea typeface="Verdana" pitchFamily="34" charset="-122"/>
+                <a:cs typeface="Verdana" pitchFamily="34" charset="-120"/>
               </a:rPr>
               <a:t>on a one-page summary using ChatGPT.</a:t>
             </a:r>
@@ -2027,11 +2027,11 @@
             <a:r>
               <a:rPr lang="en-US" sz="2800" b="1" dirty="0">
                 <a:solidFill>
-                  <a:srgbClr val="E0E4E8"/>
-                </a:solidFill>
-                <a:latin typeface="Calibri" pitchFamily="34" charset="0"/>
-                <a:ea typeface="Calibri" pitchFamily="34" charset="-122"/>
-                <a:cs typeface="Calibri" pitchFamily="34" charset="-120"/>
+                  <a:srgbClr val="EDEDED"/>
+                </a:solidFill>
+                <a:latin typeface="Verdana" pitchFamily="34" charset="0"/>
+                <a:ea typeface="Verdana" pitchFamily="34" charset="-122"/>
+                <a:cs typeface="Verdana" pitchFamily="34" charset="-120"/>
               </a:rPr>
               <a:t>The right approach took 2 minutes.</a:t>
             </a:r>
@@ -2053,7 +2053,7 @@
     <p:bg>
       <p:bgPr>
         <a:solidFill>
-          <a:srgbClr val="0F0F1A"/>
+          <a:srgbClr val="0A2540"/>
         </a:solidFill>
       </p:bgPr>
     </p:bg>
@@ -2086,7 +2086,7 @@
             <a:avLst/>
           </a:prstGeom>
           <a:solidFill>
-            <a:srgbClr val="00B4D8">
+            <a:srgbClr val="635BFF">
               <a:alpha val="4000"/>
             </a:srgbClr>
           </a:solidFill>
@@ -2163,7 +2163,7 @@
     <p:bg>
       <p:bgPr>
         <a:solidFill>
-          <a:srgbClr val="0F0F1A"/>
+          <a:srgbClr val="0A2540"/>
         </a:solidFill>
       </p:bgPr>
     </p:bg>
@@ -2196,7 +2196,7 @@
             <a:avLst/>
           </a:prstGeom>
           <a:solidFill>
-            <a:srgbClr val="00B4D8">
+            <a:srgbClr val="635BFF">
               <a:alpha val="4000"/>
             </a:srgbClr>
           </a:solidFill>
@@ -2269,11 +2269,11 @@
             <a:r>
               <a:rPr lang="en-US" sz="2800" dirty="0">
                 <a:solidFill>
-                  <a:srgbClr val="94A3B8"/>
-                </a:solidFill>
-                <a:latin typeface="Calibri" pitchFamily="34" charset="0"/>
-                <a:ea typeface="Calibri" pitchFamily="34" charset="-122"/>
-                <a:cs typeface="Calibri" pitchFamily="34" charset="-120"/>
+                  <a:srgbClr val="8B95A5"/>
+                </a:solidFill>
+                <a:latin typeface="Verdana" pitchFamily="34" charset="0"/>
+                <a:ea typeface="Verdana" pitchFamily="34" charset="-122"/>
+                <a:cs typeface="Verdana" pitchFamily="34" charset="-120"/>
               </a:rPr>
               <a:t>use AI tools monthly. Fewer than 2% pay for premium.</a:t>
             </a:r>
@@ -2308,11 +2308,11 @@
             <a:r>
               <a:rPr lang="en-US" sz="1100" u="sng" dirty="0">
                 <a:solidFill>
-                  <a:srgbClr val="94A3B8"/>
-                </a:solidFill>
-                <a:latin typeface="Calibri" pitchFamily="34" charset="0"/>
-                <a:ea typeface="Calibri" pitchFamily="34" charset="-122"/>
-                <a:cs typeface="Calibri" pitchFamily="34" charset="-120"/>
+                  <a:srgbClr val="8B95A5"/>
+                </a:solidFill>
+                <a:latin typeface="Verdana" pitchFamily="34" charset="0"/>
+                <a:ea typeface="Verdana" pitchFamily="34" charset="-122"/>
+                <a:cs typeface="Verdana" pitchFamily="34" charset="-120"/>
                 <a:hlinkClick r:id="rId1" invalidUrl="" action="" tgtFrame="" tooltip="" history="1" highlightClick="0" endSnd="0">
                   <a:extLst>
                     <a:ext uri="{A12FA001-AC4F-418D-AE19-62706E023703}">
@@ -2329,11 +2329,11 @@
             <a:r>
               <a:rPr lang="en-US" sz="1100" dirty="0">
                 <a:solidFill>
-                  <a:srgbClr val="94A3B8"/>
-                </a:solidFill>
-                <a:latin typeface="Calibri" pitchFamily="34" charset="0"/>
-                <a:ea typeface="Calibri" pitchFamily="34" charset="-122"/>
-                <a:cs typeface="Calibri" pitchFamily="34" charset="-120"/>
+                  <a:srgbClr val="8B95A5"/>
+                </a:solidFill>
+                <a:latin typeface="Verdana" pitchFamily="34" charset="0"/>
+                <a:ea typeface="Verdana" pitchFamily="34" charset="-122"/>
+                <a:cs typeface="Verdana" pitchFamily="34" charset="-120"/>
               </a:rPr>
               <a:t>, </a:t>
             </a:r>
@@ -2343,11 +2343,11 @@
             <a:r>
               <a:rPr lang="en-US" sz="1100" u="sng" dirty="0">
                 <a:solidFill>
-                  <a:srgbClr val="94A3B8"/>
-                </a:solidFill>
-                <a:latin typeface="Calibri" pitchFamily="34" charset="0"/>
-                <a:ea typeface="Calibri" pitchFamily="34" charset="-122"/>
-                <a:cs typeface="Calibri" pitchFamily="34" charset="-120"/>
+                  <a:srgbClr val="8B95A5"/>
+                </a:solidFill>
+                <a:latin typeface="Verdana" pitchFamily="34" charset="0"/>
+                <a:ea typeface="Verdana" pitchFamily="34" charset="-122"/>
+                <a:cs typeface="Verdana" pitchFamily="34" charset="-120"/>
                 <a:hlinkClick r:id="rId2" invalidUrl="" action="" tgtFrame="" tooltip="" history="1" highlightClick="0" endSnd="0">
                   <a:extLst>
                     <a:ext uri="{A12FA001-AC4F-418D-AE19-62706E023703}">
@@ -2376,7 +2376,7 @@
     <p:bg>
       <p:bgPr>
         <a:solidFill>
-          <a:srgbClr val="0F0F1A"/>
+          <a:srgbClr val="0A2540"/>
         </a:solidFill>
       </p:bgPr>
     </p:bg>
@@ -2409,7 +2409,7 @@
             <a:avLst/>
           </a:prstGeom>
           <a:solidFill>
-            <a:srgbClr val="00B4D8">
+            <a:srgbClr val="635BFF">
               <a:alpha val="4000"/>
             </a:srgbClr>
           </a:solidFill>
@@ -2443,7 +2443,7 @@
             <a:r>
               <a:rPr lang="en-US" sz="8000" b="1" dirty="0">
                 <a:solidFill>
-                  <a:srgbClr val="E63946"/>
+                  <a:srgbClr val="FF6B8A"/>
                 </a:solidFill>
                 <a:latin typeface="Georgia" pitchFamily="34" charset="0"/>
                 <a:ea typeface="Georgia" pitchFamily="34" charset="-122"/>
@@ -2460,7 +2460,7 @@
             <a:r>
               <a:rPr lang="en-US" sz="8000" b="1" dirty="0">
                 <a:solidFill>
-                  <a:srgbClr val="E63946"/>
+                  <a:srgbClr val="FF6B8A"/>
                 </a:solidFill>
                 <a:latin typeface="Georgia" pitchFamily="34" charset="0"/>
                 <a:ea typeface="Georgia" pitchFamily="34" charset="-122"/>
@@ -2499,11 +2499,11 @@
             <a:r>
               <a:rPr lang="en-US" sz="2800" dirty="0">
                 <a:solidFill>
-                  <a:srgbClr val="94A3B8"/>
-                </a:solidFill>
-                <a:latin typeface="Calibri" pitchFamily="34" charset="0"/>
-                <a:ea typeface="Calibri" pitchFamily="34" charset="-122"/>
-                <a:cs typeface="Calibri" pitchFamily="34" charset="-120"/>
+                  <a:srgbClr val="8B95A5"/>
+                </a:solidFill>
+                <a:latin typeface="Verdana" pitchFamily="34" charset="0"/>
+                <a:ea typeface="Verdana" pitchFamily="34" charset="-122"/>
+                <a:cs typeface="Verdana" pitchFamily="34" charset="-120"/>
               </a:rPr>
               <a:t>when developers rely on AI without understanding it</a:t>
             </a:r>
@@ -2538,11 +2538,11 @@
             <a:r>
               <a:rPr lang="en-US" sz="1100" u="sng" dirty="0">
                 <a:solidFill>
-                  <a:srgbClr val="94A3B8"/>
-                </a:solidFill>
-                <a:latin typeface="Calibri" pitchFamily="34" charset="0"/>
-                <a:ea typeface="Calibri" pitchFamily="34" charset="-122"/>
-                <a:cs typeface="Calibri" pitchFamily="34" charset="-120"/>
+                  <a:srgbClr val="8B95A5"/>
+                </a:solidFill>
+                <a:latin typeface="Verdana" pitchFamily="34" charset="0"/>
+                <a:ea typeface="Verdana" pitchFamily="34" charset="-122"/>
+                <a:cs typeface="Verdana" pitchFamily="34" charset="-120"/>
                 <a:hlinkClick r:id="rId1" invalidUrl="" action="" tgtFrame="" tooltip="" history="1" highlightClick="0" endSnd="0">
                   <a:extLst>
                     <a:ext uri="{A12FA001-AC4F-418D-AE19-62706E023703}">
@@ -2571,7 +2571,7 @@
     <p:bg>
       <p:bgPr>
         <a:solidFill>
-          <a:srgbClr val="0F0F1A"/>
+          <a:srgbClr val="0A2540"/>
         </a:solidFill>
       </p:bgPr>
     </p:bg>
@@ -2604,7 +2604,7 @@
             <a:avLst/>
           </a:prstGeom>
           <a:solidFill>
-            <a:srgbClr val="00B4D8">
+            <a:srgbClr val="635BFF">
               <a:alpha val="4000"/>
             </a:srgbClr>
           </a:solidFill>
@@ -2698,7 +2698,7 @@
     <p:bg>
       <p:bgPr>
         <a:solidFill>
-          <a:srgbClr val="0F0F1A"/>
+          <a:srgbClr val="0A2540"/>
         </a:solidFill>
       </p:bgPr>
     </p:bg>
@@ -2731,7 +2731,7 @@
             <a:avLst/>
           </a:prstGeom>
           <a:solidFill>
-            <a:srgbClr val="00B4D8">
+            <a:srgbClr val="635BFF">
               <a:alpha val="4000"/>
             </a:srgbClr>
           </a:solidFill>
@@ -2755,13 +2755,13 @@
             </a:avLst>
           </a:prstGeom>
           <a:solidFill>
-            <a:srgbClr val="0F0F1A">
+            <a:srgbClr val="0A2540">
               <a:alpha val="50000"/>
             </a:srgbClr>
           </a:solidFill>
           <a:ln w="12700">
             <a:solidFill>
-              <a:srgbClr val="94A3B8"/>
+              <a:srgbClr val="8B95A5"/>
             </a:solidFill>
             <a:prstDash val="solid"/>
           </a:ln>
@@ -2792,17 +2792,17 @@
               <a:buNone/>
             </a:pPr>
             <a:r>
-              <a:rPr lang="en-US" sz="1500" b="1" dirty="0">
-                <a:solidFill>
-                  <a:srgbClr val="94A3B8"/>
-                </a:solidFill>
-                <a:latin typeface="Calibri" pitchFamily="34" charset="0"/>
-                <a:ea typeface="Calibri" pitchFamily="34" charset="-122"/>
-                <a:cs typeface="Calibri" pitchFamily="34" charset="-120"/>
+              <a:rPr lang="en-US" sz="1200" b="1" dirty="0">
+                <a:solidFill>
+                  <a:srgbClr val="8B95A5"/>
+                </a:solidFill>
+                <a:latin typeface="Verdana" pitchFamily="34" charset="0"/>
+                <a:ea typeface="Verdana" pitchFamily="34" charset="-122"/>
+                <a:cs typeface="Verdana" pitchFamily="34" charset="-120"/>
               </a:rPr>
               <a:t>Skeptic</a:t>
             </a:r>
-            <a:endParaRPr lang="en-US" sz="1500" dirty="0"/>
+            <a:endParaRPr lang="en-US" sz="1200" dirty="0"/>
           </a:p>
         </p:txBody>
       </p:sp>
@@ -2831,17 +2831,17 @@
               <a:buNone/>
             </a:pPr>
             <a:r>
-              <a:rPr lang="en-US" sz="1400" dirty="0">
-                <a:solidFill>
-                  <a:srgbClr val="94A3B8"/>
-                </a:solidFill>
-                <a:latin typeface="Calibri" pitchFamily="34" charset="0"/>
-                <a:ea typeface="Calibri" pitchFamily="34" charset="-122"/>
-                <a:cs typeface="Calibri" pitchFamily="34" charset="-120"/>
+              <a:rPr lang="en-US" sz="1100" dirty="0">
+                <a:solidFill>
+                  <a:srgbClr val="8B95A5"/>
+                </a:solidFill>
+                <a:latin typeface="Verdana" pitchFamily="34" charset="0"/>
+                <a:ea typeface="Verdana" pitchFamily="34" charset="-122"/>
+                <a:cs typeface="Verdana" pitchFamily="34" charset="-120"/>
               </a:rPr>
               <a:t>→</a:t>
             </a:r>
-            <a:endParaRPr lang="en-US" sz="1400" dirty="0"/>
+            <a:endParaRPr lang="en-US" sz="1100" dirty="0"/>
           </a:p>
         </p:txBody>
       </p:sp>
@@ -2862,11 +2862,11 @@
             </a:avLst>
           </a:prstGeom>
           <a:solidFill>
-            <a:srgbClr val="00B4D8"/>
+            <a:srgbClr val="635BFF"/>
           </a:solidFill>
           <a:ln w="25400">
             <a:solidFill>
-              <a:srgbClr val="00B4D8"/>
+              <a:srgbClr val="635BFF"/>
             </a:solidFill>
             <a:prstDash val="solid"/>
           </a:ln>
@@ -2897,17 +2897,17 @@
               <a:buNone/>
             </a:pPr>
             <a:r>
-              <a:rPr lang="en-US" sz="1500" b="1" dirty="0">
+              <a:rPr lang="en-US" sz="1200" b="1" dirty="0">
                 <a:solidFill>
                   <a:srgbClr val="FFFFFF"/>
                 </a:solidFill>
-                <a:latin typeface="Calibri" pitchFamily="34" charset="0"/>
-                <a:ea typeface="Calibri" pitchFamily="34" charset="-122"/>
-                <a:cs typeface="Calibri" pitchFamily="34" charset="-120"/>
+                <a:latin typeface="Verdana" pitchFamily="34" charset="0"/>
+                <a:ea typeface="Verdana" pitchFamily="34" charset="-122"/>
+                <a:cs typeface="Verdana" pitchFamily="34" charset="-120"/>
               </a:rPr>
               <a:t>Explorer</a:t>
             </a:r>
-            <a:endParaRPr lang="en-US" sz="1500" dirty="0"/>
+            <a:endParaRPr lang="en-US" sz="1200" dirty="0"/>
           </a:p>
         </p:txBody>
       </p:sp>
@@ -2936,17 +2936,17 @@
               <a:buNone/>
             </a:pPr>
             <a:r>
-              <a:rPr lang="en-US" sz="1400" dirty="0">
-                <a:solidFill>
-                  <a:srgbClr val="94A3B8"/>
-                </a:solidFill>
-                <a:latin typeface="Calibri" pitchFamily="34" charset="0"/>
-                <a:ea typeface="Calibri" pitchFamily="34" charset="-122"/>
-                <a:cs typeface="Calibri" pitchFamily="34" charset="-120"/>
+              <a:rPr lang="en-US" sz="1100" dirty="0">
+                <a:solidFill>
+                  <a:srgbClr val="8B95A5"/>
+                </a:solidFill>
+                <a:latin typeface="Verdana" pitchFamily="34" charset="0"/>
+                <a:ea typeface="Verdana" pitchFamily="34" charset="-122"/>
+                <a:cs typeface="Verdana" pitchFamily="34" charset="-120"/>
               </a:rPr>
               <a:t>→</a:t>
             </a:r>
-            <a:endParaRPr lang="en-US" sz="1400" dirty="0"/>
+            <a:endParaRPr lang="en-US" sz="1100" dirty="0"/>
           </a:p>
         </p:txBody>
       </p:sp>
@@ -2967,13 +2967,13 @@
             </a:avLst>
           </a:prstGeom>
           <a:solidFill>
-            <a:srgbClr val="0F0F1A">
+            <a:srgbClr val="0A2540">
               <a:alpha val="50000"/>
             </a:srgbClr>
           </a:solidFill>
           <a:ln w="12700">
             <a:solidFill>
-              <a:srgbClr val="94A3B8"/>
+              <a:srgbClr val="8B95A5"/>
             </a:solidFill>
             <a:prstDash val="solid"/>
           </a:ln>
@@ -3004,17 +3004,17 @@
               <a:buNone/>
             </a:pPr>
             <a:r>
-              <a:rPr lang="en-US" sz="1500" b="1" dirty="0">
-                <a:solidFill>
-                  <a:srgbClr val="94A3B8"/>
-                </a:solidFill>
-                <a:latin typeface="Calibri" pitchFamily="34" charset="0"/>
-                <a:ea typeface="Calibri" pitchFamily="34" charset="-122"/>
-                <a:cs typeface="Calibri" pitchFamily="34" charset="-120"/>
+              <a:rPr lang="en-US" sz="1200" b="1" dirty="0">
+                <a:solidFill>
+                  <a:srgbClr val="8B95A5"/>
+                </a:solidFill>
+                <a:latin typeface="Verdana" pitchFamily="34" charset="0"/>
+                <a:ea typeface="Verdana" pitchFamily="34" charset="-122"/>
+                <a:cs typeface="Verdana" pitchFamily="34" charset="-120"/>
               </a:rPr>
               <a:t>Whisperer</a:t>
             </a:r>
-            <a:endParaRPr lang="en-US" sz="1500" dirty="0"/>
+            <a:endParaRPr lang="en-US" sz="1200" dirty="0"/>
           </a:p>
         </p:txBody>
       </p:sp>
@@ -3043,17 +3043,17 @@
               <a:buNone/>
             </a:pPr>
             <a:r>
-              <a:rPr lang="en-US" sz="1400" dirty="0">
-                <a:solidFill>
-                  <a:srgbClr val="94A3B8"/>
-                </a:solidFill>
-                <a:latin typeface="Calibri" pitchFamily="34" charset="0"/>
-                <a:ea typeface="Calibri" pitchFamily="34" charset="-122"/>
-                <a:cs typeface="Calibri" pitchFamily="34" charset="-120"/>
+              <a:rPr lang="en-US" sz="1100" dirty="0">
+                <a:solidFill>
+                  <a:srgbClr val="8B95A5"/>
+                </a:solidFill>
+                <a:latin typeface="Verdana" pitchFamily="34" charset="0"/>
+                <a:ea typeface="Verdana" pitchFamily="34" charset="-122"/>
+                <a:cs typeface="Verdana" pitchFamily="34" charset="-120"/>
               </a:rPr>
               <a:t>→</a:t>
             </a:r>
-            <a:endParaRPr lang="en-US" sz="1400" dirty="0"/>
+            <a:endParaRPr lang="en-US" sz="1100" dirty="0"/>
           </a:p>
         </p:txBody>
       </p:sp>
@@ -3074,13 +3074,13 @@
             </a:avLst>
           </a:prstGeom>
           <a:solidFill>
-            <a:srgbClr val="0F0F1A">
+            <a:srgbClr val="0A2540">
               <a:alpha val="50000"/>
             </a:srgbClr>
           </a:solidFill>
           <a:ln w="12700">
             <a:solidFill>
-              <a:srgbClr val="94A3B8"/>
+              <a:srgbClr val="8B95A5"/>
             </a:solidFill>
             <a:prstDash val="solid"/>
           </a:ln>
@@ -3111,17 +3111,17 @@
               <a:buNone/>
             </a:pPr>
             <a:r>
-              <a:rPr lang="en-US" sz="1500" b="1" dirty="0">
-                <a:solidFill>
-                  <a:srgbClr val="94A3B8"/>
-                </a:solidFill>
-                <a:latin typeface="Calibri" pitchFamily="34" charset="0"/>
-                <a:ea typeface="Calibri" pitchFamily="34" charset="-122"/>
-                <a:cs typeface="Calibri" pitchFamily="34" charset="-120"/>
+              <a:rPr lang="en-US" sz="1200" b="1" dirty="0">
+                <a:solidFill>
+                  <a:srgbClr val="8B95A5"/>
+                </a:solidFill>
+                <a:latin typeface="Verdana" pitchFamily="34" charset="0"/>
+                <a:ea typeface="Verdana" pitchFamily="34" charset="-122"/>
+                <a:cs typeface="Verdana" pitchFamily="34" charset="-120"/>
               </a:rPr>
               <a:t>Strategist</a:t>
             </a:r>
-            <a:endParaRPr lang="en-US" sz="1500" dirty="0"/>
+            <a:endParaRPr lang="en-US" sz="1200" dirty="0"/>
           </a:p>
         </p:txBody>
       </p:sp>
@@ -3150,17 +3150,17 @@
               <a:buNone/>
             </a:pPr>
             <a:r>
-              <a:rPr lang="en-US" sz="1400" dirty="0">
-                <a:solidFill>
-                  <a:srgbClr val="94A3B8"/>
-                </a:solidFill>
-                <a:latin typeface="Calibri" pitchFamily="34" charset="0"/>
-                <a:ea typeface="Calibri" pitchFamily="34" charset="-122"/>
-                <a:cs typeface="Calibri" pitchFamily="34" charset="-120"/>
+              <a:rPr lang="en-US" sz="1100" dirty="0">
+                <a:solidFill>
+                  <a:srgbClr val="8B95A5"/>
+                </a:solidFill>
+                <a:latin typeface="Verdana" pitchFamily="34" charset="0"/>
+                <a:ea typeface="Verdana" pitchFamily="34" charset="-122"/>
+                <a:cs typeface="Verdana" pitchFamily="34" charset="-120"/>
               </a:rPr>
               <a:t>→</a:t>
             </a:r>
-            <a:endParaRPr lang="en-US" sz="1400" dirty="0"/>
+            <a:endParaRPr lang="en-US" sz="1100" dirty="0"/>
           </a:p>
         </p:txBody>
       </p:sp>
@@ -3181,13 +3181,13 @@
             </a:avLst>
           </a:prstGeom>
           <a:solidFill>
-            <a:srgbClr val="0F0F1A">
+            <a:srgbClr val="0A2540">
               <a:alpha val="50000"/>
             </a:srgbClr>
           </a:solidFill>
           <a:ln w="12700">
             <a:solidFill>
-              <a:srgbClr val="94A3B8"/>
+              <a:srgbClr val="8B95A5"/>
             </a:solidFill>
             <a:prstDash val="solid"/>
           </a:ln>
@@ -3218,17 +3218,17 @@
               <a:buNone/>
             </a:pPr>
             <a:r>
-              <a:rPr lang="en-US" sz="1500" b="1" dirty="0">
-                <a:solidFill>
-                  <a:srgbClr val="94A3B8"/>
-                </a:solidFill>
-                <a:latin typeface="Calibri" pitchFamily="34" charset="0"/>
-                <a:ea typeface="Calibri" pitchFamily="34" charset="-122"/>
-                <a:cs typeface="Calibri" pitchFamily="34" charset="-120"/>
+              <a:rPr lang="en-US" sz="1200" b="1" dirty="0">
+                <a:solidFill>
+                  <a:srgbClr val="8B95A5"/>
+                </a:solidFill>
+                <a:latin typeface="Verdana" pitchFamily="34" charset="0"/>
+                <a:ea typeface="Verdana" pitchFamily="34" charset="-122"/>
+                <a:cs typeface="Verdana" pitchFamily="34" charset="-120"/>
               </a:rPr>
               <a:t>Operator</a:t>
             </a:r>
-            <a:endParaRPr lang="en-US" sz="1500" dirty="0"/>
+            <a:endParaRPr lang="en-US" sz="1200" dirty="0"/>
           </a:p>
         </p:txBody>
       </p:sp>
@@ -3257,17 +3257,17 @@
               <a:buNone/>
             </a:pPr>
             <a:r>
-              <a:rPr lang="en-US" sz="1400" dirty="0">
-                <a:solidFill>
-                  <a:srgbClr val="94A3B8"/>
-                </a:solidFill>
-                <a:latin typeface="Calibri" pitchFamily="34" charset="0"/>
-                <a:ea typeface="Calibri" pitchFamily="34" charset="-122"/>
-                <a:cs typeface="Calibri" pitchFamily="34" charset="-120"/>
+              <a:rPr lang="en-US" sz="1100" dirty="0">
+                <a:solidFill>
+                  <a:srgbClr val="8B95A5"/>
+                </a:solidFill>
+                <a:latin typeface="Verdana" pitchFamily="34" charset="0"/>
+                <a:ea typeface="Verdana" pitchFamily="34" charset="-122"/>
+                <a:cs typeface="Verdana" pitchFamily="34" charset="-120"/>
               </a:rPr>
               <a:t>→</a:t>
             </a:r>
-            <a:endParaRPr lang="en-US" sz="1400" dirty="0"/>
+            <a:endParaRPr lang="en-US" sz="1100" dirty="0"/>
           </a:p>
         </p:txBody>
       </p:sp>
@@ -3288,13 +3288,13 @@
             </a:avLst>
           </a:prstGeom>
           <a:solidFill>
-            <a:srgbClr val="0F0F1A">
+            <a:srgbClr val="0A2540">
               <a:alpha val="50000"/>
             </a:srgbClr>
           </a:solidFill>
           <a:ln w="25400">
             <a:solidFill>
-              <a:srgbClr val="00B4D8"/>
+              <a:srgbClr val="635BFF"/>
             </a:solidFill>
             <a:prstDash val="solid"/>
           </a:ln>
@@ -3325,17 +3325,17 @@
               <a:buNone/>
             </a:pPr>
             <a:r>
-              <a:rPr lang="en-US" sz="1500" b="1" dirty="0">
-                <a:solidFill>
-                  <a:srgbClr val="00B4D8"/>
-                </a:solidFill>
-                <a:latin typeface="Calibri" pitchFamily="34" charset="0"/>
-                <a:ea typeface="Calibri" pitchFamily="34" charset="-122"/>
-                <a:cs typeface="Calibri" pitchFamily="34" charset="-120"/>
+              <a:rPr lang="en-US" sz="1200" b="1" dirty="0">
+                <a:solidFill>
+                  <a:srgbClr val="635BFF"/>
+                </a:solidFill>
+                <a:latin typeface="Verdana" pitchFamily="34" charset="0"/>
+                <a:ea typeface="Verdana" pitchFamily="34" charset="-122"/>
+                <a:cs typeface="Verdana" pitchFamily="34" charset="-120"/>
               </a:rPr>
               <a:t>Orchestrator</a:t>
             </a:r>
-            <a:endParaRPr lang="en-US" sz="1500" dirty="0"/>
+            <a:endParaRPr lang="en-US" sz="1200" dirty="0"/>
           </a:p>
         </p:txBody>
       </p:sp>
@@ -3364,17 +3364,17 @@
               <a:buNone/>
             </a:pPr>
             <a:r>
-              <a:rPr lang="en-US" sz="1400" dirty="0">
-                <a:solidFill>
-                  <a:srgbClr val="94A3B8"/>
-                </a:solidFill>
-                <a:latin typeface="Calibri" pitchFamily="34" charset="0"/>
-                <a:ea typeface="Calibri" pitchFamily="34" charset="-122"/>
-                <a:cs typeface="Calibri" pitchFamily="34" charset="-120"/>
+              <a:rPr lang="en-US" sz="1100" dirty="0">
+                <a:solidFill>
+                  <a:srgbClr val="8B95A5"/>
+                </a:solidFill>
+                <a:latin typeface="Verdana" pitchFamily="34" charset="0"/>
+                <a:ea typeface="Verdana" pitchFamily="34" charset="-122"/>
+                <a:cs typeface="Verdana" pitchFamily="34" charset="-120"/>
               </a:rPr>
               <a:t>→</a:t>
             </a:r>
-            <a:endParaRPr lang="en-US" sz="1400" dirty="0"/>
+            <a:endParaRPr lang="en-US" sz="1100" dirty="0"/>
           </a:p>
         </p:txBody>
       </p:sp>
@@ -3395,13 +3395,13 @@
             </a:avLst>
           </a:prstGeom>
           <a:solidFill>
-            <a:srgbClr val="0F0F1A">
+            <a:srgbClr val="0A2540">
               <a:alpha val="50000"/>
             </a:srgbClr>
           </a:solidFill>
           <a:ln w="12700">
             <a:solidFill>
-              <a:srgbClr val="94A3B8"/>
+              <a:srgbClr val="8B95A5"/>
             </a:solidFill>
             <a:prstDash val="dash"/>
           </a:ln>
@@ -3432,17 +3432,17 @@
               <a:buNone/>
             </a:pPr>
             <a:r>
-              <a:rPr lang="en-US" sz="1500" b="1" dirty="0">
-                <a:solidFill>
-                  <a:srgbClr val="94A3B8"/>
-                </a:solidFill>
-                <a:latin typeface="Calibri" pitchFamily="34" charset="0"/>
-                <a:ea typeface="Calibri" pitchFamily="34" charset="-122"/>
-                <a:cs typeface="Calibri" pitchFamily="34" charset="-120"/>
+              <a:rPr lang="en-US" sz="1200" b="1" dirty="0">
+                <a:solidFill>
+                  <a:srgbClr val="8B95A5"/>
+                </a:solidFill>
+                <a:latin typeface="Verdana" pitchFamily="34" charset="0"/>
+                <a:ea typeface="Verdana" pitchFamily="34" charset="-122"/>
+                <a:cs typeface="Verdana" pitchFamily="34" charset="-120"/>
               </a:rPr>
               <a:t>Builder</a:t>
             </a:r>
-            <a:endParaRPr lang="en-US" sz="1500" dirty="0"/>
+            <a:endParaRPr lang="en-US" sz="1200" dirty="0"/>
           </a:p>
         </p:txBody>
       </p:sp>
@@ -3473,7 +3473,7 @@
             <a:r>
               <a:rPr lang="en-US" sz="2800" b="1" dirty="0">
                 <a:solidFill>
-                  <a:srgbClr val="00B4D8"/>
+                  <a:srgbClr val="635BFF"/>
                 </a:solidFill>
                 <a:latin typeface="Georgia" pitchFamily="34" charset="0"/>
                 <a:ea typeface="Georgia" pitchFamily="34" charset="-122"/>
@@ -3512,7 +3512,7 @@
             <a:r>
               <a:rPr lang="en-US" sz="2800" b="1" dirty="0">
                 <a:solidFill>
-                  <a:srgbClr val="00B4D8"/>
+                  <a:srgbClr val="635BFF"/>
                 </a:solidFill>
                 <a:latin typeface="Georgia" pitchFamily="34" charset="0"/>
                 <a:ea typeface="Georgia" pitchFamily="34" charset="-122"/>
@@ -3538,7 +3538,7 @@
     <p:bg>
       <p:bgPr>
         <a:solidFill>
-          <a:srgbClr val="0F0F1A"/>
+          <a:srgbClr val="0A2540"/>
         </a:solidFill>
       </p:bgPr>
     </p:bg>
@@ -3571,7 +3571,7 @@
             <a:avLst/>
           </a:prstGeom>
           <a:solidFill>
-            <a:srgbClr val="00B4D8">
+            <a:srgbClr val="635BFF">
               <a:alpha val="4000"/>
             </a:srgbClr>
           </a:solidFill>
@@ -3661,11 +3661,11 @@
             <a:r>
               <a:rPr lang="en-US" sz="2800" dirty="0">
                 <a:solidFill>
-                  <a:srgbClr val="94A3B8"/>
-                </a:solidFill>
-                <a:latin typeface="Calibri" pitchFamily="34" charset="0"/>
-                <a:ea typeface="Calibri" pitchFamily="34" charset="-122"/>
-                <a:cs typeface="Calibri" pitchFamily="34" charset="-120"/>
+                  <a:srgbClr val="8B95A5"/>
+                </a:solidFill>
+                <a:latin typeface="Verdana" pitchFamily="34" charset="0"/>
+                <a:ea typeface="Verdana" pitchFamily="34" charset="-122"/>
+                <a:cs typeface="Verdana" pitchFamily="34" charset="-120"/>
               </a:rPr>
               <a:t>Bring your laptop.</a:t>
             </a:r>
@@ -3687,7 +3687,7 @@
     <p:bg>
       <p:bgPr>
         <a:solidFill>
-          <a:srgbClr val="0F0F1A"/>
+          <a:srgbClr val="0A2540"/>
         </a:solidFill>
       </p:bgPr>
     </p:bg>
@@ -3720,7 +3720,7 @@
             <a:avLst/>
           </a:prstGeom>
           <a:solidFill>
-            <a:srgbClr val="00B4D8">
+            <a:srgbClr val="635BFF">
               <a:alpha val="4000"/>
             </a:srgbClr>
           </a:solidFill>
@@ -3754,7 +3754,7 @@
             <a:r>
               <a:rPr lang="en-US" sz="3600" b="1" dirty="0">
                 <a:solidFill>
-                  <a:srgbClr val="00B4D8"/>
+                  <a:srgbClr val="635BFF"/>
                 </a:solidFill>
                 <a:latin typeface="Georgia" pitchFamily="34" charset="0"/>
                 <a:ea typeface="Georgia" pitchFamily="34" charset="-122"/>
@@ -3793,11 +3793,11 @@
             <a:r>
               <a:rPr lang="en-US" sz="1800" b="1" dirty="0">
                 <a:solidFill>
-                  <a:srgbClr val="94A3B8"/>
-                </a:solidFill>
-                <a:latin typeface="Calibri" pitchFamily="34" charset="0"/>
-                <a:ea typeface="Calibri" pitchFamily="34" charset="-122"/>
-                <a:cs typeface="Calibri" pitchFamily="34" charset="-120"/>
+                  <a:srgbClr val="8B95A5"/>
+                </a:solidFill>
+                <a:latin typeface="Verdana" pitchFamily="34" charset="0"/>
+                <a:ea typeface="Verdana" pitchFamily="34" charset="-122"/>
+                <a:cs typeface="Verdana" pitchFamily="34" charset="-120"/>
               </a:rPr>
               <a:t>Explorer → Whisperer</a:t>
             </a:r>
@@ -3871,7 +3871,7 @@
             <a:r>
               <a:rPr lang="en-US" sz="3600" b="1" dirty="0">
                 <a:solidFill>
-                  <a:srgbClr val="00B4D8"/>
+                  <a:srgbClr val="635BFF"/>
                 </a:solidFill>
                 <a:latin typeface="Georgia" pitchFamily="34" charset="0"/>
                 <a:ea typeface="Georgia" pitchFamily="34" charset="-122"/>
@@ -3910,11 +3910,11 @@
             <a:r>
               <a:rPr lang="en-US" sz="1800" b="1" dirty="0">
                 <a:solidFill>
-                  <a:srgbClr val="94A3B8"/>
-                </a:solidFill>
-                <a:latin typeface="Calibri" pitchFamily="34" charset="0"/>
-                <a:ea typeface="Calibri" pitchFamily="34" charset="-122"/>
-                <a:cs typeface="Calibri" pitchFamily="34" charset="-120"/>
+                  <a:srgbClr val="8B95A5"/>
+                </a:solidFill>
+                <a:latin typeface="Verdana" pitchFamily="34" charset="0"/>
+                <a:ea typeface="Verdana" pitchFamily="34" charset="-122"/>
+                <a:cs typeface="Verdana" pitchFamily="34" charset="-120"/>
               </a:rPr>
               <a:t>Whisperer → Strategist</a:t>
             </a:r>
@@ -3988,7 +3988,7 @@
             <a:r>
               <a:rPr lang="en-US" sz="3600" b="1" dirty="0">
                 <a:solidFill>
-                  <a:srgbClr val="00B4D8"/>
+                  <a:srgbClr val="635BFF"/>
                 </a:solidFill>
                 <a:latin typeface="Georgia" pitchFamily="34" charset="0"/>
                 <a:ea typeface="Georgia" pitchFamily="34" charset="-122"/>
@@ -4027,11 +4027,11 @@
             <a:r>
               <a:rPr lang="en-US" sz="1800" b="1" dirty="0">
                 <a:solidFill>
-                  <a:srgbClr val="94A3B8"/>
-                </a:solidFill>
-                <a:latin typeface="Calibri" pitchFamily="34" charset="0"/>
-                <a:ea typeface="Calibri" pitchFamily="34" charset="-122"/>
-                <a:cs typeface="Calibri" pitchFamily="34" charset="-120"/>
+                  <a:srgbClr val="8B95A5"/>
+                </a:solidFill>
+                <a:latin typeface="Verdana" pitchFamily="34" charset="0"/>
+                <a:ea typeface="Verdana" pitchFamily="34" charset="-122"/>
+                <a:cs typeface="Verdana" pitchFamily="34" charset="-120"/>
               </a:rPr>
               <a:t>Strategist → Operator</a:t>
             </a:r>
@@ -4105,7 +4105,7 @@
             <a:r>
               <a:rPr lang="en-US" sz="3600" b="1" dirty="0">
                 <a:solidFill>
-                  <a:srgbClr val="00B4D8"/>
+                  <a:srgbClr val="635BFF"/>
                 </a:solidFill>
                 <a:latin typeface="Georgia" pitchFamily="34" charset="0"/>
                 <a:ea typeface="Georgia" pitchFamily="34" charset="-122"/>
@@ -4144,11 +4144,11 @@
             <a:r>
               <a:rPr lang="en-US" sz="1800" b="1" dirty="0">
                 <a:solidFill>
-                  <a:srgbClr val="94A3B8"/>
-                </a:solidFill>
-                <a:latin typeface="Calibri" pitchFamily="34" charset="0"/>
-                <a:ea typeface="Calibri" pitchFamily="34" charset="-122"/>
-                <a:cs typeface="Calibri" pitchFamily="34" charset="-120"/>
+                  <a:srgbClr val="8B95A5"/>
+                </a:solidFill>
+                <a:latin typeface="Verdana" pitchFamily="34" charset="0"/>
+                <a:ea typeface="Verdana" pitchFamily="34" charset="-122"/>
+                <a:cs typeface="Verdana" pitchFamily="34" charset="-120"/>
               </a:rPr>
               <a:t>Operator → Orchestrator</a:t>
             </a:r>

</xml_diff>

<commit_message>
Update pitch deck from four workshops to two sessions
Aligns with the merged workshop structure: Explorer → Strategist
(Workshop 1) and Strategist → Orchestrator (Workshop 2). Updated
across all pipeline docs (narrative, outline, design) and generation
script.

Co-Authored-By: Claude Opus 4.6 <noreply@anthropic.com>
</commit_message>
<xml_diff>
--- a/decks/ai-academy-pitch/ai-academy-pitch.pptx
+++ b/decks/ai-academy-pitch/ai-academy-pitch.pptx
@@ -1774,7 +1774,7 @@
                 <a:ea typeface="Verdana" pitchFamily="34" charset="-122"/>
                 <a:cs typeface="Verdana" pitchFamily="34" charset="-120"/>
               </a:rPr>
-              <a:t>From Explorer to Orchestrator in four lunch hours</a:t>
+              <a:t>From Explorer to Orchestrator in two sessions</a:t>
             </a:r>
             <a:endParaRPr lang="en-US" sz="2200" dirty="0"/>
           </a:p>
@@ -1867,7 +1867,7 @@
                 <a:ea typeface="Georgia" pitchFamily="34" charset="-122"/>
                 <a:cs typeface="Georgia" pitchFamily="34" charset="-120"/>
               </a:rPr>
-              <a:t>First session: [date]</a:t>
+              <a:t>First workshop: [date]</a:t>
             </a:r>
             <a:endParaRPr lang="en-US" sz="4400" dirty="0"/>
           </a:p>
@@ -3611,7 +3611,7 @@
                 <a:ea typeface="Georgia" pitchFamily="34" charset="-122"/>
                 <a:cs typeface="Georgia" pitchFamily="34" charset="-120"/>
               </a:rPr>
-              <a:t>Four sessions.</a:t>
+              <a:t>Two sessions.</a:t>
             </a:r>
             <a:endParaRPr lang="en-US" sz="4400" dirty="0"/>
           </a:p>
@@ -3628,7 +3628,7 @@
                 <a:ea typeface="Georgia" pitchFamily="34" charset="-122"/>
                 <a:cs typeface="Georgia" pitchFamily="34" charset="-120"/>
               </a:rPr>
-              <a:t>One lunch hour each.</a:t>
+              <a:t>One hour each.</a:t>
             </a:r>
             <a:endParaRPr lang="en-US" sz="4400" dirty="0"/>
           </a:p>
@@ -3735,7 +3735,7 @@
         </p:nvSpPr>
         <p:spPr>
           <a:xfrm>
-            <a:off x="731520" y="731520"/>
+            <a:off x="731520" y="1280160"/>
             <a:ext cx="731520" cy="822960"/>
           </a:xfrm>
           <a:prstGeom prst="rect">
@@ -3774,7 +3774,7 @@
         </p:nvSpPr>
         <p:spPr>
           <a:xfrm>
-            <a:off x="1645920" y="731520"/>
+            <a:off x="1645920" y="1280160"/>
             <a:ext cx="3200400" cy="411480"/>
           </a:xfrm>
           <a:prstGeom prst="rect">
@@ -3799,7 +3799,7 @@
                 <a:ea typeface="Verdana" pitchFamily="34" charset="-122"/>
                 <a:cs typeface="Verdana" pitchFamily="34" charset="-120"/>
               </a:rPr>
-              <a:t>Explorer → Whisperer</a:t>
+              <a:t>Explorer → Strategist</a:t>
             </a:r>
             <a:endParaRPr lang="en-US" sz="1800" dirty="0"/>
           </a:p>
@@ -3813,7 +3813,7 @@
         </p:nvSpPr>
         <p:spPr>
           <a:xfrm>
-            <a:off x="1645920" y="1143000"/>
+            <a:off x="1645920" y="1691640"/>
             <a:ext cx="5486400" cy="411480"/>
           </a:xfrm>
           <a:prstGeom prst="rect">
@@ -3838,7 +3838,7 @@
                 <a:ea typeface="Georgia" pitchFamily="34" charset="-122"/>
                 <a:cs typeface="Georgia" pitchFamily="34" charset="-120"/>
               </a:rPr>
-              <a:t>Learn to talk to AI properly</a:t>
+              <a:t>From vague prompts to a persistent AI playbook</a:t>
             </a:r>
             <a:endParaRPr lang="en-US" sz="2400" dirty="0"/>
           </a:p>
@@ -3852,7 +3852,7 @@
         </p:nvSpPr>
         <p:spPr>
           <a:xfrm>
-            <a:off x="731520" y="1737360"/>
+            <a:off x="731520" y="2651760"/>
             <a:ext cx="731520" cy="822960"/>
           </a:xfrm>
           <a:prstGeom prst="rect">
@@ -3891,7 +3891,7 @@
         </p:nvSpPr>
         <p:spPr>
           <a:xfrm>
-            <a:off x="1645920" y="1737360"/>
+            <a:off x="1645920" y="2651760"/>
             <a:ext cx="3200400" cy="411480"/>
           </a:xfrm>
           <a:prstGeom prst="rect">
@@ -3916,7 +3916,7 @@
                 <a:ea typeface="Verdana" pitchFamily="34" charset="-122"/>
                 <a:cs typeface="Verdana" pitchFamily="34" charset="-120"/>
               </a:rPr>
-              <a:t>Whisperer → Strategist</a:t>
+              <a:t>Strategist → Orchestrator</a:t>
             </a:r>
             <a:endParaRPr lang="en-US" sz="1800" dirty="0"/>
           </a:p>
@@ -3930,7 +3930,7 @@
         </p:nvSpPr>
         <p:spPr>
           <a:xfrm>
-            <a:off x="1645920" y="2148840"/>
+            <a:off x="1645920" y="3063240"/>
             <a:ext cx="5486400" cy="411480"/>
           </a:xfrm>
           <a:prstGeom prst="rect">
@@ -3955,241 +3955,7 @@
                 <a:ea typeface="Georgia" pitchFamily="34" charset="-122"/>
                 <a:cs typeface="Georgia" pitchFamily="34" charset="-120"/>
               </a:rPr>
-              <a:t>Make AI remember what you need</a:t>
-            </a:r>
-            <a:endParaRPr lang="en-US" sz="2400" dirty="0"/>
-          </a:p>
-        </p:txBody>
-      </p:sp>
-      <p:sp>
-        <p:nvSpPr>
-          <p:cNvPr id="9" name="Text 7"/>
-          <p:cNvSpPr/>
-          <p:nvPr/>
-        </p:nvSpPr>
-        <p:spPr>
-          <a:xfrm>
-            <a:off x="731520" y="2743200"/>
-            <a:ext cx="731520" cy="822960"/>
-          </a:xfrm>
-          <a:prstGeom prst="rect">
-            <a:avLst/>
-          </a:prstGeom>
-          <a:noFill/>
-          <a:ln/>
-        </p:spPr>
-        <p:txBody>
-          <a:bodyPr wrap="square" lIns="0" tIns="0" rIns="0" bIns="0" rtlCol="0" anchor="ctr"/>
-          <a:lstStyle/>
-          <a:p>
-            <a:pPr algn="ctr" indent="0" marL="0">
-              <a:buNone/>
-            </a:pPr>
-            <a:r>
-              <a:rPr lang="en-US" sz="3600" b="1" dirty="0">
-                <a:solidFill>
-                  <a:srgbClr val="635BFF"/>
-                </a:solidFill>
-                <a:latin typeface="Georgia" pitchFamily="34" charset="0"/>
-                <a:ea typeface="Georgia" pitchFamily="34" charset="-122"/>
-                <a:cs typeface="Georgia" pitchFamily="34" charset="-120"/>
-              </a:rPr>
-              <a:t>3</a:t>
-            </a:r>
-            <a:endParaRPr lang="en-US" sz="3600" dirty="0"/>
-          </a:p>
-        </p:txBody>
-      </p:sp>
-      <p:sp>
-        <p:nvSpPr>
-          <p:cNvPr id="10" name="Text 8"/>
-          <p:cNvSpPr/>
-          <p:nvPr/>
-        </p:nvSpPr>
-        <p:spPr>
-          <a:xfrm>
-            <a:off x="1645920" y="2743200"/>
-            <a:ext cx="3200400" cy="411480"/>
-          </a:xfrm>
-          <a:prstGeom prst="rect">
-            <a:avLst/>
-          </a:prstGeom>
-          <a:noFill/>
-          <a:ln/>
-        </p:spPr>
-        <p:txBody>
-          <a:bodyPr wrap="square" lIns="0" tIns="0" rIns="0" bIns="0" rtlCol="0" anchor="b"/>
-          <a:lstStyle/>
-          <a:p>
-            <a:pPr indent="0" marL="0">
-              <a:buNone/>
-            </a:pPr>
-            <a:r>
-              <a:rPr lang="en-US" sz="1800" b="1" dirty="0">
-                <a:solidFill>
-                  <a:srgbClr val="8B95A5"/>
-                </a:solidFill>
-                <a:latin typeface="Verdana" pitchFamily="34" charset="0"/>
-                <a:ea typeface="Verdana" pitchFamily="34" charset="-122"/>
-                <a:cs typeface="Verdana" pitchFamily="34" charset="-120"/>
-              </a:rPr>
-              <a:t>Strategist → Operator</a:t>
-            </a:r>
-            <a:endParaRPr lang="en-US" sz="1800" dirty="0"/>
-          </a:p>
-        </p:txBody>
-      </p:sp>
-      <p:sp>
-        <p:nvSpPr>
-          <p:cNvPr id="11" name="Text 9"/>
-          <p:cNvSpPr/>
-          <p:nvPr/>
-        </p:nvSpPr>
-        <p:spPr>
-          <a:xfrm>
-            <a:off x="1645920" y="3154680"/>
-            <a:ext cx="5486400" cy="411480"/>
-          </a:xfrm>
-          <a:prstGeom prst="rect">
-            <a:avLst/>
-          </a:prstGeom>
-          <a:noFill/>
-          <a:ln/>
-        </p:spPr>
-        <p:txBody>
-          <a:bodyPr wrap="square" lIns="0" tIns="0" rIns="0" bIns="0" rtlCol="0" anchor="t"/>
-          <a:lstStyle/>
-          <a:p>
-            <a:pPr indent="0" marL="0">
-              <a:buNone/>
-            </a:pPr>
-            <a:r>
-              <a:rPr lang="en-US" sz="2400" b="1" dirty="0">
-                <a:solidFill>
-                  <a:srgbClr val="FFFFFF"/>
-                </a:solidFill>
-                <a:latin typeface="Georgia" pitchFamily="34" charset="0"/>
-                <a:ea typeface="Georgia" pitchFamily="34" charset="-122"/>
-                <a:cs typeface="Georgia" pitchFamily="34" charset="-120"/>
-              </a:rPr>
-              <a:t>Let AI work for you</a:t>
-            </a:r>
-            <a:endParaRPr lang="en-US" sz="2400" dirty="0"/>
-          </a:p>
-        </p:txBody>
-      </p:sp>
-      <p:sp>
-        <p:nvSpPr>
-          <p:cNvPr id="12" name="Text 10"/>
-          <p:cNvSpPr/>
-          <p:nvPr/>
-        </p:nvSpPr>
-        <p:spPr>
-          <a:xfrm>
-            <a:off x="731520" y="3749040"/>
-            <a:ext cx="731520" cy="822960"/>
-          </a:xfrm>
-          <a:prstGeom prst="rect">
-            <a:avLst/>
-          </a:prstGeom>
-          <a:noFill/>
-          <a:ln/>
-        </p:spPr>
-        <p:txBody>
-          <a:bodyPr wrap="square" lIns="0" tIns="0" rIns="0" bIns="0" rtlCol="0" anchor="ctr"/>
-          <a:lstStyle/>
-          <a:p>
-            <a:pPr algn="ctr" indent="0" marL="0">
-              <a:buNone/>
-            </a:pPr>
-            <a:r>
-              <a:rPr lang="en-US" sz="3600" b="1" dirty="0">
-                <a:solidFill>
-                  <a:srgbClr val="635BFF"/>
-                </a:solidFill>
-                <a:latin typeface="Georgia" pitchFamily="34" charset="0"/>
-                <a:ea typeface="Georgia" pitchFamily="34" charset="-122"/>
-                <a:cs typeface="Georgia" pitchFamily="34" charset="-120"/>
-              </a:rPr>
-              <a:t>4</a:t>
-            </a:r>
-            <a:endParaRPr lang="en-US" sz="3600" dirty="0"/>
-          </a:p>
-        </p:txBody>
-      </p:sp>
-      <p:sp>
-        <p:nvSpPr>
-          <p:cNvPr id="13" name="Text 11"/>
-          <p:cNvSpPr/>
-          <p:nvPr/>
-        </p:nvSpPr>
-        <p:spPr>
-          <a:xfrm>
-            <a:off x="1645920" y="3749040"/>
-            <a:ext cx="3200400" cy="411480"/>
-          </a:xfrm>
-          <a:prstGeom prst="rect">
-            <a:avLst/>
-          </a:prstGeom>
-          <a:noFill/>
-          <a:ln/>
-        </p:spPr>
-        <p:txBody>
-          <a:bodyPr wrap="square" lIns="0" tIns="0" rIns="0" bIns="0" rtlCol="0" anchor="b"/>
-          <a:lstStyle/>
-          <a:p>
-            <a:pPr indent="0" marL="0">
-              <a:buNone/>
-            </a:pPr>
-            <a:r>
-              <a:rPr lang="en-US" sz="1800" b="1" dirty="0">
-                <a:solidFill>
-                  <a:srgbClr val="8B95A5"/>
-                </a:solidFill>
-                <a:latin typeface="Verdana" pitchFamily="34" charset="0"/>
-                <a:ea typeface="Verdana" pitchFamily="34" charset="-122"/>
-                <a:cs typeface="Verdana" pitchFamily="34" charset="-120"/>
-              </a:rPr>
-              <a:t>Operator → Orchestrator</a:t>
-            </a:r>
-            <a:endParaRPr lang="en-US" sz="1800" dirty="0"/>
-          </a:p>
-        </p:txBody>
-      </p:sp>
-      <p:sp>
-        <p:nvSpPr>
-          <p:cNvPr id="14" name="Text 12"/>
-          <p:cNvSpPr/>
-          <p:nvPr/>
-        </p:nvSpPr>
-        <p:spPr>
-          <a:xfrm>
-            <a:off x="1645920" y="4160520"/>
-            <a:ext cx="5486400" cy="411480"/>
-          </a:xfrm>
-          <a:prstGeom prst="rect">
-            <a:avLst/>
-          </a:prstGeom>
-          <a:noFill/>
-          <a:ln/>
-        </p:spPr>
-        <p:txBody>
-          <a:bodyPr wrap="square" lIns="0" tIns="0" rIns="0" bIns="0" rtlCol="0" anchor="t"/>
-          <a:lstStyle/>
-          <a:p>
-            <a:pPr indent="0" marL="0">
-              <a:buNone/>
-            </a:pPr>
-            <a:r>
-              <a:rPr lang="en-US" sz="2400" b="1" dirty="0">
-                <a:solidFill>
-                  <a:srgbClr val="FFFFFF"/>
-                </a:solidFill>
-                <a:latin typeface="Georgia" pitchFamily="34" charset="0"/>
-                <a:ea typeface="Georgia" pitchFamily="34" charset="-122"/>
-                <a:cs typeface="Georgia" pitchFamily="34" charset="-120"/>
-              </a:rPr>
-              <a:t>Coordinate AI teams</a:t>
+              <a:t>From doing the work to directing AI teams</a:t>
             </a:r>
             <a:endParaRPr lang="en-US" sz="2400" dirty="0"/>
           </a:p>

</xml_diff>

<commit_message>
Polish pitch deck: drop date placeholder, fix line wrapping
Remove [date] placeholder from CTA slide — makes it ready to present
as-is. Fix line breaks on slides 2 and 6 to avoid awkward word wrapping
at 28pt and 38pt respectively.

Co-Authored-By: Claude Opus 4.6 <noreply@anthropic.com>
</commit_message>
<xml_diff>
--- a/decks/ai-academy-pitch/ai-academy-pitch.pptx
+++ b/decks/ai-academy-pitch/ai-academy-pitch.pptx
@@ -1867,48 +1867,26 @@
                 <a:ea typeface="Georgia" pitchFamily="34" charset="-122"/>
                 <a:cs typeface="Georgia" pitchFamily="34" charset="-120"/>
               </a:rPr>
-              <a:t>First workshop: [date]</a:t>
+              <a:t>Bring your laptop</a:t>
             </a:r>
             <a:endParaRPr lang="en-US" sz="4400" dirty="0"/>
           </a:p>
-        </p:txBody>
-      </p:sp>
-      <p:sp>
-        <p:nvSpPr>
-          <p:cNvPr id="4" name="Text 2"/>
-          <p:cNvSpPr/>
-          <p:nvPr/>
-        </p:nvSpPr>
-        <p:spPr>
-          <a:xfrm>
-            <a:off x="1371600" y="3657600"/>
-            <a:ext cx="6400800" cy="731520"/>
-          </a:xfrm>
-          <a:prstGeom prst="rect">
-            <a:avLst/>
-          </a:prstGeom>
-          <a:noFill/>
-          <a:ln/>
-        </p:spPr>
-        <p:txBody>
-          <a:bodyPr wrap="square" lIns="0" tIns="0" rIns="0" bIns="0" rtlCol="0" anchor="t"/>
-          <a:lstStyle/>
           <a:p>
             <a:pPr algn="ctr" indent="0" marL="0">
               <a:buNone/>
             </a:pPr>
             <a:r>
-              <a:rPr lang="en-US" sz="2800" dirty="0">
-                <a:solidFill>
-                  <a:srgbClr val="8B95A5"/>
-                </a:solidFill>
-                <a:latin typeface="Verdana" pitchFamily="34" charset="0"/>
-                <a:ea typeface="Verdana" pitchFamily="34" charset="-122"/>
-                <a:cs typeface="Verdana" pitchFamily="34" charset="-120"/>
-              </a:rPr>
-              <a:t>Bring your laptop and a task you do every week.</a:t>
-            </a:r>
-            <a:endParaRPr lang="en-US" sz="2800" dirty="0"/>
+              <a:rPr lang="en-US" sz="4400" b="1" dirty="0">
+                <a:solidFill>
+                  <a:srgbClr val="FFFFFF"/>
+                </a:solidFill>
+                <a:latin typeface="Georgia" pitchFamily="34" charset="0"/>
+                <a:ea typeface="Georgia" pitchFamily="34" charset="-122"/>
+                <a:cs typeface="Georgia" pitchFamily="34" charset="-120"/>
+              </a:rPr>
+              <a:t>and a task you do every week.</a:t>
+            </a:r>
+            <a:endParaRPr lang="en-US" sz="4400" dirty="0"/>
           </a:p>
         </p:txBody>
       </p:sp>
@@ -1999,7 +1977,7 @@
                 <a:ea typeface="Verdana" pitchFamily="34" charset="-122"/>
                 <a:cs typeface="Verdana" pitchFamily="34" charset="-120"/>
               </a:rPr>
-              <a:t>Last month, someone spent 45 minutes</a:t>
+              <a:t>Last month, someone spent</a:t>
             </a:r>
             <a:endParaRPr lang="en-US" sz="2800" dirty="0"/>
           </a:p>
@@ -2016,7 +1994,7 @@
                 <a:ea typeface="Verdana" pitchFamily="34" charset="-122"/>
                 <a:cs typeface="Verdana" pitchFamily="34" charset="-120"/>
               </a:rPr>
-              <a:t>on a one-page summary using ChatGPT.</a:t>
+              <a:t>45 minutes on a one-page summary.</a:t>
             </a:r>
             <a:endParaRPr lang="en-US" sz="2800" dirty="0"/>
           </a:p>
@@ -2636,7 +2614,7 @@
               <a:buNone/>
             </a:pPr>
             <a:r>
-              <a:rPr lang="en-US" sz="4400" b="1" dirty="0">
+              <a:rPr lang="en-US" sz="3800" b="1" dirty="0">
                 <a:solidFill>
                   <a:srgbClr val="FFFFFF"/>
                 </a:solidFill>
@@ -2644,16 +2622,16 @@
                 <a:ea typeface="Georgia" pitchFamily="34" charset="-122"/>
                 <a:cs typeface="Georgia" pitchFamily="34" charset="-120"/>
               </a:rPr>
-              <a:t>The gap between using AI</a:t>
-            </a:r>
-            <a:endParaRPr lang="en-US" sz="4400" dirty="0"/>
+              <a:t>The gap between</a:t>
+            </a:r>
+            <a:endParaRPr lang="en-US" sz="3800" dirty="0"/>
           </a:p>
           <a:p>
             <a:pPr algn="ctr" indent="0" marL="0">
               <a:buNone/>
             </a:pPr>
             <a:r>
-              <a:rPr lang="en-US" sz="4400" b="1" dirty="0">
+              <a:rPr lang="en-US" sz="3800" b="1" dirty="0">
                 <a:solidFill>
                   <a:srgbClr val="FFFFFF"/>
                 </a:solidFill>
@@ -2661,16 +2639,16 @@
                 <a:ea typeface="Georgia" pitchFamily="34" charset="-122"/>
                 <a:cs typeface="Georgia" pitchFamily="34" charset="-120"/>
               </a:rPr>
-              <a:t>and using AI well</a:t>
-            </a:r>
-            <a:endParaRPr lang="en-US" sz="4400" dirty="0"/>
+              <a:t>using AI and using AI well</a:t>
+            </a:r>
+            <a:endParaRPr lang="en-US" sz="3800" dirty="0"/>
           </a:p>
           <a:p>
             <a:pPr algn="ctr" indent="0" marL="0">
               <a:buNone/>
             </a:pPr>
             <a:r>
-              <a:rPr lang="en-US" sz="4400" b="1" dirty="0">
+              <a:rPr lang="en-US" sz="3800" b="1" dirty="0">
                 <a:solidFill>
                   <a:srgbClr val="FFFFFF"/>
                 </a:solidFill>
@@ -2680,7 +2658,7 @@
               </a:rPr>
               <a:t>is massive.</a:t>
             </a:r>
-            <a:endParaRPr lang="en-US" sz="4400" dirty="0"/>
+            <a:endParaRPr lang="en-US" sz="3800" dirty="0"/>
           </a:p>
         </p:txBody>
       </p:sp>

</xml_diff>

<commit_message>
Replace opening hook with Karpathy "slop" → "skill issue" contrast
The old "45 minutes to 2 minutes" anecdote was vague, anonymous, and
low-stakes. Replace with Andrej Karpathy's real, sourced two-month arc:
dismissed AI tools as "slop" in October 2025, then posted "this is a
skill issue" in December 2025. Updates both main deck and pitch deck
across all pipeline stages (narrative, content outline, slide design,
generation script, .pptx, .pdf).

Co-Authored-By: Claude Opus 4.6 <noreply@anthropic.com>
</commit_message>
<xml_diff>
--- a/decks/ai-academy-pitch/ai-academy-pitch.pptx
+++ b/decks/ai-academy-pitch/ai-academy-pitch.pptx
@@ -15,9 +15,10 @@
     <p:sldId id="263" r:id="rId9"/>
     <p:sldId id="264" r:id="rId10"/>
     <p:sldId id="265" r:id="rId11"/>
+    <p:sldId id="266" r:id="rId12"/>
   </p:sldIdLst>
   <p:notesMasterIdLst>
-    <p:notesMasterId r:id="rId12"/>
+    <p:notesMasterId r:id="rId13"/>
   </p:notesMasterIdLst>
   <p:sldSz cx="9144000" cy="5143500"/>
   <p:notesSz cx="5143500" cy="9144000"/>
@@ -599,7 +600,7 @@
           <a:p>
             <a:r>
               <a:rPr lang="en-US" dirty="0"/>
-              <a:t>Specific, low-commitment ask. Emphasis: existing weekly task, not new skill. Live transformation in session. ~15 seconds.</a:t>
+              <a:t>Brief walkthrough of each session. One-liners = curiosity hooks. ~30 seconds.</a:t>
             </a:r>
             <a:endParaRPr lang="en-US" dirty="0"/>
           </a:p>
@@ -623,6 +624,94 @@
             <a:fld id="{F7021451-1387-4CA6-816F-3879F97B5CBC}" type="slidenum">
               <a:rPr lang="en-US"/>
               <a:t>10</a:t>
+            </a:fld>
+            <a:endParaRPr lang="en-US"/>
+          </a:p>
+        </p:txBody>
+      </p:sp>
+    </p:spTree>
+    <p:extLst>
+      <p:ext uri="{BB962C8B-B14F-4D97-AF65-F5344CB8AC3E}">
+        <p14:creationId xmlns:p14="http://schemas.microsoft.com/office/powerpoint/2010/main" val="1024086991"/>
+      </p:ext>
+    </p:extLst>
+  </p:cSld>
+  <p:clrMapOvr>
+    <a:masterClrMapping/>
+  </p:clrMapOvr>
+</p:notes>
+</file>
+
+<file path=ppt/notesSlides/notesSlide11.xml><?xml version="1.0" encoding="utf-8"?>
+<p:notes xmlns:a="http://schemas.openxmlformats.org/drawingml/2006/main" xmlns:r="http://schemas.openxmlformats.org/officeDocument/2006/relationships" xmlns:p="http://schemas.openxmlformats.org/presentationml/2006/main">
+  <p:cSld>
+    <p:spTree>
+      <p:nvGrpSpPr>
+        <p:cNvPr id="1" name=""/>
+        <p:cNvGrpSpPr/>
+        <p:nvPr/>
+      </p:nvGrpSpPr>
+      <p:grpSpPr>
+        <a:xfrm>
+          <a:off x="0" y="0"/>
+          <a:ext cx="0" cy="0"/>
+          <a:chOff x="0" y="0"/>
+          <a:chExt cx="0" cy="0"/>
+        </a:xfrm>
+      </p:grpSpPr>
+      <p:sp>
+        <p:nvSpPr>
+          <p:cNvPr id="2" name="Slide Image Placeholder 1"/>
+          <p:cNvSpPr>
+            <a:spLocks noGrp="1" noRot="1" noChangeAspect="1"/>
+          </p:cNvSpPr>
+          <p:nvPr>
+            <p:ph type="sldImg"/>
+          </p:nvPr>
+        </p:nvSpPr>
+        <p:spPr/>
+      </p:sp>
+      <p:sp>
+        <p:nvSpPr>
+          <p:cNvPr id="3" name="Notes Placeholder 2"/>
+          <p:cNvSpPr>
+            <a:spLocks noGrp="1"/>
+          </p:cNvSpPr>
+          <p:nvPr>
+            <p:ph type="body" idx="1"/>
+          </p:nvPr>
+        </p:nvSpPr>
+        <p:spPr/>
+        <p:txBody>
+          <a:bodyPr/>
+          <a:lstStyle/>
+          <a:p>
+            <a:r>
+              <a:rPr lang="en-US" dirty="0"/>
+              <a:t>Specific, low-commitment ask. Emphasis: existing weekly task, not new skill. Live transformation in session. ~15 seconds.</a:t>
+            </a:r>
+            <a:endParaRPr lang="en-US" dirty="0"/>
+          </a:p>
+        </p:txBody>
+      </p:sp>
+      <p:sp>
+        <p:nvSpPr>
+          <p:cNvPr id="4" name="Slide Number Placeholder 3"/>
+          <p:cNvSpPr>
+            <a:spLocks noGrp="1"/>
+          </p:cNvSpPr>
+          <p:nvPr>
+            <p:ph type="sldNum" sz="quarter" idx="10"/>
+          </p:nvPr>
+        </p:nvSpPr>
+        <p:spPr/>
+        <p:txBody>
+          <a:bodyPr/>
+          <a:lstStyle/>
+          <a:p>
+            <a:fld id="{F7021451-1387-4CA6-816F-3879F97B5CBC}" type="slidenum">
+              <a:rPr lang="en-US"/>
+              <a:t>11</a:t>
             </a:fld>
             <a:endParaRPr lang="en-US"/>
           </a:p>
@@ -687,7 +776,7 @@
           <a:p>
             <a:r>
               <a:rPr lang="en-US" dirty="0"/>
-              <a:t>Same hook as the main deck — proven and relatable. Let it land. ~15 seconds.</a:t>
+              <a:t>Let the quote sit. 'The co-founder of the company that made ChatGPT called AI tools slop. That was October 2025.' ~10 seconds. Source: Dwarkesh Podcast, https://www.dwarkesh.com/p/andrej-karpathy</a:t>
             </a:r>
             <a:endParaRPr lang="en-US" dirty="0"/>
           </a:p>
@@ -775,7 +864,7 @@
           <a:p>
             <a:r>
               <a:rPr lang="en-US" dirty="0"/>
-              <a:t>Shift from individual anecdote to organizational opportunity. Pause. ~10 seconds.</a:t>
+              <a:t>Two months later — same person — 'This is a skill issue.' If the co-founder of OpenAI has a skill gap, what about our team? ~15 seconds. Source: https://x.com/karpathy/status/2004607146781278521</a:t>
             </a:r>
             <a:endParaRPr lang="en-US" dirty="0"/>
           </a:p>
@@ -863,10 +952,7 @@
           <a:p>
             <a:r>
               <a:rPr lang="en-US" dirty="0"/>
-              <a:t>Sources: DataReportal 2026, Reuters.
-• https://datareportal.com/reports/digital-2026-one-billion-people-using-ai
-• https://www.reuters.com/commentary/breakingviews/ai-investment-bubble-inflated-by-trio-dilemmas-2025-09-25/
-Mass adoption but shallow depth. The opportunity gap is enormous. ~15 seconds.</a:t>
+              <a:t>Shift from the Karpathy skill gap to organizational opportunity. Pause. ~10 seconds.</a:t>
             </a:r>
             <a:endParaRPr lang="en-US" dirty="0"/>
           </a:p>
@@ -954,8 +1040,10 @@
           <a:p>
             <a:r>
               <a:rPr lang="en-US" dirty="0"/>
-              <a:t>Source: Addy Osmani — https://addyo.substack.com/p/the-reality-of-ai-assisted-software
-Key contrast: perceived 20% faster vs actual 19% slower after debugging. Gap = active harm, not just missed potential. ~15 seconds.</a:t>
+              <a:t>Sources: DataReportal 2026, Reuters.
+• https://datareportal.com/reports/digital-2026-one-billion-people-using-ai
+• https://www.reuters.com/commentary/breakingviews/ai-investment-bubble-inflated-by-trio-dilemmas-2025-09-25/
+Mass adoption but shallow depth. The opportunity gap is enormous. ~15 seconds.</a:t>
             </a:r>
             <a:endParaRPr lang="en-US" dirty="0"/>
           </a:p>
@@ -1043,7 +1131,8 @@
           <a:p>
             <a:r>
               <a:rPr lang="en-US" dirty="0"/>
-              <a:t>Let it land. Goal: self-identification. ~10 seconds.</a:t>
+              <a:t>Source: Addy Osmani — https://addyo.substack.com/p/the-reality-of-ai-assisted-software
+Key contrast: perceived 20% faster vs actual 19% slower after debugging. Gap = active harm, not just missed potential. ~15 seconds.</a:t>
             </a:r>
             <a:endParaRPr lang="en-US" dirty="0"/>
           </a:p>
@@ -1131,7 +1220,7 @@
           <a:p>
             <a:r>
               <a:rPr lang="en-US" dirty="0"/>
-              <a:t>Self-identification moment. Pause for audience to locate themselves on spectrum. ~20 seconds.</a:t>
+              <a:t>Let it land. Goal: self-identification. ~10 seconds.</a:t>
             </a:r>
             <a:endParaRPr lang="en-US" dirty="0"/>
           </a:p>
@@ -1219,7 +1308,7 @@
           <a:p>
             <a:r>
               <a:rPr lang="en-US" dirty="0"/>
-              <a:t>The sell starts here. Practical, time-bound, low-commitment. ~15 seconds.</a:t>
+              <a:t>Self-identification moment. Pause for audience to locate themselves on spectrum. ~20 seconds.</a:t>
             </a:r>
             <a:endParaRPr lang="en-US" dirty="0"/>
           </a:p>
@@ -1307,7 +1396,7 @@
           <a:p>
             <a:r>
               <a:rPr lang="en-US" dirty="0"/>
-              <a:t>Brief walkthrough of each session. One-liners = curiosity hooks. ~30 seconds.</a:t>
+              <a:t>The sell starts here. Practical, time-bound, low-commitment. ~15 seconds.</a:t>
             </a:r>
             <a:endParaRPr lang="en-US" dirty="0"/>
           </a:p>
@@ -1842,6 +1931,294 @@
         </p:nvSpPr>
         <p:spPr>
           <a:xfrm>
+            <a:off x="731520" y="1280160"/>
+            <a:ext cx="731520" cy="822960"/>
+          </a:xfrm>
+          <a:prstGeom prst="rect">
+            <a:avLst/>
+          </a:prstGeom>
+          <a:noFill/>
+          <a:ln/>
+        </p:spPr>
+        <p:txBody>
+          <a:bodyPr wrap="square" lIns="0" tIns="0" rIns="0" bIns="0" rtlCol="0" anchor="ctr"/>
+          <a:lstStyle/>
+          <a:p>
+            <a:pPr algn="ctr" indent="0" marL="0">
+              <a:buNone/>
+            </a:pPr>
+            <a:r>
+              <a:rPr lang="en-US" sz="3600" b="1" dirty="0">
+                <a:solidFill>
+                  <a:srgbClr val="635BFF"/>
+                </a:solidFill>
+                <a:latin typeface="Georgia" pitchFamily="34" charset="0"/>
+                <a:ea typeface="Georgia" pitchFamily="34" charset="-122"/>
+                <a:cs typeface="Georgia" pitchFamily="34" charset="-120"/>
+              </a:rPr>
+              <a:t>1</a:t>
+            </a:r>
+            <a:endParaRPr lang="en-US" sz="3600" dirty="0"/>
+          </a:p>
+        </p:txBody>
+      </p:sp>
+      <p:sp>
+        <p:nvSpPr>
+          <p:cNvPr id="4" name="Text 2"/>
+          <p:cNvSpPr/>
+          <p:nvPr/>
+        </p:nvSpPr>
+        <p:spPr>
+          <a:xfrm>
+            <a:off x="1645920" y="1280160"/>
+            <a:ext cx="3200400" cy="411480"/>
+          </a:xfrm>
+          <a:prstGeom prst="rect">
+            <a:avLst/>
+          </a:prstGeom>
+          <a:noFill/>
+          <a:ln/>
+        </p:spPr>
+        <p:txBody>
+          <a:bodyPr wrap="square" lIns="0" tIns="0" rIns="0" bIns="0" rtlCol="0" anchor="b"/>
+          <a:lstStyle/>
+          <a:p>
+            <a:pPr indent="0" marL="0">
+              <a:buNone/>
+            </a:pPr>
+            <a:r>
+              <a:rPr lang="en-US" sz="1800" b="1" dirty="0">
+                <a:solidFill>
+                  <a:srgbClr val="8B95A5"/>
+                </a:solidFill>
+                <a:latin typeface="Verdana" pitchFamily="34" charset="0"/>
+                <a:ea typeface="Verdana" pitchFamily="34" charset="-122"/>
+                <a:cs typeface="Verdana" pitchFamily="34" charset="-120"/>
+              </a:rPr>
+              <a:t>Explorer → Strategist</a:t>
+            </a:r>
+            <a:endParaRPr lang="en-US" sz="1800" dirty="0"/>
+          </a:p>
+        </p:txBody>
+      </p:sp>
+      <p:sp>
+        <p:nvSpPr>
+          <p:cNvPr id="5" name="Text 3"/>
+          <p:cNvSpPr/>
+          <p:nvPr/>
+        </p:nvSpPr>
+        <p:spPr>
+          <a:xfrm>
+            <a:off x="1645920" y="1691640"/>
+            <a:ext cx="5486400" cy="411480"/>
+          </a:xfrm>
+          <a:prstGeom prst="rect">
+            <a:avLst/>
+          </a:prstGeom>
+          <a:noFill/>
+          <a:ln/>
+        </p:spPr>
+        <p:txBody>
+          <a:bodyPr wrap="square" lIns="0" tIns="0" rIns="0" bIns="0" rtlCol="0" anchor="t"/>
+          <a:lstStyle/>
+          <a:p>
+            <a:pPr indent="0" marL="0">
+              <a:buNone/>
+            </a:pPr>
+            <a:r>
+              <a:rPr lang="en-US" sz="2400" b="1" dirty="0">
+                <a:solidFill>
+                  <a:srgbClr val="FFFFFF"/>
+                </a:solidFill>
+                <a:latin typeface="Georgia" pitchFamily="34" charset="0"/>
+                <a:ea typeface="Georgia" pitchFamily="34" charset="-122"/>
+                <a:cs typeface="Georgia" pitchFamily="34" charset="-120"/>
+              </a:rPr>
+              <a:t>From vague prompts to a persistent AI playbook</a:t>
+            </a:r>
+            <a:endParaRPr lang="en-US" sz="2400" dirty="0"/>
+          </a:p>
+        </p:txBody>
+      </p:sp>
+      <p:sp>
+        <p:nvSpPr>
+          <p:cNvPr id="6" name="Text 4"/>
+          <p:cNvSpPr/>
+          <p:nvPr/>
+        </p:nvSpPr>
+        <p:spPr>
+          <a:xfrm>
+            <a:off x="731520" y="2651760"/>
+            <a:ext cx="731520" cy="822960"/>
+          </a:xfrm>
+          <a:prstGeom prst="rect">
+            <a:avLst/>
+          </a:prstGeom>
+          <a:noFill/>
+          <a:ln/>
+        </p:spPr>
+        <p:txBody>
+          <a:bodyPr wrap="square" lIns="0" tIns="0" rIns="0" bIns="0" rtlCol="0" anchor="ctr"/>
+          <a:lstStyle/>
+          <a:p>
+            <a:pPr algn="ctr" indent="0" marL="0">
+              <a:buNone/>
+            </a:pPr>
+            <a:r>
+              <a:rPr lang="en-US" sz="3600" b="1" dirty="0">
+                <a:solidFill>
+                  <a:srgbClr val="635BFF"/>
+                </a:solidFill>
+                <a:latin typeface="Georgia" pitchFamily="34" charset="0"/>
+                <a:ea typeface="Georgia" pitchFamily="34" charset="-122"/>
+                <a:cs typeface="Georgia" pitchFamily="34" charset="-120"/>
+              </a:rPr>
+              <a:t>2</a:t>
+            </a:r>
+            <a:endParaRPr lang="en-US" sz="3600" dirty="0"/>
+          </a:p>
+        </p:txBody>
+      </p:sp>
+      <p:sp>
+        <p:nvSpPr>
+          <p:cNvPr id="7" name="Text 5"/>
+          <p:cNvSpPr/>
+          <p:nvPr/>
+        </p:nvSpPr>
+        <p:spPr>
+          <a:xfrm>
+            <a:off x="1645920" y="2651760"/>
+            <a:ext cx="3200400" cy="411480"/>
+          </a:xfrm>
+          <a:prstGeom prst="rect">
+            <a:avLst/>
+          </a:prstGeom>
+          <a:noFill/>
+          <a:ln/>
+        </p:spPr>
+        <p:txBody>
+          <a:bodyPr wrap="square" lIns="0" tIns="0" rIns="0" bIns="0" rtlCol="0" anchor="b"/>
+          <a:lstStyle/>
+          <a:p>
+            <a:pPr indent="0" marL="0">
+              <a:buNone/>
+            </a:pPr>
+            <a:r>
+              <a:rPr lang="en-US" sz="1800" b="1" dirty="0">
+                <a:solidFill>
+                  <a:srgbClr val="8B95A5"/>
+                </a:solidFill>
+                <a:latin typeface="Verdana" pitchFamily="34" charset="0"/>
+                <a:ea typeface="Verdana" pitchFamily="34" charset="-122"/>
+                <a:cs typeface="Verdana" pitchFamily="34" charset="-120"/>
+              </a:rPr>
+              <a:t>Strategist → Orchestrator</a:t>
+            </a:r>
+            <a:endParaRPr lang="en-US" sz="1800" dirty="0"/>
+          </a:p>
+        </p:txBody>
+      </p:sp>
+      <p:sp>
+        <p:nvSpPr>
+          <p:cNvPr id="8" name="Text 6"/>
+          <p:cNvSpPr/>
+          <p:nvPr/>
+        </p:nvSpPr>
+        <p:spPr>
+          <a:xfrm>
+            <a:off x="1645920" y="3063240"/>
+            <a:ext cx="5486400" cy="411480"/>
+          </a:xfrm>
+          <a:prstGeom prst="rect">
+            <a:avLst/>
+          </a:prstGeom>
+          <a:noFill/>
+          <a:ln/>
+        </p:spPr>
+        <p:txBody>
+          <a:bodyPr wrap="square" lIns="0" tIns="0" rIns="0" bIns="0" rtlCol="0" anchor="t"/>
+          <a:lstStyle/>
+          <a:p>
+            <a:pPr indent="0" marL="0">
+              <a:buNone/>
+            </a:pPr>
+            <a:r>
+              <a:rPr lang="en-US" sz="2400" b="1" dirty="0">
+                <a:solidFill>
+                  <a:srgbClr val="FFFFFF"/>
+                </a:solidFill>
+                <a:latin typeface="Georgia" pitchFamily="34" charset="0"/>
+                <a:ea typeface="Georgia" pitchFamily="34" charset="-122"/>
+                <a:cs typeface="Georgia" pitchFamily="34" charset="-120"/>
+              </a:rPr>
+              <a:t>From doing the work to directing AI teams</a:t>
+            </a:r>
+            <a:endParaRPr lang="en-US" sz="2400" dirty="0"/>
+          </a:p>
+        </p:txBody>
+      </p:sp>
+    </p:spTree>
+  </p:cSld>
+  <p:clrMapOvr>
+    <a:masterClrMapping/>
+  </p:clrMapOvr>
+</p:sld>
+</file>
+
+<file path=ppt/slides/slide11.xml><?xml version="1.0" encoding="utf-8"?>
+<p:sld xmlns:a="http://schemas.openxmlformats.org/drawingml/2006/main" xmlns:r="http://schemas.openxmlformats.org/officeDocument/2006/relationships" xmlns:p="http://schemas.openxmlformats.org/presentationml/2006/main">
+  <p:cSld name="Slide 11">
+    <p:bg>
+      <p:bgPr>
+        <a:solidFill>
+          <a:srgbClr val="0A2540"/>
+        </a:solidFill>
+      </p:bgPr>
+    </p:bg>
+    <p:spTree>
+      <p:nvGrpSpPr>
+        <p:cNvPr id="1" name=""/>
+        <p:cNvGrpSpPr/>
+        <p:nvPr/>
+      </p:nvGrpSpPr>
+      <p:grpSpPr>
+        <a:xfrm>
+          <a:off x="0" y="0"/>
+          <a:ext cx="0" cy="0"/>
+          <a:chOff x="0" y="0"/>
+          <a:chExt cx="0" cy="0"/>
+        </a:xfrm>
+      </p:grpSpPr>
+      <p:sp>
+        <p:nvSpPr>
+          <p:cNvPr id="2" name="Shape 0"/>
+          <p:cNvSpPr/>
+          <p:nvPr/>
+        </p:nvSpPr>
+        <p:spPr>
+          <a:xfrm>
+            <a:off x="4572000" y="2286000"/>
+            <a:ext cx="7315200" cy="5486400"/>
+          </a:xfrm>
+          <a:prstGeom prst="ellipse">
+            <a:avLst/>
+          </a:prstGeom>
+          <a:solidFill>
+            <a:srgbClr val="635BFF">
+              <a:alpha val="4000"/>
+            </a:srgbClr>
+          </a:solidFill>
+          <a:ln/>
+        </p:spPr>
+      </p:sp>
+      <p:sp>
+        <p:nvSpPr>
+          <p:cNvPr id="3" name="Text 1"/>
+          <p:cNvSpPr/>
+          <p:nvPr/>
+        </p:nvSpPr>
+        <p:spPr>
+          <a:xfrm>
             <a:off x="914400" y="1097280"/>
             <a:ext cx="7315200" cy="2560320"/>
           </a:xfrm>
@@ -1969,49 +2346,54 @@
               <a:buNone/>
             </a:pPr>
             <a:r>
-              <a:rPr lang="en-US" sz="2800" b="1" dirty="0">
-                <a:solidFill>
-                  <a:srgbClr val="EDEDED"/>
+              <a:rPr lang="en-US" sz="7200" b="1" dirty="0">
+                <a:solidFill>
+                  <a:srgbClr val="FFFFFF"/>
+                </a:solidFill>
+                <a:latin typeface="Georgia" pitchFamily="34" charset="0"/>
+                <a:ea typeface="Georgia" pitchFamily="34" charset="-122"/>
+                <a:cs typeface="Georgia" pitchFamily="34" charset="-120"/>
+              </a:rPr>
+              <a:t>“It’s slop.”</a:t>
+            </a:r>
+            <a:endParaRPr lang="en-US" sz="7200" dirty="0"/>
+          </a:p>
+        </p:txBody>
+      </p:sp>
+      <p:sp>
+        <p:nvSpPr>
+          <p:cNvPr id="4" name="Text 2"/>
+          <p:cNvSpPr/>
+          <p:nvPr/>
+        </p:nvSpPr>
+        <p:spPr>
+          <a:xfrm>
+            <a:off x="1371600" y="3657600"/>
+            <a:ext cx="6400800" cy="731520"/>
+          </a:xfrm>
+          <a:prstGeom prst="rect">
+            <a:avLst/>
+          </a:prstGeom>
+          <a:noFill/>
+          <a:ln/>
+        </p:spPr>
+        <p:txBody>
+          <a:bodyPr wrap="square" lIns="0" tIns="0" rIns="0" bIns="0" rtlCol="0" anchor="t"/>
+          <a:lstStyle/>
+          <a:p>
+            <a:pPr algn="ctr" indent="0" marL="0">
+              <a:buNone/>
+            </a:pPr>
+            <a:r>
+              <a:rPr lang="en-US" sz="2800" dirty="0">
+                <a:solidFill>
+                  <a:srgbClr val="8B95A5"/>
                 </a:solidFill>
                 <a:latin typeface="Verdana" pitchFamily="34" charset="0"/>
                 <a:ea typeface="Verdana" pitchFamily="34" charset="-122"/>
                 <a:cs typeface="Verdana" pitchFamily="34" charset="-120"/>
               </a:rPr>
-              <a:t>Last month, someone spent</a:t>
-            </a:r>
-            <a:endParaRPr lang="en-US" sz="2800" dirty="0"/>
-          </a:p>
-          <a:p>
-            <a:pPr algn="ctr" indent="0" marL="0">
-              <a:buNone/>
-            </a:pPr>
-            <a:r>
-              <a:rPr lang="en-US" sz="2800" b="1" dirty="0">
-                <a:solidFill>
-                  <a:srgbClr val="EDEDED"/>
-                </a:solidFill>
-                <a:latin typeface="Verdana" pitchFamily="34" charset="0"/>
-                <a:ea typeface="Verdana" pitchFamily="34" charset="-122"/>
-                <a:cs typeface="Verdana" pitchFamily="34" charset="-120"/>
-              </a:rPr>
-              <a:t>45 minutes on a one-page summary.</a:t>
-            </a:r>
-            <a:endParaRPr lang="en-US" sz="2800" dirty="0"/>
-          </a:p>
-          <a:p>
-            <a:pPr algn="ctr" indent="0" marL="0">
-              <a:buNone/>
-            </a:pPr>
-            <a:r>
-              <a:rPr lang="en-US" sz="2800" b="1" dirty="0">
-                <a:solidFill>
-                  <a:srgbClr val="EDEDED"/>
-                </a:solidFill>
-                <a:latin typeface="Verdana" pitchFamily="34" charset="0"/>
-                <a:ea typeface="Verdana" pitchFamily="34" charset="-122"/>
-                <a:cs typeface="Verdana" pitchFamily="34" charset="-120"/>
-              </a:rPr>
-              <a:t>The right approach took 2 minutes.</a:t>
+              <a:t>— Co-founder of OpenAI, October 2025</a:t>
             </a:r>
             <a:endParaRPr lang="en-US" sz="2800" dirty="0"/>
           </a:p>
@@ -2096,7 +2478,7 @@
               <a:buNone/>
             </a:pPr>
             <a:r>
-              <a:rPr lang="en-US" sz="4800" b="1" dirty="0">
+              <a:rPr lang="en-US" sz="3600" b="1" dirty="0">
                 <a:solidFill>
                   <a:srgbClr val="FFFFFF"/>
                 </a:solidFill>
@@ -2104,16 +2486,16 @@
                 <a:ea typeface="Georgia" pitchFamily="34" charset="-122"/>
                 <a:cs typeface="Georgia" pitchFamily="34" charset="-120"/>
               </a:rPr>
-              <a:t>What if your whole team</a:t>
-            </a:r>
-            <a:endParaRPr lang="en-US" sz="4800" dirty="0"/>
+              <a:t>“I’ve never felt this much behind.</a:t>
+            </a:r>
+            <a:endParaRPr lang="en-US" sz="3600" dirty="0"/>
           </a:p>
           <a:p>
             <a:pPr algn="ctr" indent="0" marL="0">
               <a:buNone/>
             </a:pPr>
             <a:r>
-              <a:rPr lang="en-US" sz="4800" b="1" dirty="0">
+              <a:rPr lang="en-US" sz="3600" b="1" dirty="0">
                 <a:solidFill>
                   <a:srgbClr val="FFFFFF"/>
                 </a:solidFill>
@@ -2121,9 +2503,48 @@
                 <a:ea typeface="Georgia" pitchFamily="34" charset="-122"/>
                 <a:cs typeface="Georgia" pitchFamily="34" charset="-120"/>
               </a:rPr>
-              <a:t>knew the trick?</a:t>
-            </a:r>
-            <a:endParaRPr lang="en-US" sz="4800" dirty="0"/>
+              <a:t>This is a skill issue.”</a:t>
+            </a:r>
+            <a:endParaRPr lang="en-US" sz="3600" dirty="0"/>
+          </a:p>
+        </p:txBody>
+      </p:sp>
+      <p:sp>
+        <p:nvSpPr>
+          <p:cNvPr id="4" name="Text 2"/>
+          <p:cNvSpPr/>
+          <p:nvPr/>
+        </p:nvSpPr>
+        <p:spPr>
+          <a:xfrm>
+            <a:off x="1371600" y="3657600"/>
+            <a:ext cx="6400800" cy="731520"/>
+          </a:xfrm>
+          <a:prstGeom prst="rect">
+            <a:avLst/>
+          </a:prstGeom>
+          <a:noFill/>
+          <a:ln/>
+        </p:spPr>
+        <p:txBody>
+          <a:bodyPr wrap="square" lIns="0" tIns="0" rIns="0" bIns="0" rtlCol="0" anchor="t"/>
+          <a:lstStyle/>
+          <a:p>
+            <a:pPr algn="ctr" indent="0" marL="0">
+              <a:buNone/>
+            </a:pPr>
+            <a:r>
+              <a:rPr lang="en-US" sz="2800" dirty="0">
+                <a:solidFill>
+                  <a:srgbClr val="8B95A5"/>
+                </a:solidFill>
+                <a:latin typeface="Verdana" pitchFamily="34" charset="0"/>
+                <a:ea typeface="Verdana" pitchFamily="34" charset="-122"/>
+                <a:cs typeface="Verdana" pitchFamily="34" charset="-120"/>
+              </a:rPr>
+              <a:t>— Same person. Two months later.</a:t>
+            </a:r>
+            <a:endParaRPr lang="en-US" sz="2800" dirty="0"/>
           </a:p>
         </p:txBody>
       </p:sp>
@@ -2189,8 +2610,8 @@
         </p:nvSpPr>
         <p:spPr>
           <a:xfrm>
-            <a:off x="457200" y="914400"/>
-            <a:ext cx="8229600" cy="2286000"/>
+            <a:off x="914400" y="1097280"/>
+            <a:ext cx="7315200" cy="2560320"/>
           </a:xfrm>
           <a:prstGeom prst="rect">
             <a:avLst/>
@@ -2199,14 +2620,14 @@
           <a:ln/>
         </p:spPr>
         <p:txBody>
-          <a:bodyPr wrap="square" lIns="0" tIns="0" rIns="0" bIns="0" rtlCol="0" anchor="b"/>
+          <a:bodyPr wrap="square" lIns="0" tIns="0" rIns="0" bIns="0" rtlCol="0" anchor="ctr"/>
           <a:lstStyle/>
           <a:p>
             <a:pPr algn="ctr" indent="0" marL="0">
               <a:buNone/>
             </a:pPr>
             <a:r>
-              <a:rPr lang="en-US" sz="12000" b="1" dirty="0">
+              <a:rPr lang="en-US" sz="4800" b="1" dirty="0">
                 <a:solidFill>
                   <a:srgbClr val="FFFFFF"/>
                 </a:solidFill>
@@ -2214,129 +2635,26 @@
                 <a:ea typeface="Georgia" pitchFamily="34" charset="-122"/>
                 <a:cs typeface="Georgia" pitchFamily="34" charset="-120"/>
               </a:rPr>
-              <a:t>1 billion+</a:t>
-            </a:r>
-            <a:endParaRPr lang="en-US" sz="12000" dirty="0"/>
-          </a:p>
-        </p:txBody>
-      </p:sp>
-      <p:sp>
-        <p:nvSpPr>
-          <p:cNvPr id="4" name="Text 2"/>
-          <p:cNvSpPr/>
-          <p:nvPr/>
-        </p:nvSpPr>
-        <p:spPr>
-          <a:xfrm>
-            <a:off x="1371600" y="3291840"/>
-            <a:ext cx="6400800" cy="731520"/>
-          </a:xfrm>
-          <a:prstGeom prst="rect">
-            <a:avLst/>
-          </a:prstGeom>
-          <a:noFill/>
-          <a:ln/>
-        </p:spPr>
-        <p:txBody>
-          <a:bodyPr wrap="square" lIns="0" tIns="0" rIns="0" bIns="0" rtlCol="0" anchor="t"/>
-          <a:lstStyle/>
+              <a:t>What if your whole team</a:t>
+            </a:r>
+            <a:endParaRPr lang="en-US" sz="4800" dirty="0"/>
+          </a:p>
           <a:p>
             <a:pPr algn="ctr" indent="0" marL="0">
               <a:buNone/>
             </a:pPr>
             <a:r>
-              <a:rPr lang="en-US" sz="2800" dirty="0">
-                <a:solidFill>
-                  <a:srgbClr val="8B95A5"/>
-                </a:solidFill>
-                <a:latin typeface="Verdana" pitchFamily="34" charset="0"/>
-                <a:ea typeface="Verdana" pitchFamily="34" charset="-122"/>
-                <a:cs typeface="Verdana" pitchFamily="34" charset="-120"/>
-              </a:rPr>
-              <a:t>use AI tools monthly. Fewer than 2% pay for premium.</a:t>
-            </a:r>
-            <a:endParaRPr lang="en-US" sz="2800" dirty="0"/>
-          </a:p>
-        </p:txBody>
-      </p:sp>
-      <p:sp>
-        <p:nvSpPr>
-          <p:cNvPr id="5" name="Text 3"/>
-          <p:cNvSpPr/>
-          <p:nvPr/>
-        </p:nvSpPr>
-        <p:spPr>
-          <a:xfrm>
-            <a:off x="457200" y="4572000"/>
-            <a:ext cx="8229600" cy="365760"/>
-          </a:xfrm>
-          <a:prstGeom prst="rect">
-            <a:avLst/>
-          </a:prstGeom>
-          <a:noFill/>
-          <a:ln/>
-        </p:spPr>
-        <p:txBody>
-          <a:bodyPr wrap="square" lIns="0" tIns="0" rIns="0" bIns="0" rtlCol="0" anchor="b"/>
-          <a:lstStyle/>
-          <a:p>
-            <a:pPr algn="r" indent="0" marL="0">
-              <a:buNone/>
-            </a:pPr>
-            <a:r>
-              <a:rPr lang="en-US" sz="1100" u="sng" dirty="0">
-                <a:solidFill>
-                  <a:srgbClr val="8B95A5"/>
-                </a:solidFill>
-                <a:latin typeface="Verdana" pitchFamily="34" charset="0"/>
-                <a:ea typeface="Verdana" pitchFamily="34" charset="-122"/>
-                <a:cs typeface="Verdana" pitchFamily="34" charset="-120"/>
-                <a:hlinkClick r:id="rId1" invalidUrl="" action="" tgtFrame="" tooltip="" history="1" highlightClick="0" endSnd="0">
-                  <a:extLst>
-                    <a:ext uri="{A12FA001-AC4F-418D-AE19-62706E023703}">
-                      <ahyp:hlinkClr xmlns:ahyp="http://schemas.microsoft.com/office/drawing/2018/hyperlinkcolor" val="tx"/>
-                    </a:ext>
-                  </a:extLst>
-                </a:hlinkClick>
-              </a:rPr>
-              <a:t>DataReportal 2026</a:t>
-            </a:r>
-            <a:pPr algn="r" indent="0" marL="0">
-              <a:buNone/>
-            </a:pPr>
-            <a:r>
-              <a:rPr lang="en-US" sz="1100" dirty="0">
-                <a:solidFill>
-                  <a:srgbClr val="8B95A5"/>
-                </a:solidFill>
-                <a:latin typeface="Verdana" pitchFamily="34" charset="0"/>
-                <a:ea typeface="Verdana" pitchFamily="34" charset="-122"/>
-                <a:cs typeface="Verdana" pitchFamily="34" charset="-120"/>
-              </a:rPr>
-              <a:t>, </a:t>
-            </a:r>
-            <a:pPr algn="r" indent="0" marL="0">
-              <a:buNone/>
-            </a:pPr>
-            <a:r>
-              <a:rPr lang="en-US" sz="1100" u="sng" dirty="0">
-                <a:solidFill>
-                  <a:srgbClr val="8B95A5"/>
-                </a:solidFill>
-                <a:latin typeface="Verdana" pitchFamily="34" charset="0"/>
-                <a:ea typeface="Verdana" pitchFamily="34" charset="-122"/>
-                <a:cs typeface="Verdana" pitchFamily="34" charset="-120"/>
-                <a:hlinkClick r:id="rId2" invalidUrl="" action="" tgtFrame="" tooltip="" history="1" highlightClick="0" endSnd="0">
-                  <a:extLst>
-                    <a:ext uri="{A12FA001-AC4F-418D-AE19-62706E023703}">
-                      <ahyp:hlinkClr xmlns:ahyp="http://schemas.microsoft.com/office/drawing/2018/hyperlinkcolor" val="tx"/>
-                    </a:ext>
-                  </a:extLst>
-                </a:hlinkClick>
-              </a:rPr>
-              <a:t>Reuters</a:t>
-            </a:r>
-            <a:endParaRPr lang="en-US" sz="1100" dirty="0"/>
+              <a:rPr lang="en-US" sz="4800" b="1" dirty="0">
+                <a:solidFill>
+                  <a:srgbClr val="FFFFFF"/>
+                </a:solidFill>
+                <a:latin typeface="Georgia" pitchFamily="34" charset="0"/>
+                <a:ea typeface="Georgia" pitchFamily="34" charset="-122"/>
+                <a:cs typeface="Georgia" pitchFamily="34" charset="-120"/>
+              </a:rPr>
+              <a:t>knew the trick?</a:t>
+            </a:r>
+            <a:endParaRPr lang="en-US" sz="4800" dirty="0"/>
           </a:p>
         </p:txBody>
       </p:sp>
@@ -2419,34 +2737,17 @@
               <a:buNone/>
             </a:pPr>
             <a:r>
-              <a:rPr lang="en-US" sz="8000" b="1" dirty="0">
-                <a:solidFill>
-                  <a:srgbClr val="FF6B8A"/>
+              <a:rPr lang="en-US" sz="12000" b="1" dirty="0">
+                <a:solidFill>
+                  <a:srgbClr val="FFFFFF"/>
                 </a:solidFill>
                 <a:latin typeface="Georgia" pitchFamily="34" charset="0"/>
                 <a:ea typeface="Georgia" pitchFamily="34" charset="-122"/>
                 <a:cs typeface="Georgia" pitchFamily="34" charset="-120"/>
               </a:rPr>
-              <a:t>19%</a:t>
-            </a:r>
-            <a:endParaRPr lang="en-US" sz="8000" dirty="0"/>
-          </a:p>
-          <a:p>
-            <a:pPr algn="ctr" indent="0" marL="0">
-              <a:buNone/>
-            </a:pPr>
-            <a:r>
-              <a:rPr lang="en-US" sz="8000" b="1" dirty="0">
-                <a:solidFill>
-                  <a:srgbClr val="FF6B8A"/>
-                </a:solidFill>
-                <a:latin typeface="Georgia" pitchFamily="34" charset="0"/>
-                <a:ea typeface="Georgia" pitchFamily="34" charset="-122"/>
-                <a:cs typeface="Georgia" pitchFamily="34" charset="-120"/>
-              </a:rPr>
-              <a:t>longer</a:t>
-            </a:r>
-            <a:endParaRPr lang="en-US" sz="8000" dirty="0"/>
+              <a:t>1 billion+</a:t>
+            </a:r>
+            <a:endParaRPr lang="en-US" sz="12000" dirty="0"/>
           </a:p>
         </p:txBody>
       </p:sp>
@@ -2483,7 +2784,7 @@
                 <a:ea typeface="Verdana" pitchFamily="34" charset="-122"/>
                 <a:cs typeface="Verdana" pitchFamily="34" charset="-120"/>
               </a:rPr>
-              <a:t>when developers rely on AI without understanding it</a:t>
+              <a:t>use AI tools monthly. Fewer than 2% pay for premium.</a:t>
             </a:r>
             <a:endParaRPr lang="en-US" sz="2800" dirty="0"/>
           </a:p>
@@ -2529,7 +2830,42 @@
                   </a:extLst>
                 </a:hlinkClick>
               </a:rPr>
-              <a:t>Addy Osmani</a:t>
+              <a:t>DataReportal 2026</a:t>
+            </a:r>
+            <a:pPr algn="r" indent="0" marL="0">
+              <a:buNone/>
+            </a:pPr>
+            <a:r>
+              <a:rPr lang="en-US" sz="1100" dirty="0">
+                <a:solidFill>
+                  <a:srgbClr val="8B95A5"/>
+                </a:solidFill>
+                <a:latin typeface="Verdana" pitchFamily="34" charset="0"/>
+                <a:ea typeface="Verdana" pitchFamily="34" charset="-122"/>
+                <a:cs typeface="Verdana" pitchFamily="34" charset="-120"/>
+              </a:rPr>
+              <a:t>, </a:t>
+            </a:r>
+            <a:pPr algn="r" indent="0" marL="0">
+              <a:buNone/>
+            </a:pPr>
+            <a:r>
+              <a:rPr lang="en-US" sz="1100" u="sng" dirty="0">
+                <a:solidFill>
+                  <a:srgbClr val="8B95A5"/>
+                </a:solidFill>
+                <a:latin typeface="Verdana" pitchFamily="34" charset="0"/>
+                <a:ea typeface="Verdana" pitchFamily="34" charset="-122"/>
+                <a:cs typeface="Verdana" pitchFamily="34" charset="-120"/>
+                <a:hlinkClick r:id="rId2" invalidUrl="" action="" tgtFrame="" tooltip="" history="1" highlightClick="0" endSnd="0">
+                  <a:extLst>
+                    <a:ext uri="{A12FA001-AC4F-418D-AE19-62706E023703}">
+                      <ahyp:hlinkClr xmlns:ahyp="http://schemas.microsoft.com/office/drawing/2018/hyperlinkcolor" val="tx"/>
+                    </a:ext>
+                  </a:extLst>
+                </a:hlinkClick>
+              </a:rPr>
+              <a:t>Reuters</a:t>
             </a:r>
             <a:endParaRPr lang="en-US" sz="1100" dirty="0"/>
           </a:p>
@@ -2597,8 +2933,8 @@
         </p:nvSpPr>
         <p:spPr>
           <a:xfrm>
-            <a:off x="914400" y="1097280"/>
-            <a:ext cx="7315200" cy="2560320"/>
+            <a:off x="457200" y="914400"/>
+            <a:ext cx="8229600" cy="2286000"/>
           </a:xfrm>
           <a:prstGeom prst="rect">
             <a:avLst/>
@@ -2607,58 +2943,126 @@
           <a:ln/>
         </p:spPr>
         <p:txBody>
-          <a:bodyPr wrap="square" lIns="0" tIns="0" rIns="0" bIns="0" rtlCol="0" anchor="ctr"/>
+          <a:bodyPr wrap="square" lIns="0" tIns="0" rIns="0" bIns="0" rtlCol="0" anchor="b"/>
           <a:lstStyle/>
           <a:p>
             <a:pPr algn="ctr" indent="0" marL="0">
               <a:buNone/>
             </a:pPr>
             <a:r>
-              <a:rPr lang="en-US" sz="3800" b="1" dirty="0">
-                <a:solidFill>
-                  <a:srgbClr val="FFFFFF"/>
+              <a:rPr lang="en-US" sz="8000" b="1" dirty="0">
+                <a:solidFill>
+                  <a:srgbClr val="FF6B8A"/>
                 </a:solidFill>
                 <a:latin typeface="Georgia" pitchFamily="34" charset="0"/>
                 <a:ea typeface="Georgia" pitchFamily="34" charset="-122"/>
                 <a:cs typeface="Georgia" pitchFamily="34" charset="-120"/>
               </a:rPr>
-              <a:t>The gap between</a:t>
-            </a:r>
-            <a:endParaRPr lang="en-US" sz="3800" dirty="0"/>
+              <a:t>19%</a:t>
+            </a:r>
+            <a:endParaRPr lang="en-US" sz="8000" dirty="0"/>
           </a:p>
           <a:p>
             <a:pPr algn="ctr" indent="0" marL="0">
               <a:buNone/>
             </a:pPr>
             <a:r>
-              <a:rPr lang="en-US" sz="3800" b="1" dirty="0">
-                <a:solidFill>
-                  <a:srgbClr val="FFFFFF"/>
+              <a:rPr lang="en-US" sz="8000" b="1" dirty="0">
+                <a:solidFill>
+                  <a:srgbClr val="FF6B8A"/>
                 </a:solidFill>
                 <a:latin typeface="Georgia" pitchFamily="34" charset="0"/>
                 <a:ea typeface="Georgia" pitchFamily="34" charset="-122"/>
                 <a:cs typeface="Georgia" pitchFamily="34" charset="-120"/>
               </a:rPr>
-              <a:t>using AI and using AI well</a:t>
-            </a:r>
-            <a:endParaRPr lang="en-US" sz="3800" dirty="0"/>
-          </a:p>
+              <a:t>longer</a:t>
+            </a:r>
+            <a:endParaRPr lang="en-US" sz="8000" dirty="0"/>
+          </a:p>
+        </p:txBody>
+      </p:sp>
+      <p:sp>
+        <p:nvSpPr>
+          <p:cNvPr id="4" name="Text 2"/>
+          <p:cNvSpPr/>
+          <p:nvPr/>
+        </p:nvSpPr>
+        <p:spPr>
+          <a:xfrm>
+            <a:off x="1371600" y="3291840"/>
+            <a:ext cx="6400800" cy="731520"/>
+          </a:xfrm>
+          <a:prstGeom prst="rect">
+            <a:avLst/>
+          </a:prstGeom>
+          <a:noFill/>
+          <a:ln/>
+        </p:spPr>
+        <p:txBody>
+          <a:bodyPr wrap="square" lIns="0" tIns="0" rIns="0" bIns="0" rtlCol="0" anchor="t"/>
+          <a:lstStyle/>
           <a:p>
             <a:pPr algn="ctr" indent="0" marL="0">
               <a:buNone/>
             </a:pPr>
             <a:r>
-              <a:rPr lang="en-US" sz="3800" b="1" dirty="0">
-                <a:solidFill>
-                  <a:srgbClr val="FFFFFF"/>
-                </a:solidFill>
-                <a:latin typeface="Georgia" pitchFamily="34" charset="0"/>
-                <a:ea typeface="Georgia" pitchFamily="34" charset="-122"/>
-                <a:cs typeface="Georgia" pitchFamily="34" charset="-120"/>
-              </a:rPr>
-              <a:t>is massive.</a:t>
-            </a:r>
-            <a:endParaRPr lang="en-US" sz="3800" dirty="0"/>
+              <a:rPr lang="en-US" sz="2800" dirty="0">
+                <a:solidFill>
+                  <a:srgbClr val="8B95A5"/>
+                </a:solidFill>
+                <a:latin typeface="Verdana" pitchFamily="34" charset="0"/>
+                <a:ea typeface="Verdana" pitchFamily="34" charset="-122"/>
+                <a:cs typeface="Verdana" pitchFamily="34" charset="-120"/>
+              </a:rPr>
+              <a:t>when developers rely on AI without understanding it</a:t>
+            </a:r>
+            <a:endParaRPr lang="en-US" sz="2800" dirty="0"/>
+          </a:p>
+        </p:txBody>
+      </p:sp>
+      <p:sp>
+        <p:nvSpPr>
+          <p:cNvPr id="5" name="Text 3"/>
+          <p:cNvSpPr/>
+          <p:nvPr/>
+        </p:nvSpPr>
+        <p:spPr>
+          <a:xfrm>
+            <a:off x="457200" y="4572000"/>
+            <a:ext cx="8229600" cy="365760"/>
+          </a:xfrm>
+          <a:prstGeom prst="rect">
+            <a:avLst/>
+          </a:prstGeom>
+          <a:noFill/>
+          <a:ln/>
+        </p:spPr>
+        <p:txBody>
+          <a:bodyPr wrap="square" lIns="0" tIns="0" rIns="0" bIns="0" rtlCol="0" anchor="b"/>
+          <a:lstStyle/>
+          <a:p>
+            <a:pPr algn="r" indent="0" marL="0">
+              <a:buNone/>
+            </a:pPr>
+            <a:r>
+              <a:rPr lang="en-US" sz="1100" u="sng" dirty="0">
+                <a:solidFill>
+                  <a:srgbClr val="8B95A5"/>
+                </a:solidFill>
+                <a:latin typeface="Verdana" pitchFamily="34" charset="0"/>
+                <a:ea typeface="Verdana" pitchFamily="34" charset="-122"/>
+                <a:cs typeface="Verdana" pitchFamily="34" charset="-120"/>
+                <a:hlinkClick r:id="rId1" invalidUrl="" action="" tgtFrame="" tooltip="" history="1" highlightClick="0" endSnd="0">
+                  <a:extLst>
+                    <a:ext uri="{A12FA001-AC4F-418D-AE19-62706E023703}">
+                      <ahyp:hlinkClr xmlns:ahyp="http://schemas.microsoft.com/office/drawing/2018/hyperlinkcolor" val="tx"/>
+                    </a:ext>
+                  </a:extLst>
+                </a:hlinkClick>
+              </a:rPr>
+              <a:t>Addy Osmani</a:t>
+            </a:r>
+            <a:endParaRPr lang="en-US" sz="1100" dirty="0"/>
           </a:p>
         </p:txBody>
       </p:sp>
@@ -2718,43 +3122,14 @@
       </p:sp>
       <p:sp>
         <p:nvSpPr>
-          <p:cNvPr id="3" name="Shape 1"/>
-          <p:cNvSpPr/>
-          <p:nvPr/>
-        </p:nvSpPr>
-        <p:spPr>
-          <a:xfrm>
-            <a:off x="457200" y="1463040"/>
-            <a:ext cx="1097280" cy="640080"/>
-          </a:xfrm>
-          <a:prstGeom prst="roundRect">
-            <a:avLst>
-              <a:gd name="adj" fmla="val 11429"/>
-            </a:avLst>
-          </a:prstGeom>
-          <a:solidFill>
-            <a:srgbClr val="0A2540">
-              <a:alpha val="50000"/>
-            </a:srgbClr>
-          </a:solidFill>
-          <a:ln w="12700">
-            <a:solidFill>
-              <a:srgbClr val="8B95A5"/>
-            </a:solidFill>
-            <a:prstDash val="solid"/>
-          </a:ln>
-        </p:spPr>
-      </p:sp>
-      <p:sp>
-        <p:nvSpPr>
-          <p:cNvPr id="4" name="Text 2"/>
-          <p:cNvSpPr/>
-          <p:nvPr/>
-        </p:nvSpPr>
-        <p:spPr>
-          <a:xfrm>
-            <a:off x="457200" y="1463040"/>
-            <a:ext cx="1097280" cy="640080"/>
+          <p:cNvPr id="3" name="Text 1"/>
+          <p:cNvSpPr/>
+          <p:nvPr/>
+        </p:nvSpPr>
+        <p:spPr>
+          <a:xfrm>
+            <a:off x="914400" y="1097280"/>
+            <a:ext cx="7315200" cy="2560320"/>
           </a:xfrm>
           <a:prstGeom prst="rect">
             <a:avLst/>
@@ -2770,735 +3145,51 @@
               <a:buNone/>
             </a:pPr>
             <a:r>
-              <a:rPr lang="en-US" sz="1200" b="1" dirty="0">
-                <a:solidFill>
-                  <a:srgbClr val="8B95A5"/>
-                </a:solidFill>
-                <a:latin typeface="Verdana" pitchFamily="34" charset="0"/>
-                <a:ea typeface="Verdana" pitchFamily="34" charset="-122"/>
-                <a:cs typeface="Verdana" pitchFamily="34" charset="-120"/>
-              </a:rPr>
-              <a:t>Skeptic</a:t>
-            </a:r>
-            <a:endParaRPr lang="en-US" sz="1200" dirty="0"/>
-          </a:p>
-        </p:txBody>
-      </p:sp>
-      <p:sp>
-        <p:nvSpPr>
-          <p:cNvPr id="5" name="Text 3"/>
-          <p:cNvSpPr/>
-          <p:nvPr/>
-        </p:nvSpPr>
-        <p:spPr>
-          <a:xfrm>
-            <a:off x="1554480" y="1463040"/>
-            <a:ext cx="91440" cy="640080"/>
-          </a:xfrm>
-          <a:prstGeom prst="rect">
-            <a:avLst/>
-          </a:prstGeom>
-          <a:noFill/>
-          <a:ln/>
-        </p:spPr>
-        <p:txBody>
-          <a:bodyPr wrap="square" lIns="0" tIns="0" rIns="0" bIns="0" rtlCol="0" anchor="ctr"/>
-          <a:lstStyle/>
-          <a:p>
-            <a:pPr algn="ctr" indent="0" marL="0">
-              <a:buNone/>
-            </a:pPr>
-            <a:r>
-              <a:rPr lang="en-US" sz="1100" dirty="0">
-                <a:solidFill>
-                  <a:srgbClr val="8B95A5"/>
-                </a:solidFill>
-                <a:latin typeface="Verdana" pitchFamily="34" charset="0"/>
-                <a:ea typeface="Verdana" pitchFamily="34" charset="-122"/>
-                <a:cs typeface="Verdana" pitchFamily="34" charset="-120"/>
-              </a:rPr>
-              <a:t>→</a:t>
-            </a:r>
-            <a:endParaRPr lang="en-US" sz="1100" dirty="0"/>
-          </a:p>
-        </p:txBody>
-      </p:sp>
-      <p:sp>
-        <p:nvSpPr>
-          <p:cNvPr id="6" name="Shape 4"/>
-          <p:cNvSpPr/>
-          <p:nvPr/>
-        </p:nvSpPr>
-        <p:spPr>
-          <a:xfrm>
-            <a:off x="1645920" y="1463040"/>
-            <a:ext cx="1097280" cy="640080"/>
-          </a:xfrm>
-          <a:prstGeom prst="roundRect">
-            <a:avLst>
-              <a:gd name="adj" fmla="val 11429"/>
-            </a:avLst>
-          </a:prstGeom>
-          <a:solidFill>
-            <a:srgbClr val="635BFF"/>
-          </a:solidFill>
-          <a:ln w="25400">
-            <a:solidFill>
-              <a:srgbClr val="635BFF"/>
-            </a:solidFill>
-            <a:prstDash val="solid"/>
-          </a:ln>
-        </p:spPr>
-      </p:sp>
-      <p:sp>
-        <p:nvSpPr>
-          <p:cNvPr id="7" name="Text 5"/>
-          <p:cNvSpPr/>
-          <p:nvPr/>
-        </p:nvSpPr>
-        <p:spPr>
-          <a:xfrm>
-            <a:off x="1645920" y="1463040"/>
-            <a:ext cx="1097280" cy="640080"/>
-          </a:xfrm>
-          <a:prstGeom prst="rect">
-            <a:avLst/>
-          </a:prstGeom>
-          <a:noFill/>
-          <a:ln/>
-        </p:spPr>
-        <p:txBody>
-          <a:bodyPr wrap="square" lIns="0" tIns="0" rIns="0" bIns="0" rtlCol="0" anchor="ctr"/>
-          <a:lstStyle/>
-          <a:p>
-            <a:pPr algn="ctr" indent="0" marL="0">
-              <a:buNone/>
-            </a:pPr>
-            <a:r>
-              <a:rPr lang="en-US" sz="1200" b="1" dirty="0">
+              <a:rPr lang="en-US" sz="3800" b="1" dirty="0">
                 <a:solidFill>
                   <a:srgbClr val="FFFFFF"/>
-                </a:solidFill>
-                <a:latin typeface="Verdana" pitchFamily="34" charset="0"/>
-                <a:ea typeface="Verdana" pitchFamily="34" charset="-122"/>
-                <a:cs typeface="Verdana" pitchFamily="34" charset="-120"/>
-              </a:rPr>
-              <a:t>Explorer</a:t>
-            </a:r>
-            <a:endParaRPr lang="en-US" sz="1200" dirty="0"/>
-          </a:p>
-        </p:txBody>
-      </p:sp>
-      <p:sp>
-        <p:nvSpPr>
-          <p:cNvPr id="8" name="Text 6"/>
-          <p:cNvSpPr/>
-          <p:nvPr/>
-        </p:nvSpPr>
-        <p:spPr>
-          <a:xfrm>
-            <a:off x="2743200" y="1463040"/>
-            <a:ext cx="91440" cy="640080"/>
-          </a:xfrm>
-          <a:prstGeom prst="rect">
-            <a:avLst/>
-          </a:prstGeom>
-          <a:noFill/>
-          <a:ln/>
-        </p:spPr>
-        <p:txBody>
-          <a:bodyPr wrap="square" lIns="0" tIns="0" rIns="0" bIns="0" rtlCol="0" anchor="ctr"/>
-          <a:lstStyle/>
-          <a:p>
-            <a:pPr algn="ctr" indent="0" marL="0">
-              <a:buNone/>
-            </a:pPr>
-            <a:r>
-              <a:rPr lang="en-US" sz="1100" dirty="0">
-                <a:solidFill>
-                  <a:srgbClr val="8B95A5"/>
-                </a:solidFill>
-                <a:latin typeface="Verdana" pitchFamily="34" charset="0"/>
-                <a:ea typeface="Verdana" pitchFamily="34" charset="-122"/>
-                <a:cs typeface="Verdana" pitchFamily="34" charset="-120"/>
-              </a:rPr>
-              <a:t>→</a:t>
-            </a:r>
-            <a:endParaRPr lang="en-US" sz="1100" dirty="0"/>
-          </a:p>
-        </p:txBody>
-      </p:sp>
-      <p:sp>
-        <p:nvSpPr>
-          <p:cNvPr id="9" name="Shape 7"/>
-          <p:cNvSpPr/>
-          <p:nvPr/>
-        </p:nvSpPr>
-        <p:spPr>
-          <a:xfrm>
-            <a:off x="2834640" y="1463040"/>
-            <a:ext cx="1097280" cy="640080"/>
-          </a:xfrm>
-          <a:prstGeom prst="roundRect">
-            <a:avLst>
-              <a:gd name="adj" fmla="val 11429"/>
-            </a:avLst>
-          </a:prstGeom>
-          <a:solidFill>
-            <a:srgbClr val="0A2540">
-              <a:alpha val="50000"/>
-            </a:srgbClr>
-          </a:solidFill>
-          <a:ln w="12700">
-            <a:solidFill>
-              <a:srgbClr val="8B95A5"/>
-            </a:solidFill>
-            <a:prstDash val="solid"/>
-          </a:ln>
-        </p:spPr>
-      </p:sp>
-      <p:sp>
-        <p:nvSpPr>
-          <p:cNvPr id="10" name="Text 8"/>
-          <p:cNvSpPr/>
-          <p:nvPr/>
-        </p:nvSpPr>
-        <p:spPr>
-          <a:xfrm>
-            <a:off x="2834640" y="1463040"/>
-            <a:ext cx="1097280" cy="640080"/>
-          </a:xfrm>
-          <a:prstGeom prst="rect">
-            <a:avLst/>
-          </a:prstGeom>
-          <a:noFill/>
-          <a:ln/>
-        </p:spPr>
-        <p:txBody>
-          <a:bodyPr wrap="square" lIns="0" tIns="0" rIns="0" bIns="0" rtlCol="0" anchor="ctr"/>
-          <a:lstStyle/>
-          <a:p>
-            <a:pPr algn="ctr" indent="0" marL="0">
-              <a:buNone/>
-            </a:pPr>
-            <a:r>
-              <a:rPr lang="en-US" sz="1200" b="1" dirty="0">
-                <a:solidFill>
-                  <a:srgbClr val="8B95A5"/>
-                </a:solidFill>
-                <a:latin typeface="Verdana" pitchFamily="34" charset="0"/>
-                <a:ea typeface="Verdana" pitchFamily="34" charset="-122"/>
-                <a:cs typeface="Verdana" pitchFamily="34" charset="-120"/>
-              </a:rPr>
-              <a:t>Whisperer</a:t>
-            </a:r>
-            <a:endParaRPr lang="en-US" sz="1200" dirty="0"/>
-          </a:p>
-        </p:txBody>
-      </p:sp>
-      <p:sp>
-        <p:nvSpPr>
-          <p:cNvPr id="11" name="Text 9"/>
-          <p:cNvSpPr/>
-          <p:nvPr/>
-        </p:nvSpPr>
-        <p:spPr>
-          <a:xfrm>
-            <a:off x="3931920" y="1463040"/>
-            <a:ext cx="91440" cy="640080"/>
-          </a:xfrm>
-          <a:prstGeom prst="rect">
-            <a:avLst/>
-          </a:prstGeom>
-          <a:noFill/>
-          <a:ln/>
-        </p:spPr>
-        <p:txBody>
-          <a:bodyPr wrap="square" lIns="0" tIns="0" rIns="0" bIns="0" rtlCol="0" anchor="ctr"/>
-          <a:lstStyle/>
-          <a:p>
-            <a:pPr algn="ctr" indent="0" marL="0">
-              <a:buNone/>
-            </a:pPr>
-            <a:r>
-              <a:rPr lang="en-US" sz="1100" dirty="0">
-                <a:solidFill>
-                  <a:srgbClr val="8B95A5"/>
-                </a:solidFill>
-                <a:latin typeface="Verdana" pitchFamily="34" charset="0"/>
-                <a:ea typeface="Verdana" pitchFamily="34" charset="-122"/>
-                <a:cs typeface="Verdana" pitchFamily="34" charset="-120"/>
-              </a:rPr>
-              <a:t>→</a:t>
-            </a:r>
-            <a:endParaRPr lang="en-US" sz="1100" dirty="0"/>
-          </a:p>
-        </p:txBody>
-      </p:sp>
-      <p:sp>
-        <p:nvSpPr>
-          <p:cNvPr id="12" name="Shape 10"/>
-          <p:cNvSpPr/>
-          <p:nvPr/>
-        </p:nvSpPr>
-        <p:spPr>
-          <a:xfrm>
-            <a:off x="4023360" y="1463040"/>
-            <a:ext cx="1097280" cy="640080"/>
-          </a:xfrm>
-          <a:prstGeom prst="roundRect">
-            <a:avLst>
-              <a:gd name="adj" fmla="val 11429"/>
-            </a:avLst>
-          </a:prstGeom>
-          <a:solidFill>
-            <a:srgbClr val="0A2540">
-              <a:alpha val="50000"/>
-            </a:srgbClr>
-          </a:solidFill>
-          <a:ln w="12700">
-            <a:solidFill>
-              <a:srgbClr val="8B95A5"/>
-            </a:solidFill>
-            <a:prstDash val="solid"/>
-          </a:ln>
-        </p:spPr>
-      </p:sp>
-      <p:sp>
-        <p:nvSpPr>
-          <p:cNvPr id="13" name="Text 11"/>
-          <p:cNvSpPr/>
-          <p:nvPr/>
-        </p:nvSpPr>
-        <p:spPr>
-          <a:xfrm>
-            <a:off x="4023360" y="1463040"/>
-            <a:ext cx="1097280" cy="640080"/>
-          </a:xfrm>
-          <a:prstGeom prst="rect">
-            <a:avLst/>
-          </a:prstGeom>
-          <a:noFill/>
-          <a:ln/>
-        </p:spPr>
-        <p:txBody>
-          <a:bodyPr wrap="square" lIns="0" tIns="0" rIns="0" bIns="0" rtlCol="0" anchor="ctr"/>
-          <a:lstStyle/>
-          <a:p>
-            <a:pPr algn="ctr" indent="0" marL="0">
-              <a:buNone/>
-            </a:pPr>
-            <a:r>
-              <a:rPr lang="en-US" sz="1200" b="1" dirty="0">
-                <a:solidFill>
-                  <a:srgbClr val="8B95A5"/>
-                </a:solidFill>
-                <a:latin typeface="Verdana" pitchFamily="34" charset="0"/>
-                <a:ea typeface="Verdana" pitchFamily="34" charset="-122"/>
-                <a:cs typeface="Verdana" pitchFamily="34" charset="-120"/>
-              </a:rPr>
-              <a:t>Strategist</a:t>
-            </a:r>
-            <a:endParaRPr lang="en-US" sz="1200" dirty="0"/>
-          </a:p>
-        </p:txBody>
-      </p:sp>
-      <p:sp>
-        <p:nvSpPr>
-          <p:cNvPr id="14" name="Text 12"/>
-          <p:cNvSpPr/>
-          <p:nvPr/>
-        </p:nvSpPr>
-        <p:spPr>
-          <a:xfrm>
-            <a:off x="5120640" y="1463040"/>
-            <a:ext cx="91440" cy="640080"/>
-          </a:xfrm>
-          <a:prstGeom prst="rect">
-            <a:avLst/>
-          </a:prstGeom>
-          <a:noFill/>
-          <a:ln/>
-        </p:spPr>
-        <p:txBody>
-          <a:bodyPr wrap="square" lIns="0" tIns="0" rIns="0" bIns="0" rtlCol="0" anchor="ctr"/>
-          <a:lstStyle/>
-          <a:p>
-            <a:pPr algn="ctr" indent="0" marL="0">
-              <a:buNone/>
-            </a:pPr>
-            <a:r>
-              <a:rPr lang="en-US" sz="1100" dirty="0">
-                <a:solidFill>
-                  <a:srgbClr val="8B95A5"/>
-                </a:solidFill>
-                <a:latin typeface="Verdana" pitchFamily="34" charset="0"/>
-                <a:ea typeface="Verdana" pitchFamily="34" charset="-122"/>
-                <a:cs typeface="Verdana" pitchFamily="34" charset="-120"/>
-              </a:rPr>
-              <a:t>→</a:t>
-            </a:r>
-            <a:endParaRPr lang="en-US" sz="1100" dirty="0"/>
-          </a:p>
-        </p:txBody>
-      </p:sp>
-      <p:sp>
-        <p:nvSpPr>
-          <p:cNvPr id="15" name="Shape 13"/>
-          <p:cNvSpPr/>
-          <p:nvPr/>
-        </p:nvSpPr>
-        <p:spPr>
-          <a:xfrm>
-            <a:off x="5212080" y="1463040"/>
-            <a:ext cx="1097280" cy="640080"/>
-          </a:xfrm>
-          <a:prstGeom prst="roundRect">
-            <a:avLst>
-              <a:gd name="adj" fmla="val 11429"/>
-            </a:avLst>
-          </a:prstGeom>
-          <a:solidFill>
-            <a:srgbClr val="0A2540">
-              <a:alpha val="50000"/>
-            </a:srgbClr>
-          </a:solidFill>
-          <a:ln w="12700">
-            <a:solidFill>
-              <a:srgbClr val="8B95A5"/>
-            </a:solidFill>
-            <a:prstDash val="solid"/>
-          </a:ln>
-        </p:spPr>
-      </p:sp>
-      <p:sp>
-        <p:nvSpPr>
-          <p:cNvPr id="16" name="Text 14"/>
-          <p:cNvSpPr/>
-          <p:nvPr/>
-        </p:nvSpPr>
-        <p:spPr>
-          <a:xfrm>
-            <a:off x="5212080" y="1463040"/>
-            <a:ext cx="1097280" cy="640080"/>
-          </a:xfrm>
-          <a:prstGeom prst="rect">
-            <a:avLst/>
-          </a:prstGeom>
-          <a:noFill/>
-          <a:ln/>
-        </p:spPr>
-        <p:txBody>
-          <a:bodyPr wrap="square" lIns="0" tIns="0" rIns="0" bIns="0" rtlCol="0" anchor="ctr"/>
-          <a:lstStyle/>
-          <a:p>
-            <a:pPr algn="ctr" indent="0" marL="0">
-              <a:buNone/>
-            </a:pPr>
-            <a:r>
-              <a:rPr lang="en-US" sz="1200" b="1" dirty="0">
-                <a:solidFill>
-                  <a:srgbClr val="8B95A5"/>
-                </a:solidFill>
-                <a:latin typeface="Verdana" pitchFamily="34" charset="0"/>
-                <a:ea typeface="Verdana" pitchFamily="34" charset="-122"/>
-                <a:cs typeface="Verdana" pitchFamily="34" charset="-120"/>
-              </a:rPr>
-              <a:t>Operator</a:t>
-            </a:r>
-            <a:endParaRPr lang="en-US" sz="1200" dirty="0"/>
-          </a:p>
-        </p:txBody>
-      </p:sp>
-      <p:sp>
-        <p:nvSpPr>
-          <p:cNvPr id="17" name="Text 15"/>
-          <p:cNvSpPr/>
-          <p:nvPr/>
-        </p:nvSpPr>
-        <p:spPr>
-          <a:xfrm>
-            <a:off x="6309360" y="1463040"/>
-            <a:ext cx="91440" cy="640080"/>
-          </a:xfrm>
-          <a:prstGeom prst="rect">
-            <a:avLst/>
-          </a:prstGeom>
-          <a:noFill/>
-          <a:ln/>
-        </p:spPr>
-        <p:txBody>
-          <a:bodyPr wrap="square" lIns="0" tIns="0" rIns="0" bIns="0" rtlCol="0" anchor="ctr"/>
-          <a:lstStyle/>
-          <a:p>
-            <a:pPr algn="ctr" indent="0" marL="0">
-              <a:buNone/>
-            </a:pPr>
-            <a:r>
-              <a:rPr lang="en-US" sz="1100" dirty="0">
-                <a:solidFill>
-                  <a:srgbClr val="8B95A5"/>
-                </a:solidFill>
-                <a:latin typeface="Verdana" pitchFamily="34" charset="0"/>
-                <a:ea typeface="Verdana" pitchFamily="34" charset="-122"/>
-                <a:cs typeface="Verdana" pitchFamily="34" charset="-120"/>
-              </a:rPr>
-              <a:t>→</a:t>
-            </a:r>
-            <a:endParaRPr lang="en-US" sz="1100" dirty="0"/>
-          </a:p>
-        </p:txBody>
-      </p:sp>
-      <p:sp>
-        <p:nvSpPr>
-          <p:cNvPr id="18" name="Shape 16"/>
-          <p:cNvSpPr/>
-          <p:nvPr/>
-        </p:nvSpPr>
-        <p:spPr>
-          <a:xfrm>
-            <a:off x="6400800" y="1463040"/>
-            <a:ext cx="1097280" cy="640080"/>
-          </a:xfrm>
-          <a:prstGeom prst="roundRect">
-            <a:avLst>
-              <a:gd name="adj" fmla="val 11429"/>
-            </a:avLst>
-          </a:prstGeom>
-          <a:solidFill>
-            <a:srgbClr val="0A2540">
-              <a:alpha val="50000"/>
-            </a:srgbClr>
-          </a:solidFill>
-          <a:ln w="25400">
-            <a:solidFill>
-              <a:srgbClr val="635BFF"/>
-            </a:solidFill>
-            <a:prstDash val="solid"/>
-          </a:ln>
-        </p:spPr>
-      </p:sp>
-      <p:sp>
-        <p:nvSpPr>
-          <p:cNvPr id="19" name="Text 17"/>
-          <p:cNvSpPr/>
-          <p:nvPr/>
-        </p:nvSpPr>
-        <p:spPr>
-          <a:xfrm>
-            <a:off x="6400800" y="1463040"/>
-            <a:ext cx="1097280" cy="640080"/>
-          </a:xfrm>
-          <a:prstGeom prst="rect">
-            <a:avLst/>
-          </a:prstGeom>
-          <a:noFill/>
-          <a:ln/>
-        </p:spPr>
-        <p:txBody>
-          <a:bodyPr wrap="square" lIns="0" tIns="0" rIns="0" bIns="0" rtlCol="0" anchor="ctr"/>
-          <a:lstStyle/>
-          <a:p>
-            <a:pPr algn="ctr" indent="0" marL="0">
-              <a:buNone/>
-            </a:pPr>
-            <a:r>
-              <a:rPr lang="en-US" sz="1200" b="1" dirty="0">
-                <a:solidFill>
-                  <a:srgbClr val="635BFF"/>
-                </a:solidFill>
-                <a:latin typeface="Verdana" pitchFamily="34" charset="0"/>
-                <a:ea typeface="Verdana" pitchFamily="34" charset="-122"/>
-                <a:cs typeface="Verdana" pitchFamily="34" charset="-120"/>
-              </a:rPr>
-              <a:t>Orchestrator</a:t>
-            </a:r>
-            <a:endParaRPr lang="en-US" sz="1200" dirty="0"/>
-          </a:p>
-        </p:txBody>
-      </p:sp>
-      <p:sp>
-        <p:nvSpPr>
-          <p:cNvPr id="20" name="Text 18"/>
-          <p:cNvSpPr/>
-          <p:nvPr/>
-        </p:nvSpPr>
-        <p:spPr>
-          <a:xfrm>
-            <a:off x="7498080" y="1463040"/>
-            <a:ext cx="91440" cy="640080"/>
-          </a:xfrm>
-          <a:prstGeom prst="rect">
-            <a:avLst/>
-          </a:prstGeom>
-          <a:noFill/>
-          <a:ln/>
-        </p:spPr>
-        <p:txBody>
-          <a:bodyPr wrap="square" lIns="0" tIns="0" rIns="0" bIns="0" rtlCol="0" anchor="ctr"/>
-          <a:lstStyle/>
-          <a:p>
-            <a:pPr algn="ctr" indent="0" marL="0">
-              <a:buNone/>
-            </a:pPr>
-            <a:r>
-              <a:rPr lang="en-US" sz="1100" dirty="0">
-                <a:solidFill>
-                  <a:srgbClr val="8B95A5"/>
-                </a:solidFill>
-                <a:latin typeface="Verdana" pitchFamily="34" charset="0"/>
-                <a:ea typeface="Verdana" pitchFamily="34" charset="-122"/>
-                <a:cs typeface="Verdana" pitchFamily="34" charset="-120"/>
-              </a:rPr>
-              <a:t>→</a:t>
-            </a:r>
-            <a:endParaRPr lang="en-US" sz="1100" dirty="0"/>
-          </a:p>
-        </p:txBody>
-      </p:sp>
-      <p:sp>
-        <p:nvSpPr>
-          <p:cNvPr id="21" name="Shape 19"/>
-          <p:cNvSpPr/>
-          <p:nvPr/>
-        </p:nvSpPr>
-        <p:spPr>
-          <a:xfrm>
-            <a:off x="7589520" y="1463040"/>
-            <a:ext cx="1097280" cy="640080"/>
-          </a:xfrm>
-          <a:prstGeom prst="roundRect">
-            <a:avLst>
-              <a:gd name="adj" fmla="val 11429"/>
-            </a:avLst>
-          </a:prstGeom>
-          <a:solidFill>
-            <a:srgbClr val="0A2540">
-              <a:alpha val="50000"/>
-            </a:srgbClr>
-          </a:solidFill>
-          <a:ln w="12700">
-            <a:solidFill>
-              <a:srgbClr val="8B95A5"/>
-            </a:solidFill>
-            <a:prstDash val="dash"/>
-          </a:ln>
-        </p:spPr>
-      </p:sp>
-      <p:sp>
-        <p:nvSpPr>
-          <p:cNvPr id="22" name="Text 20"/>
-          <p:cNvSpPr/>
-          <p:nvPr/>
-        </p:nvSpPr>
-        <p:spPr>
-          <a:xfrm>
-            <a:off x="7589520" y="1463040"/>
-            <a:ext cx="1097280" cy="640080"/>
-          </a:xfrm>
-          <a:prstGeom prst="rect">
-            <a:avLst/>
-          </a:prstGeom>
-          <a:noFill/>
-          <a:ln/>
-        </p:spPr>
-        <p:txBody>
-          <a:bodyPr wrap="square" lIns="0" tIns="0" rIns="0" bIns="0" rtlCol="0" anchor="ctr"/>
-          <a:lstStyle/>
-          <a:p>
-            <a:pPr algn="ctr" indent="0" marL="0">
-              <a:buNone/>
-            </a:pPr>
-            <a:r>
-              <a:rPr lang="en-US" sz="1200" b="1" dirty="0">
-                <a:solidFill>
-                  <a:srgbClr val="8B95A5"/>
-                </a:solidFill>
-                <a:latin typeface="Verdana" pitchFamily="34" charset="0"/>
-                <a:ea typeface="Verdana" pitchFamily="34" charset="-122"/>
-                <a:cs typeface="Verdana" pitchFamily="34" charset="-120"/>
-              </a:rPr>
-              <a:t>Builder</a:t>
-            </a:r>
-            <a:endParaRPr lang="en-US" sz="1200" dirty="0"/>
-          </a:p>
-        </p:txBody>
-      </p:sp>
-      <p:sp>
-        <p:nvSpPr>
-          <p:cNvPr id="23" name="Text 21"/>
-          <p:cNvSpPr/>
-          <p:nvPr/>
-        </p:nvSpPr>
-        <p:spPr>
-          <a:xfrm>
-            <a:off x="457200" y="2468880"/>
-            <a:ext cx="4114800" cy="731520"/>
-          </a:xfrm>
-          <a:prstGeom prst="rect">
-            <a:avLst/>
-          </a:prstGeom>
-          <a:noFill/>
-          <a:ln/>
-        </p:spPr>
-        <p:txBody>
-          <a:bodyPr wrap="square" lIns="0" tIns="0" rIns="0" bIns="0" rtlCol="0" anchor="t"/>
-          <a:lstStyle/>
-          <a:p>
-            <a:pPr algn="ctr" indent="0" marL="0">
-              <a:buNone/>
-            </a:pPr>
-            <a:r>
-              <a:rPr lang="en-US" sz="2800" b="1" dirty="0">
-                <a:solidFill>
-                  <a:srgbClr val="635BFF"/>
                 </a:solidFill>
                 <a:latin typeface="Georgia" pitchFamily="34" charset="0"/>
                 <a:ea typeface="Georgia" pitchFamily="34" charset="-122"/>
                 <a:cs typeface="Georgia" pitchFamily="34" charset="-120"/>
               </a:rPr>
-              <a:t>Most of us are here.</a:t>
-            </a:r>
-            <a:endParaRPr lang="en-US" sz="2800" dirty="0"/>
-          </a:p>
-        </p:txBody>
-      </p:sp>
-      <p:sp>
-        <p:nvSpPr>
-          <p:cNvPr id="24" name="Text 22"/>
-          <p:cNvSpPr/>
-          <p:nvPr/>
-        </p:nvSpPr>
-        <p:spPr>
-          <a:xfrm>
-            <a:off x="4572000" y="2468880"/>
-            <a:ext cx="4114800" cy="731520"/>
-          </a:xfrm>
-          <a:prstGeom prst="rect">
-            <a:avLst/>
-          </a:prstGeom>
-          <a:noFill/>
-          <a:ln/>
-        </p:spPr>
-        <p:txBody>
-          <a:bodyPr wrap="square" lIns="0" tIns="0" rIns="0" bIns="0" rtlCol="0" anchor="t"/>
-          <a:lstStyle/>
+              <a:t>The gap between</a:t>
+            </a:r>
+            <a:endParaRPr lang="en-US" sz="3800" dirty="0"/>
+          </a:p>
           <a:p>
             <a:pPr algn="ctr" indent="0" marL="0">
               <a:buNone/>
             </a:pPr>
             <a:r>
-              <a:rPr lang="en-US" sz="2800" b="1" dirty="0">
-                <a:solidFill>
-                  <a:srgbClr val="635BFF"/>
+              <a:rPr lang="en-US" sz="3800" b="1" dirty="0">
+                <a:solidFill>
+                  <a:srgbClr val="FFFFFF"/>
                 </a:solidFill>
                 <a:latin typeface="Georgia" pitchFamily="34" charset="0"/>
                 <a:ea typeface="Georgia" pitchFamily="34" charset="-122"/>
                 <a:cs typeface="Georgia" pitchFamily="34" charset="-120"/>
               </a:rPr>
-              <a:t>The AI Academy takes you here.</a:t>
-            </a:r>
-            <a:endParaRPr lang="en-US" sz="2800" dirty="0"/>
+              <a:t>using AI and using AI well</a:t>
+            </a:r>
+            <a:endParaRPr lang="en-US" sz="3800" dirty="0"/>
+          </a:p>
+          <a:p>
+            <a:pPr algn="ctr" indent="0" marL="0">
+              <a:buNone/>
+            </a:pPr>
+            <a:r>
+              <a:rPr lang="en-US" sz="3800" b="1" dirty="0">
+                <a:solidFill>
+                  <a:srgbClr val="FFFFFF"/>
+                </a:solidFill>
+                <a:latin typeface="Georgia" pitchFamily="34" charset="0"/>
+                <a:ea typeface="Georgia" pitchFamily="34" charset="-122"/>
+                <a:cs typeface="Georgia" pitchFamily="34" charset="-120"/>
+              </a:rPr>
+              <a:t>is massive.</a:t>
+            </a:r>
+            <a:endParaRPr lang="en-US" sz="3800" dirty="0"/>
           </a:p>
         </p:txBody>
       </p:sp>
@@ -3558,14 +3249,43 @@
       </p:sp>
       <p:sp>
         <p:nvSpPr>
-          <p:cNvPr id="3" name="Text 1"/>
-          <p:cNvSpPr/>
-          <p:nvPr/>
-        </p:nvSpPr>
-        <p:spPr>
-          <a:xfrm>
-            <a:off x="914400" y="1097280"/>
-            <a:ext cx="7315200" cy="2560320"/>
+          <p:cNvPr id="3" name="Shape 1"/>
+          <p:cNvSpPr/>
+          <p:nvPr/>
+        </p:nvSpPr>
+        <p:spPr>
+          <a:xfrm>
+            <a:off x="457200" y="1463040"/>
+            <a:ext cx="1097280" cy="640080"/>
+          </a:xfrm>
+          <a:prstGeom prst="roundRect">
+            <a:avLst>
+              <a:gd name="adj" fmla="val 11429"/>
+            </a:avLst>
+          </a:prstGeom>
+          <a:solidFill>
+            <a:srgbClr val="0A2540">
+              <a:alpha val="50000"/>
+            </a:srgbClr>
+          </a:solidFill>
+          <a:ln w="12700">
+            <a:solidFill>
+              <a:srgbClr val="8B95A5"/>
+            </a:solidFill>
+            <a:prstDash val="solid"/>
+          </a:ln>
+        </p:spPr>
+      </p:sp>
+      <p:sp>
+        <p:nvSpPr>
+          <p:cNvPr id="4" name="Text 2"/>
+          <p:cNvSpPr/>
+          <p:nvPr/>
+        </p:nvSpPr>
+        <p:spPr>
+          <a:xfrm>
+            <a:off x="457200" y="1463040"/>
+            <a:ext cx="1097280" cy="640080"/>
           </a:xfrm>
           <a:prstGeom prst="rect">
             <a:avLst/>
@@ -3581,71 +3301,733 @@
               <a:buNone/>
             </a:pPr>
             <a:r>
-              <a:rPr lang="en-US" sz="4400" b="1" dirty="0">
+              <a:rPr lang="en-US" sz="1200" b="1" dirty="0">
+                <a:solidFill>
+                  <a:srgbClr val="8B95A5"/>
+                </a:solidFill>
+                <a:latin typeface="Verdana" pitchFamily="34" charset="0"/>
+                <a:ea typeface="Verdana" pitchFamily="34" charset="-122"/>
+                <a:cs typeface="Verdana" pitchFamily="34" charset="-120"/>
+              </a:rPr>
+              <a:t>Skeptic</a:t>
+            </a:r>
+            <a:endParaRPr lang="en-US" sz="1200" dirty="0"/>
+          </a:p>
+        </p:txBody>
+      </p:sp>
+      <p:sp>
+        <p:nvSpPr>
+          <p:cNvPr id="5" name="Text 3"/>
+          <p:cNvSpPr/>
+          <p:nvPr/>
+        </p:nvSpPr>
+        <p:spPr>
+          <a:xfrm>
+            <a:off x="1554480" y="1463040"/>
+            <a:ext cx="91440" cy="640080"/>
+          </a:xfrm>
+          <a:prstGeom prst="rect">
+            <a:avLst/>
+          </a:prstGeom>
+          <a:noFill/>
+          <a:ln/>
+        </p:spPr>
+        <p:txBody>
+          <a:bodyPr wrap="square" lIns="0" tIns="0" rIns="0" bIns="0" rtlCol="0" anchor="ctr"/>
+          <a:lstStyle/>
+          <a:p>
+            <a:pPr algn="ctr" indent="0" marL="0">
+              <a:buNone/>
+            </a:pPr>
+            <a:r>
+              <a:rPr lang="en-US" sz="1100" dirty="0">
+                <a:solidFill>
+                  <a:srgbClr val="8B95A5"/>
+                </a:solidFill>
+                <a:latin typeface="Verdana" pitchFamily="34" charset="0"/>
+                <a:ea typeface="Verdana" pitchFamily="34" charset="-122"/>
+                <a:cs typeface="Verdana" pitchFamily="34" charset="-120"/>
+              </a:rPr>
+              <a:t>→</a:t>
+            </a:r>
+            <a:endParaRPr lang="en-US" sz="1100" dirty="0"/>
+          </a:p>
+        </p:txBody>
+      </p:sp>
+      <p:sp>
+        <p:nvSpPr>
+          <p:cNvPr id="6" name="Shape 4"/>
+          <p:cNvSpPr/>
+          <p:nvPr/>
+        </p:nvSpPr>
+        <p:spPr>
+          <a:xfrm>
+            <a:off x="1645920" y="1463040"/>
+            <a:ext cx="1097280" cy="640080"/>
+          </a:xfrm>
+          <a:prstGeom prst="roundRect">
+            <a:avLst>
+              <a:gd name="adj" fmla="val 11429"/>
+            </a:avLst>
+          </a:prstGeom>
+          <a:solidFill>
+            <a:srgbClr val="635BFF"/>
+          </a:solidFill>
+          <a:ln w="25400">
+            <a:solidFill>
+              <a:srgbClr val="635BFF"/>
+            </a:solidFill>
+            <a:prstDash val="solid"/>
+          </a:ln>
+        </p:spPr>
+      </p:sp>
+      <p:sp>
+        <p:nvSpPr>
+          <p:cNvPr id="7" name="Text 5"/>
+          <p:cNvSpPr/>
+          <p:nvPr/>
+        </p:nvSpPr>
+        <p:spPr>
+          <a:xfrm>
+            <a:off x="1645920" y="1463040"/>
+            <a:ext cx="1097280" cy="640080"/>
+          </a:xfrm>
+          <a:prstGeom prst="rect">
+            <a:avLst/>
+          </a:prstGeom>
+          <a:noFill/>
+          <a:ln/>
+        </p:spPr>
+        <p:txBody>
+          <a:bodyPr wrap="square" lIns="0" tIns="0" rIns="0" bIns="0" rtlCol="0" anchor="ctr"/>
+          <a:lstStyle/>
+          <a:p>
+            <a:pPr algn="ctr" indent="0" marL="0">
+              <a:buNone/>
+            </a:pPr>
+            <a:r>
+              <a:rPr lang="en-US" sz="1200" b="1" dirty="0">
                 <a:solidFill>
                   <a:srgbClr val="FFFFFF"/>
+                </a:solidFill>
+                <a:latin typeface="Verdana" pitchFamily="34" charset="0"/>
+                <a:ea typeface="Verdana" pitchFamily="34" charset="-122"/>
+                <a:cs typeface="Verdana" pitchFamily="34" charset="-120"/>
+              </a:rPr>
+              <a:t>Explorer</a:t>
+            </a:r>
+            <a:endParaRPr lang="en-US" sz="1200" dirty="0"/>
+          </a:p>
+        </p:txBody>
+      </p:sp>
+      <p:sp>
+        <p:nvSpPr>
+          <p:cNvPr id="8" name="Text 6"/>
+          <p:cNvSpPr/>
+          <p:nvPr/>
+        </p:nvSpPr>
+        <p:spPr>
+          <a:xfrm>
+            <a:off x="2743200" y="1463040"/>
+            <a:ext cx="91440" cy="640080"/>
+          </a:xfrm>
+          <a:prstGeom prst="rect">
+            <a:avLst/>
+          </a:prstGeom>
+          <a:noFill/>
+          <a:ln/>
+        </p:spPr>
+        <p:txBody>
+          <a:bodyPr wrap="square" lIns="0" tIns="0" rIns="0" bIns="0" rtlCol="0" anchor="ctr"/>
+          <a:lstStyle/>
+          <a:p>
+            <a:pPr algn="ctr" indent="0" marL="0">
+              <a:buNone/>
+            </a:pPr>
+            <a:r>
+              <a:rPr lang="en-US" sz="1100" dirty="0">
+                <a:solidFill>
+                  <a:srgbClr val="8B95A5"/>
+                </a:solidFill>
+                <a:latin typeface="Verdana" pitchFamily="34" charset="0"/>
+                <a:ea typeface="Verdana" pitchFamily="34" charset="-122"/>
+                <a:cs typeface="Verdana" pitchFamily="34" charset="-120"/>
+              </a:rPr>
+              <a:t>→</a:t>
+            </a:r>
+            <a:endParaRPr lang="en-US" sz="1100" dirty="0"/>
+          </a:p>
+        </p:txBody>
+      </p:sp>
+      <p:sp>
+        <p:nvSpPr>
+          <p:cNvPr id="9" name="Shape 7"/>
+          <p:cNvSpPr/>
+          <p:nvPr/>
+        </p:nvSpPr>
+        <p:spPr>
+          <a:xfrm>
+            <a:off x="2834640" y="1463040"/>
+            <a:ext cx="1097280" cy="640080"/>
+          </a:xfrm>
+          <a:prstGeom prst="roundRect">
+            <a:avLst>
+              <a:gd name="adj" fmla="val 11429"/>
+            </a:avLst>
+          </a:prstGeom>
+          <a:solidFill>
+            <a:srgbClr val="0A2540">
+              <a:alpha val="50000"/>
+            </a:srgbClr>
+          </a:solidFill>
+          <a:ln w="12700">
+            <a:solidFill>
+              <a:srgbClr val="8B95A5"/>
+            </a:solidFill>
+            <a:prstDash val="solid"/>
+          </a:ln>
+        </p:spPr>
+      </p:sp>
+      <p:sp>
+        <p:nvSpPr>
+          <p:cNvPr id="10" name="Text 8"/>
+          <p:cNvSpPr/>
+          <p:nvPr/>
+        </p:nvSpPr>
+        <p:spPr>
+          <a:xfrm>
+            <a:off x="2834640" y="1463040"/>
+            <a:ext cx="1097280" cy="640080"/>
+          </a:xfrm>
+          <a:prstGeom prst="rect">
+            <a:avLst/>
+          </a:prstGeom>
+          <a:noFill/>
+          <a:ln/>
+        </p:spPr>
+        <p:txBody>
+          <a:bodyPr wrap="square" lIns="0" tIns="0" rIns="0" bIns="0" rtlCol="0" anchor="ctr"/>
+          <a:lstStyle/>
+          <a:p>
+            <a:pPr algn="ctr" indent="0" marL="0">
+              <a:buNone/>
+            </a:pPr>
+            <a:r>
+              <a:rPr lang="en-US" sz="1200" b="1" dirty="0">
+                <a:solidFill>
+                  <a:srgbClr val="8B95A5"/>
+                </a:solidFill>
+                <a:latin typeface="Verdana" pitchFamily="34" charset="0"/>
+                <a:ea typeface="Verdana" pitchFamily="34" charset="-122"/>
+                <a:cs typeface="Verdana" pitchFamily="34" charset="-120"/>
+              </a:rPr>
+              <a:t>Whisperer</a:t>
+            </a:r>
+            <a:endParaRPr lang="en-US" sz="1200" dirty="0"/>
+          </a:p>
+        </p:txBody>
+      </p:sp>
+      <p:sp>
+        <p:nvSpPr>
+          <p:cNvPr id="11" name="Text 9"/>
+          <p:cNvSpPr/>
+          <p:nvPr/>
+        </p:nvSpPr>
+        <p:spPr>
+          <a:xfrm>
+            <a:off x="3931920" y="1463040"/>
+            <a:ext cx="91440" cy="640080"/>
+          </a:xfrm>
+          <a:prstGeom prst="rect">
+            <a:avLst/>
+          </a:prstGeom>
+          <a:noFill/>
+          <a:ln/>
+        </p:spPr>
+        <p:txBody>
+          <a:bodyPr wrap="square" lIns="0" tIns="0" rIns="0" bIns="0" rtlCol="0" anchor="ctr"/>
+          <a:lstStyle/>
+          <a:p>
+            <a:pPr algn="ctr" indent="0" marL="0">
+              <a:buNone/>
+            </a:pPr>
+            <a:r>
+              <a:rPr lang="en-US" sz="1100" dirty="0">
+                <a:solidFill>
+                  <a:srgbClr val="8B95A5"/>
+                </a:solidFill>
+                <a:latin typeface="Verdana" pitchFamily="34" charset="0"/>
+                <a:ea typeface="Verdana" pitchFamily="34" charset="-122"/>
+                <a:cs typeface="Verdana" pitchFamily="34" charset="-120"/>
+              </a:rPr>
+              <a:t>→</a:t>
+            </a:r>
+            <a:endParaRPr lang="en-US" sz="1100" dirty="0"/>
+          </a:p>
+        </p:txBody>
+      </p:sp>
+      <p:sp>
+        <p:nvSpPr>
+          <p:cNvPr id="12" name="Shape 10"/>
+          <p:cNvSpPr/>
+          <p:nvPr/>
+        </p:nvSpPr>
+        <p:spPr>
+          <a:xfrm>
+            <a:off x="4023360" y="1463040"/>
+            <a:ext cx="1097280" cy="640080"/>
+          </a:xfrm>
+          <a:prstGeom prst="roundRect">
+            <a:avLst>
+              <a:gd name="adj" fmla="val 11429"/>
+            </a:avLst>
+          </a:prstGeom>
+          <a:solidFill>
+            <a:srgbClr val="0A2540">
+              <a:alpha val="50000"/>
+            </a:srgbClr>
+          </a:solidFill>
+          <a:ln w="12700">
+            <a:solidFill>
+              <a:srgbClr val="8B95A5"/>
+            </a:solidFill>
+            <a:prstDash val="solid"/>
+          </a:ln>
+        </p:spPr>
+      </p:sp>
+      <p:sp>
+        <p:nvSpPr>
+          <p:cNvPr id="13" name="Text 11"/>
+          <p:cNvSpPr/>
+          <p:nvPr/>
+        </p:nvSpPr>
+        <p:spPr>
+          <a:xfrm>
+            <a:off x="4023360" y="1463040"/>
+            <a:ext cx="1097280" cy="640080"/>
+          </a:xfrm>
+          <a:prstGeom prst="rect">
+            <a:avLst/>
+          </a:prstGeom>
+          <a:noFill/>
+          <a:ln/>
+        </p:spPr>
+        <p:txBody>
+          <a:bodyPr wrap="square" lIns="0" tIns="0" rIns="0" bIns="0" rtlCol="0" anchor="ctr"/>
+          <a:lstStyle/>
+          <a:p>
+            <a:pPr algn="ctr" indent="0" marL="0">
+              <a:buNone/>
+            </a:pPr>
+            <a:r>
+              <a:rPr lang="en-US" sz="1200" b="1" dirty="0">
+                <a:solidFill>
+                  <a:srgbClr val="8B95A5"/>
+                </a:solidFill>
+                <a:latin typeface="Verdana" pitchFamily="34" charset="0"/>
+                <a:ea typeface="Verdana" pitchFamily="34" charset="-122"/>
+                <a:cs typeface="Verdana" pitchFamily="34" charset="-120"/>
+              </a:rPr>
+              <a:t>Strategist</a:t>
+            </a:r>
+            <a:endParaRPr lang="en-US" sz="1200" dirty="0"/>
+          </a:p>
+        </p:txBody>
+      </p:sp>
+      <p:sp>
+        <p:nvSpPr>
+          <p:cNvPr id="14" name="Text 12"/>
+          <p:cNvSpPr/>
+          <p:nvPr/>
+        </p:nvSpPr>
+        <p:spPr>
+          <a:xfrm>
+            <a:off x="5120640" y="1463040"/>
+            <a:ext cx="91440" cy="640080"/>
+          </a:xfrm>
+          <a:prstGeom prst="rect">
+            <a:avLst/>
+          </a:prstGeom>
+          <a:noFill/>
+          <a:ln/>
+        </p:spPr>
+        <p:txBody>
+          <a:bodyPr wrap="square" lIns="0" tIns="0" rIns="0" bIns="0" rtlCol="0" anchor="ctr"/>
+          <a:lstStyle/>
+          <a:p>
+            <a:pPr algn="ctr" indent="0" marL="0">
+              <a:buNone/>
+            </a:pPr>
+            <a:r>
+              <a:rPr lang="en-US" sz="1100" dirty="0">
+                <a:solidFill>
+                  <a:srgbClr val="8B95A5"/>
+                </a:solidFill>
+                <a:latin typeface="Verdana" pitchFamily="34" charset="0"/>
+                <a:ea typeface="Verdana" pitchFamily="34" charset="-122"/>
+                <a:cs typeface="Verdana" pitchFamily="34" charset="-120"/>
+              </a:rPr>
+              <a:t>→</a:t>
+            </a:r>
+            <a:endParaRPr lang="en-US" sz="1100" dirty="0"/>
+          </a:p>
+        </p:txBody>
+      </p:sp>
+      <p:sp>
+        <p:nvSpPr>
+          <p:cNvPr id="15" name="Shape 13"/>
+          <p:cNvSpPr/>
+          <p:nvPr/>
+        </p:nvSpPr>
+        <p:spPr>
+          <a:xfrm>
+            <a:off x="5212080" y="1463040"/>
+            <a:ext cx="1097280" cy="640080"/>
+          </a:xfrm>
+          <a:prstGeom prst="roundRect">
+            <a:avLst>
+              <a:gd name="adj" fmla="val 11429"/>
+            </a:avLst>
+          </a:prstGeom>
+          <a:solidFill>
+            <a:srgbClr val="0A2540">
+              <a:alpha val="50000"/>
+            </a:srgbClr>
+          </a:solidFill>
+          <a:ln w="12700">
+            <a:solidFill>
+              <a:srgbClr val="8B95A5"/>
+            </a:solidFill>
+            <a:prstDash val="solid"/>
+          </a:ln>
+        </p:spPr>
+      </p:sp>
+      <p:sp>
+        <p:nvSpPr>
+          <p:cNvPr id="16" name="Text 14"/>
+          <p:cNvSpPr/>
+          <p:nvPr/>
+        </p:nvSpPr>
+        <p:spPr>
+          <a:xfrm>
+            <a:off x="5212080" y="1463040"/>
+            <a:ext cx="1097280" cy="640080"/>
+          </a:xfrm>
+          <a:prstGeom prst="rect">
+            <a:avLst/>
+          </a:prstGeom>
+          <a:noFill/>
+          <a:ln/>
+        </p:spPr>
+        <p:txBody>
+          <a:bodyPr wrap="square" lIns="0" tIns="0" rIns="0" bIns="0" rtlCol="0" anchor="ctr"/>
+          <a:lstStyle/>
+          <a:p>
+            <a:pPr algn="ctr" indent="0" marL="0">
+              <a:buNone/>
+            </a:pPr>
+            <a:r>
+              <a:rPr lang="en-US" sz="1200" b="1" dirty="0">
+                <a:solidFill>
+                  <a:srgbClr val="8B95A5"/>
+                </a:solidFill>
+                <a:latin typeface="Verdana" pitchFamily="34" charset="0"/>
+                <a:ea typeface="Verdana" pitchFamily="34" charset="-122"/>
+                <a:cs typeface="Verdana" pitchFamily="34" charset="-120"/>
+              </a:rPr>
+              <a:t>Operator</a:t>
+            </a:r>
+            <a:endParaRPr lang="en-US" sz="1200" dirty="0"/>
+          </a:p>
+        </p:txBody>
+      </p:sp>
+      <p:sp>
+        <p:nvSpPr>
+          <p:cNvPr id="17" name="Text 15"/>
+          <p:cNvSpPr/>
+          <p:nvPr/>
+        </p:nvSpPr>
+        <p:spPr>
+          <a:xfrm>
+            <a:off x="6309360" y="1463040"/>
+            <a:ext cx="91440" cy="640080"/>
+          </a:xfrm>
+          <a:prstGeom prst="rect">
+            <a:avLst/>
+          </a:prstGeom>
+          <a:noFill/>
+          <a:ln/>
+        </p:spPr>
+        <p:txBody>
+          <a:bodyPr wrap="square" lIns="0" tIns="0" rIns="0" bIns="0" rtlCol="0" anchor="ctr"/>
+          <a:lstStyle/>
+          <a:p>
+            <a:pPr algn="ctr" indent="0" marL="0">
+              <a:buNone/>
+            </a:pPr>
+            <a:r>
+              <a:rPr lang="en-US" sz="1100" dirty="0">
+                <a:solidFill>
+                  <a:srgbClr val="8B95A5"/>
+                </a:solidFill>
+                <a:latin typeface="Verdana" pitchFamily="34" charset="0"/>
+                <a:ea typeface="Verdana" pitchFamily="34" charset="-122"/>
+                <a:cs typeface="Verdana" pitchFamily="34" charset="-120"/>
+              </a:rPr>
+              <a:t>→</a:t>
+            </a:r>
+            <a:endParaRPr lang="en-US" sz="1100" dirty="0"/>
+          </a:p>
+        </p:txBody>
+      </p:sp>
+      <p:sp>
+        <p:nvSpPr>
+          <p:cNvPr id="18" name="Shape 16"/>
+          <p:cNvSpPr/>
+          <p:nvPr/>
+        </p:nvSpPr>
+        <p:spPr>
+          <a:xfrm>
+            <a:off x="6400800" y="1463040"/>
+            <a:ext cx="1097280" cy="640080"/>
+          </a:xfrm>
+          <a:prstGeom prst="roundRect">
+            <a:avLst>
+              <a:gd name="adj" fmla="val 11429"/>
+            </a:avLst>
+          </a:prstGeom>
+          <a:solidFill>
+            <a:srgbClr val="0A2540">
+              <a:alpha val="50000"/>
+            </a:srgbClr>
+          </a:solidFill>
+          <a:ln w="25400">
+            <a:solidFill>
+              <a:srgbClr val="635BFF"/>
+            </a:solidFill>
+            <a:prstDash val="solid"/>
+          </a:ln>
+        </p:spPr>
+      </p:sp>
+      <p:sp>
+        <p:nvSpPr>
+          <p:cNvPr id="19" name="Text 17"/>
+          <p:cNvSpPr/>
+          <p:nvPr/>
+        </p:nvSpPr>
+        <p:spPr>
+          <a:xfrm>
+            <a:off x="6400800" y="1463040"/>
+            <a:ext cx="1097280" cy="640080"/>
+          </a:xfrm>
+          <a:prstGeom prst="rect">
+            <a:avLst/>
+          </a:prstGeom>
+          <a:noFill/>
+          <a:ln/>
+        </p:spPr>
+        <p:txBody>
+          <a:bodyPr wrap="square" lIns="0" tIns="0" rIns="0" bIns="0" rtlCol="0" anchor="ctr"/>
+          <a:lstStyle/>
+          <a:p>
+            <a:pPr algn="ctr" indent="0" marL="0">
+              <a:buNone/>
+            </a:pPr>
+            <a:r>
+              <a:rPr lang="en-US" sz="1200" b="1" dirty="0">
+                <a:solidFill>
+                  <a:srgbClr val="635BFF"/>
+                </a:solidFill>
+                <a:latin typeface="Verdana" pitchFamily="34" charset="0"/>
+                <a:ea typeface="Verdana" pitchFamily="34" charset="-122"/>
+                <a:cs typeface="Verdana" pitchFamily="34" charset="-120"/>
+              </a:rPr>
+              <a:t>Orchestrator</a:t>
+            </a:r>
+            <a:endParaRPr lang="en-US" sz="1200" dirty="0"/>
+          </a:p>
+        </p:txBody>
+      </p:sp>
+      <p:sp>
+        <p:nvSpPr>
+          <p:cNvPr id="20" name="Text 18"/>
+          <p:cNvSpPr/>
+          <p:nvPr/>
+        </p:nvSpPr>
+        <p:spPr>
+          <a:xfrm>
+            <a:off x="7498080" y="1463040"/>
+            <a:ext cx="91440" cy="640080"/>
+          </a:xfrm>
+          <a:prstGeom prst="rect">
+            <a:avLst/>
+          </a:prstGeom>
+          <a:noFill/>
+          <a:ln/>
+        </p:spPr>
+        <p:txBody>
+          <a:bodyPr wrap="square" lIns="0" tIns="0" rIns="0" bIns="0" rtlCol="0" anchor="ctr"/>
+          <a:lstStyle/>
+          <a:p>
+            <a:pPr algn="ctr" indent="0" marL="0">
+              <a:buNone/>
+            </a:pPr>
+            <a:r>
+              <a:rPr lang="en-US" sz="1100" dirty="0">
+                <a:solidFill>
+                  <a:srgbClr val="8B95A5"/>
+                </a:solidFill>
+                <a:latin typeface="Verdana" pitchFamily="34" charset="0"/>
+                <a:ea typeface="Verdana" pitchFamily="34" charset="-122"/>
+                <a:cs typeface="Verdana" pitchFamily="34" charset="-120"/>
+              </a:rPr>
+              <a:t>→</a:t>
+            </a:r>
+            <a:endParaRPr lang="en-US" sz="1100" dirty="0"/>
+          </a:p>
+        </p:txBody>
+      </p:sp>
+      <p:sp>
+        <p:nvSpPr>
+          <p:cNvPr id="21" name="Shape 19"/>
+          <p:cNvSpPr/>
+          <p:nvPr/>
+        </p:nvSpPr>
+        <p:spPr>
+          <a:xfrm>
+            <a:off x="7589520" y="1463040"/>
+            <a:ext cx="1097280" cy="640080"/>
+          </a:xfrm>
+          <a:prstGeom prst="roundRect">
+            <a:avLst>
+              <a:gd name="adj" fmla="val 11429"/>
+            </a:avLst>
+          </a:prstGeom>
+          <a:solidFill>
+            <a:srgbClr val="0A2540">
+              <a:alpha val="50000"/>
+            </a:srgbClr>
+          </a:solidFill>
+          <a:ln w="12700">
+            <a:solidFill>
+              <a:srgbClr val="8B95A5"/>
+            </a:solidFill>
+            <a:prstDash val="dash"/>
+          </a:ln>
+        </p:spPr>
+      </p:sp>
+      <p:sp>
+        <p:nvSpPr>
+          <p:cNvPr id="22" name="Text 20"/>
+          <p:cNvSpPr/>
+          <p:nvPr/>
+        </p:nvSpPr>
+        <p:spPr>
+          <a:xfrm>
+            <a:off x="7589520" y="1463040"/>
+            <a:ext cx="1097280" cy="640080"/>
+          </a:xfrm>
+          <a:prstGeom prst="rect">
+            <a:avLst/>
+          </a:prstGeom>
+          <a:noFill/>
+          <a:ln/>
+        </p:spPr>
+        <p:txBody>
+          <a:bodyPr wrap="square" lIns="0" tIns="0" rIns="0" bIns="0" rtlCol="0" anchor="ctr"/>
+          <a:lstStyle/>
+          <a:p>
+            <a:pPr algn="ctr" indent="0" marL="0">
+              <a:buNone/>
+            </a:pPr>
+            <a:r>
+              <a:rPr lang="en-US" sz="1200" b="1" dirty="0">
+                <a:solidFill>
+                  <a:srgbClr val="8B95A5"/>
+                </a:solidFill>
+                <a:latin typeface="Verdana" pitchFamily="34" charset="0"/>
+                <a:ea typeface="Verdana" pitchFamily="34" charset="-122"/>
+                <a:cs typeface="Verdana" pitchFamily="34" charset="-120"/>
+              </a:rPr>
+              <a:t>Builder</a:t>
+            </a:r>
+            <a:endParaRPr lang="en-US" sz="1200" dirty="0"/>
+          </a:p>
+        </p:txBody>
+      </p:sp>
+      <p:sp>
+        <p:nvSpPr>
+          <p:cNvPr id="23" name="Text 21"/>
+          <p:cNvSpPr/>
+          <p:nvPr/>
+        </p:nvSpPr>
+        <p:spPr>
+          <a:xfrm>
+            <a:off x="457200" y="2468880"/>
+            <a:ext cx="4114800" cy="731520"/>
+          </a:xfrm>
+          <a:prstGeom prst="rect">
+            <a:avLst/>
+          </a:prstGeom>
+          <a:noFill/>
+          <a:ln/>
+        </p:spPr>
+        <p:txBody>
+          <a:bodyPr wrap="square" lIns="0" tIns="0" rIns="0" bIns="0" rtlCol="0" anchor="t"/>
+          <a:lstStyle/>
+          <a:p>
+            <a:pPr algn="ctr" indent="0" marL="0">
+              <a:buNone/>
+            </a:pPr>
+            <a:r>
+              <a:rPr lang="en-US" sz="2800" b="1" dirty="0">
+                <a:solidFill>
+                  <a:srgbClr val="635BFF"/>
                 </a:solidFill>
                 <a:latin typeface="Georgia" pitchFamily="34" charset="0"/>
                 <a:ea typeface="Georgia" pitchFamily="34" charset="-122"/>
                 <a:cs typeface="Georgia" pitchFamily="34" charset="-120"/>
               </a:rPr>
-              <a:t>Two sessions.</a:t>
-            </a:r>
-            <a:endParaRPr lang="en-US" sz="4400" dirty="0"/>
-          </a:p>
+              <a:t>Most of us are here.</a:t>
+            </a:r>
+            <a:endParaRPr lang="en-US" sz="2800" dirty="0"/>
+          </a:p>
+        </p:txBody>
+      </p:sp>
+      <p:sp>
+        <p:nvSpPr>
+          <p:cNvPr id="24" name="Text 22"/>
+          <p:cNvSpPr/>
+          <p:nvPr/>
+        </p:nvSpPr>
+        <p:spPr>
+          <a:xfrm>
+            <a:off x="4572000" y="2468880"/>
+            <a:ext cx="4114800" cy="731520"/>
+          </a:xfrm>
+          <a:prstGeom prst="rect">
+            <a:avLst/>
+          </a:prstGeom>
+          <a:noFill/>
+          <a:ln/>
+        </p:spPr>
+        <p:txBody>
+          <a:bodyPr wrap="square" lIns="0" tIns="0" rIns="0" bIns="0" rtlCol="0" anchor="t"/>
+          <a:lstStyle/>
           <a:p>
             <a:pPr algn="ctr" indent="0" marL="0">
               <a:buNone/>
             </a:pPr>
             <a:r>
-              <a:rPr lang="en-US" sz="4400" b="1" dirty="0">
-                <a:solidFill>
-                  <a:srgbClr val="FFFFFF"/>
+              <a:rPr lang="en-US" sz="2800" b="1" dirty="0">
+                <a:solidFill>
+                  <a:srgbClr val="635BFF"/>
                 </a:solidFill>
                 <a:latin typeface="Georgia" pitchFamily="34" charset="0"/>
                 <a:ea typeface="Georgia" pitchFamily="34" charset="-122"/>
                 <a:cs typeface="Georgia" pitchFamily="34" charset="-120"/>
               </a:rPr>
-              <a:t>One hour each.</a:t>
-            </a:r>
-            <a:endParaRPr lang="en-US" sz="4400" dirty="0"/>
-          </a:p>
-        </p:txBody>
-      </p:sp>
-      <p:sp>
-        <p:nvSpPr>
-          <p:cNvPr id="4" name="Text 2"/>
-          <p:cNvSpPr/>
-          <p:nvPr/>
-        </p:nvSpPr>
-        <p:spPr>
-          <a:xfrm>
-            <a:off x="1371600" y="3657600"/>
-            <a:ext cx="6400800" cy="731520"/>
-          </a:xfrm>
-          <a:prstGeom prst="rect">
-            <a:avLst/>
-          </a:prstGeom>
-          <a:noFill/>
-          <a:ln/>
-        </p:spPr>
-        <p:txBody>
-          <a:bodyPr wrap="square" lIns="0" tIns="0" rIns="0" bIns="0" rtlCol="0" anchor="t"/>
-          <a:lstStyle/>
-          <a:p>
-            <a:pPr algn="ctr" indent="0" marL="0">
-              <a:buNone/>
-            </a:pPr>
-            <a:r>
-              <a:rPr lang="en-US" sz="2800" dirty="0">
-                <a:solidFill>
-                  <a:srgbClr val="8B95A5"/>
-                </a:solidFill>
-                <a:latin typeface="Verdana" pitchFamily="34" charset="0"/>
-                <a:ea typeface="Verdana" pitchFamily="34" charset="-122"/>
-                <a:cs typeface="Verdana" pitchFamily="34" charset="-120"/>
-              </a:rPr>
-              <a:t>Bring your laptop.</a:t>
+              <a:t>The AI Academy takes you here.</a:t>
             </a:r>
             <a:endParaRPr lang="en-US" sz="2800" dirty="0"/>
           </a:p>
@@ -3713,8 +4095,8 @@
         </p:nvSpPr>
         <p:spPr>
           <a:xfrm>
-            <a:off x="731520" y="1280160"/>
-            <a:ext cx="731520" cy="822960"/>
+            <a:off x="914400" y="1097280"/>
+            <a:ext cx="7315200" cy="2560320"/>
           </a:xfrm>
           <a:prstGeom prst="rect">
             <a:avLst/>
@@ -3730,17 +4112,34 @@
               <a:buNone/>
             </a:pPr>
             <a:r>
-              <a:rPr lang="en-US" sz="3600" b="1" dirty="0">
-                <a:solidFill>
-                  <a:srgbClr val="635BFF"/>
+              <a:rPr lang="en-US" sz="4400" b="1" dirty="0">
+                <a:solidFill>
+                  <a:srgbClr val="FFFFFF"/>
                 </a:solidFill>
                 <a:latin typeface="Georgia" pitchFamily="34" charset="0"/>
                 <a:ea typeface="Georgia" pitchFamily="34" charset="-122"/>
                 <a:cs typeface="Georgia" pitchFamily="34" charset="-120"/>
               </a:rPr>
-              <a:t>1</a:t>
-            </a:r>
-            <a:endParaRPr lang="en-US" sz="3600" dirty="0"/>
+              <a:t>Two sessions.</a:t>
+            </a:r>
+            <a:endParaRPr lang="en-US" sz="4400" dirty="0"/>
+          </a:p>
+          <a:p>
+            <a:pPr algn="ctr" indent="0" marL="0">
+              <a:buNone/>
+            </a:pPr>
+            <a:r>
+              <a:rPr lang="en-US" sz="4400" b="1" dirty="0">
+                <a:solidFill>
+                  <a:srgbClr val="FFFFFF"/>
+                </a:solidFill>
+                <a:latin typeface="Georgia" pitchFamily="34" charset="0"/>
+                <a:ea typeface="Georgia" pitchFamily="34" charset="-122"/>
+                <a:cs typeface="Georgia" pitchFamily="34" charset="-120"/>
+              </a:rPr>
+              <a:t>One hour each.</a:t>
+            </a:r>
+            <a:endParaRPr lang="en-US" sz="4400" dirty="0"/>
           </a:p>
         </p:txBody>
       </p:sp>
@@ -3752,8 +4151,8 @@
         </p:nvSpPr>
         <p:spPr>
           <a:xfrm>
-            <a:off x="1645920" y="1280160"/>
-            <a:ext cx="3200400" cy="411480"/>
+            <a:off x="1371600" y="3657600"/>
+            <a:ext cx="6400800" cy="731520"/>
           </a:xfrm>
           <a:prstGeom prst="rect">
             <a:avLst/>
@@ -3762,14 +4161,14 @@
           <a:ln/>
         </p:spPr>
         <p:txBody>
-          <a:bodyPr wrap="square" lIns="0" tIns="0" rIns="0" bIns="0" rtlCol="0" anchor="b"/>
-          <a:lstStyle/>
-          <a:p>
-            <a:pPr indent="0" marL="0">
-              <a:buNone/>
-            </a:pPr>
-            <a:r>
-              <a:rPr lang="en-US" sz="1800" b="1" dirty="0">
+          <a:bodyPr wrap="square" lIns="0" tIns="0" rIns="0" bIns="0" rtlCol="0" anchor="t"/>
+          <a:lstStyle/>
+          <a:p>
+            <a:pPr algn="ctr" indent="0" marL="0">
+              <a:buNone/>
+            </a:pPr>
+            <a:r>
+              <a:rPr lang="en-US" sz="2800" dirty="0">
                 <a:solidFill>
                   <a:srgbClr val="8B95A5"/>
                 </a:solidFill>
@@ -3777,165 +4176,9 @@
                 <a:ea typeface="Verdana" pitchFamily="34" charset="-122"/>
                 <a:cs typeface="Verdana" pitchFamily="34" charset="-120"/>
               </a:rPr>
-              <a:t>Explorer → Strategist</a:t>
-            </a:r>
-            <a:endParaRPr lang="en-US" sz="1800" dirty="0"/>
-          </a:p>
-        </p:txBody>
-      </p:sp>
-      <p:sp>
-        <p:nvSpPr>
-          <p:cNvPr id="5" name="Text 3"/>
-          <p:cNvSpPr/>
-          <p:nvPr/>
-        </p:nvSpPr>
-        <p:spPr>
-          <a:xfrm>
-            <a:off x="1645920" y="1691640"/>
-            <a:ext cx="5486400" cy="411480"/>
-          </a:xfrm>
-          <a:prstGeom prst="rect">
-            <a:avLst/>
-          </a:prstGeom>
-          <a:noFill/>
-          <a:ln/>
-        </p:spPr>
-        <p:txBody>
-          <a:bodyPr wrap="square" lIns="0" tIns="0" rIns="0" bIns="0" rtlCol="0" anchor="t"/>
-          <a:lstStyle/>
-          <a:p>
-            <a:pPr indent="0" marL="0">
-              <a:buNone/>
-            </a:pPr>
-            <a:r>
-              <a:rPr lang="en-US" sz="2400" b="1" dirty="0">
-                <a:solidFill>
-                  <a:srgbClr val="FFFFFF"/>
-                </a:solidFill>
-                <a:latin typeface="Georgia" pitchFamily="34" charset="0"/>
-                <a:ea typeface="Georgia" pitchFamily="34" charset="-122"/>
-                <a:cs typeface="Georgia" pitchFamily="34" charset="-120"/>
-              </a:rPr>
-              <a:t>From vague prompts to a persistent AI playbook</a:t>
-            </a:r>
-            <a:endParaRPr lang="en-US" sz="2400" dirty="0"/>
-          </a:p>
-        </p:txBody>
-      </p:sp>
-      <p:sp>
-        <p:nvSpPr>
-          <p:cNvPr id="6" name="Text 4"/>
-          <p:cNvSpPr/>
-          <p:nvPr/>
-        </p:nvSpPr>
-        <p:spPr>
-          <a:xfrm>
-            <a:off x="731520" y="2651760"/>
-            <a:ext cx="731520" cy="822960"/>
-          </a:xfrm>
-          <a:prstGeom prst="rect">
-            <a:avLst/>
-          </a:prstGeom>
-          <a:noFill/>
-          <a:ln/>
-        </p:spPr>
-        <p:txBody>
-          <a:bodyPr wrap="square" lIns="0" tIns="0" rIns="0" bIns="0" rtlCol="0" anchor="ctr"/>
-          <a:lstStyle/>
-          <a:p>
-            <a:pPr algn="ctr" indent="0" marL="0">
-              <a:buNone/>
-            </a:pPr>
-            <a:r>
-              <a:rPr lang="en-US" sz="3600" b="1" dirty="0">
-                <a:solidFill>
-                  <a:srgbClr val="635BFF"/>
-                </a:solidFill>
-                <a:latin typeface="Georgia" pitchFamily="34" charset="0"/>
-                <a:ea typeface="Georgia" pitchFamily="34" charset="-122"/>
-                <a:cs typeface="Georgia" pitchFamily="34" charset="-120"/>
-              </a:rPr>
-              <a:t>2</a:t>
-            </a:r>
-            <a:endParaRPr lang="en-US" sz="3600" dirty="0"/>
-          </a:p>
-        </p:txBody>
-      </p:sp>
-      <p:sp>
-        <p:nvSpPr>
-          <p:cNvPr id="7" name="Text 5"/>
-          <p:cNvSpPr/>
-          <p:nvPr/>
-        </p:nvSpPr>
-        <p:spPr>
-          <a:xfrm>
-            <a:off x="1645920" y="2651760"/>
-            <a:ext cx="3200400" cy="411480"/>
-          </a:xfrm>
-          <a:prstGeom prst="rect">
-            <a:avLst/>
-          </a:prstGeom>
-          <a:noFill/>
-          <a:ln/>
-        </p:spPr>
-        <p:txBody>
-          <a:bodyPr wrap="square" lIns="0" tIns="0" rIns="0" bIns="0" rtlCol="0" anchor="b"/>
-          <a:lstStyle/>
-          <a:p>
-            <a:pPr indent="0" marL="0">
-              <a:buNone/>
-            </a:pPr>
-            <a:r>
-              <a:rPr lang="en-US" sz="1800" b="1" dirty="0">
-                <a:solidFill>
-                  <a:srgbClr val="8B95A5"/>
-                </a:solidFill>
-                <a:latin typeface="Verdana" pitchFamily="34" charset="0"/>
-                <a:ea typeface="Verdana" pitchFamily="34" charset="-122"/>
-                <a:cs typeface="Verdana" pitchFamily="34" charset="-120"/>
-              </a:rPr>
-              <a:t>Strategist → Orchestrator</a:t>
-            </a:r>
-            <a:endParaRPr lang="en-US" sz="1800" dirty="0"/>
-          </a:p>
-        </p:txBody>
-      </p:sp>
-      <p:sp>
-        <p:nvSpPr>
-          <p:cNvPr id="8" name="Text 6"/>
-          <p:cNvSpPr/>
-          <p:nvPr/>
-        </p:nvSpPr>
-        <p:spPr>
-          <a:xfrm>
-            <a:off x="1645920" y="3063240"/>
-            <a:ext cx="5486400" cy="411480"/>
-          </a:xfrm>
-          <a:prstGeom prst="rect">
-            <a:avLst/>
-          </a:prstGeom>
-          <a:noFill/>
-          <a:ln/>
-        </p:spPr>
-        <p:txBody>
-          <a:bodyPr wrap="square" lIns="0" tIns="0" rIns="0" bIns="0" rtlCol="0" anchor="t"/>
-          <a:lstStyle/>
-          <a:p>
-            <a:pPr indent="0" marL="0">
-              <a:buNone/>
-            </a:pPr>
-            <a:r>
-              <a:rPr lang="en-US" sz="2400" b="1" dirty="0">
-                <a:solidFill>
-                  <a:srgbClr val="FFFFFF"/>
-                </a:solidFill>
-                <a:latin typeface="Georgia" pitchFamily="34" charset="0"/>
-                <a:ea typeface="Georgia" pitchFamily="34" charset="-122"/>
-                <a:cs typeface="Georgia" pitchFamily="34" charset="-120"/>
-              </a:rPr>
-              <a:t>From doing the work to directing AI teams</a:t>
-            </a:r>
-            <a:endParaRPr lang="en-US" sz="2400" dirty="0"/>
+              <a:t>Bring your laptop.</a:t>
+            </a:r>
+            <a:endParaRPr lang="en-US" sz="2800" dirty="0"/>
           </a:p>
         </p:txBody>
       </p:sp>

</xml_diff>

<commit_message>
Homogenize spectrum blocks across all decks
Standardize the Skeptic→Builder spectrum component across 5 decks
(7 instances) for consistent sizing, positioning, and styling:
- Widen boxes (1.2→1.3") and tighten gaps (0.1→0.08") to fix text clipping
- Reduce label font to 11pt with fit:shrink for overflow protection
- Unify Y positions: 1.6 (two-caption) / 2.2 (single/no caption)
- Consistent fill, border, dashed Builder, arrows, bold labels, caption style

Co-Authored-By: Claude Opus 4.6 <noreply@anthropic.com>
</commit_message>
<xml_diff>
--- a/decks/ai-academy-pitch/ai-academy-pitch.pptx
+++ b/decks/ai-academy-pitch/ai-academy-pitch.pptx
@@ -3255,8 +3255,8 @@
         </p:nvSpPr>
         <p:spPr>
           <a:xfrm>
-            <a:off x="457200" y="1463040"/>
-            <a:ext cx="1097280" cy="640080"/>
+            <a:off x="192024" y="1463040"/>
+            <a:ext cx="1188720" cy="640080"/>
           </a:xfrm>
           <a:prstGeom prst="roundRect">
             <a:avLst>
@@ -3268,7 +3268,7 @@
               <a:alpha val="50000"/>
             </a:srgbClr>
           </a:solidFill>
-          <a:ln w="12700">
+          <a:ln w="19050">
             <a:solidFill>
               <a:srgbClr val="8B95A5"/>
             </a:solidFill>
@@ -3284,8 +3284,8 @@
         </p:nvSpPr>
         <p:spPr>
           <a:xfrm>
-            <a:off x="457200" y="1463040"/>
-            <a:ext cx="1097280" cy="640080"/>
+            <a:off x="192024" y="1463040"/>
+            <a:ext cx="1188720" cy="640080"/>
           </a:xfrm>
           <a:prstGeom prst="rect">
             <a:avLst/>
@@ -3294,14 +3294,16 @@
           <a:ln/>
         </p:spPr>
         <p:txBody>
-          <a:bodyPr wrap="square" lIns="0" tIns="0" rIns="0" bIns="0" rtlCol="0" anchor="ctr"/>
+          <a:bodyPr wrap="square" lIns="0" tIns="0" rIns="0" bIns="0" rtlCol="0" anchor="ctr">
+            <a:normAutofit/>
+          </a:bodyPr>
           <a:lstStyle/>
           <a:p>
             <a:pPr algn="ctr" indent="0" marL="0">
               <a:buNone/>
             </a:pPr>
             <a:r>
-              <a:rPr lang="en-US" sz="1200" b="1" dirty="0">
+              <a:rPr lang="en-US" sz="1100" b="1" dirty="0">
                 <a:solidFill>
                   <a:srgbClr val="8B95A5"/>
                 </a:solidFill>
@@ -3311,7 +3313,7 @@
               </a:rPr>
               <a:t>Skeptic</a:t>
             </a:r>
-            <a:endParaRPr lang="en-US" sz="1200" dirty="0"/>
+            <a:endParaRPr lang="en-US" sz="1100" dirty="0"/>
           </a:p>
         </p:txBody>
       </p:sp>
@@ -3323,8 +3325,8 @@
         </p:nvSpPr>
         <p:spPr>
           <a:xfrm>
-            <a:off x="1554480" y="1463040"/>
-            <a:ext cx="91440" cy="640080"/>
+            <a:off x="1380744" y="1463040"/>
+            <a:ext cx="73152" cy="640080"/>
           </a:xfrm>
           <a:prstGeom prst="rect">
             <a:avLst/>
@@ -3362,8 +3364,8 @@
         </p:nvSpPr>
         <p:spPr>
           <a:xfrm>
-            <a:off x="1645920" y="1463040"/>
-            <a:ext cx="1097280" cy="640080"/>
+            <a:off x="1453896" y="1463040"/>
+            <a:ext cx="1188720" cy="640080"/>
           </a:xfrm>
           <a:prstGeom prst="roundRect">
             <a:avLst>
@@ -3373,7 +3375,7 @@
           <a:solidFill>
             <a:srgbClr val="635BFF"/>
           </a:solidFill>
-          <a:ln w="25400">
+          <a:ln w="19050">
             <a:solidFill>
               <a:srgbClr val="635BFF"/>
             </a:solidFill>
@@ -3389,8 +3391,8 @@
         </p:nvSpPr>
         <p:spPr>
           <a:xfrm>
-            <a:off x="1645920" y="1463040"/>
-            <a:ext cx="1097280" cy="640080"/>
+            <a:off x="1453896" y="1463040"/>
+            <a:ext cx="1188720" cy="640080"/>
           </a:xfrm>
           <a:prstGeom prst="rect">
             <a:avLst/>
@@ -3399,14 +3401,16 @@
           <a:ln/>
         </p:spPr>
         <p:txBody>
-          <a:bodyPr wrap="square" lIns="0" tIns="0" rIns="0" bIns="0" rtlCol="0" anchor="ctr"/>
+          <a:bodyPr wrap="square" lIns="0" tIns="0" rIns="0" bIns="0" rtlCol="0" anchor="ctr">
+            <a:normAutofit/>
+          </a:bodyPr>
           <a:lstStyle/>
           <a:p>
             <a:pPr algn="ctr" indent="0" marL="0">
               <a:buNone/>
             </a:pPr>
             <a:r>
-              <a:rPr lang="en-US" sz="1200" b="1" dirty="0">
+              <a:rPr lang="en-US" sz="1100" b="1" dirty="0">
                 <a:solidFill>
                   <a:srgbClr val="FFFFFF"/>
                 </a:solidFill>
@@ -3416,7 +3420,7 @@
               </a:rPr>
               <a:t>Explorer</a:t>
             </a:r>
-            <a:endParaRPr lang="en-US" sz="1200" dirty="0"/>
+            <a:endParaRPr lang="en-US" sz="1100" dirty="0"/>
           </a:p>
         </p:txBody>
       </p:sp>
@@ -3428,8 +3432,8 @@
         </p:nvSpPr>
         <p:spPr>
           <a:xfrm>
-            <a:off x="2743200" y="1463040"/>
-            <a:ext cx="91440" cy="640080"/>
+            <a:off x="2642616" y="1463040"/>
+            <a:ext cx="73152" cy="640080"/>
           </a:xfrm>
           <a:prstGeom prst="rect">
             <a:avLst/>
@@ -3467,8 +3471,8 @@
         </p:nvSpPr>
         <p:spPr>
           <a:xfrm>
-            <a:off x="2834640" y="1463040"/>
-            <a:ext cx="1097280" cy="640080"/>
+            <a:off x="2715768" y="1463040"/>
+            <a:ext cx="1188720" cy="640080"/>
           </a:xfrm>
           <a:prstGeom prst="roundRect">
             <a:avLst>
@@ -3480,7 +3484,7 @@
               <a:alpha val="50000"/>
             </a:srgbClr>
           </a:solidFill>
-          <a:ln w="12700">
+          <a:ln w="19050">
             <a:solidFill>
               <a:srgbClr val="8B95A5"/>
             </a:solidFill>
@@ -3496,8 +3500,8 @@
         </p:nvSpPr>
         <p:spPr>
           <a:xfrm>
-            <a:off x="2834640" y="1463040"/>
-            <a:ext cx="1097280" cy="640080"/>
+            <a:off x="2715768" y="1463040"/>
+            <a:ext cx="1188720" cy="640080"/>
           </a:xfrm>
           <a:prstGeom prst="rect">
             <a:avLst/>
@@ -3506,14 +3510,16 @@
           <a:ln/>
         </p:spPr>
         <p:txBody>
-          <a:bodyPr wrap="square" lIns="0" tIns="0" rIns="0" bIns="0" rtlCol="0" anchor="ctr"/>
+          <a:bodyPr wrap="square" lIns="0" tIns="0" rIns="0" bIns="0" rtlCol="0" anchor="ctr">
+            <a:normAutofit/>
+          </a:bodyPr>
           <a:lstStyle/>
           <a:p>
             <a:pPr algn="ctr" indent="0" marL="0">
               <a:buNone/>
             </a:pPr>
             <a:r>
-              <a:rPr lang="en-US" sz="1200" b="1" dirty="0">
+              <a:rPr lang="en-US" sz="1100" b="1" dirty="0">
                 <a:solidFill>
                   <a:srgbClr val="8B95A5"/>
                 </a:solidFill>
@@ -3523,7 +3529,7 @@
               </a:rPr>
               <a:t>Whisperer</a:t>
             </a:r>
-            <a:endParaRPr lang="en-US" sz="1200" dirty="0"/>
+            <a:endParaRPr lang="en-US" sz="1100" dirty="0"/>
           </a:p>
         </p:txBody>
       </p:sp>
@@ -3535,8 +3541,8 @@
         </p:nvSpPr>
         <p:spPr>
           <a:xfrm>
-            <a:off x="3931920" y="1463040"/>
-            <a:ext cx="91440" cy="640080"/>
+            <a:off x="3904488" y="1463040"/>
+            <a:ext cx="73152" cy="640080"/>
           </a:xfrm>
           <a:prstGeom prst="rect">
             <a:avLst/>
@@ -3574,8 +3580,8 @@
         </p:nvSpPr>
         <p:spPr>
           <a:xfrm>
-            <a:off x="4023360" y="1463040"/>
-            <a:ext cx="1097280" cy="640080"/>
+            <a:off x="3977640" y="1463040"/>
+            <a:ext cx="1188720" cy="640080"/>
           </a:xfrm>
           <a:prstGeom prst="roundRect">
             <a:avLst>
@@ -3587,7 +3593,7 @@
               <a:alpha val="50000"/>
             </a:srgbClr>
           </a:solidFill>
-          <a:ln w="12700">
+          <a:ln w="19050">
             <a:solidFill>
               <a:srgbClr val="8B95A5"/>
             </a:solidFill>
@@ -3603,8 +3609,8 @@
         </p:nvSpPr>
         <p:spPr>
           <a:xfrm>
-            <a:off x="4023360" y="1463040"/>
-            <a:ext cx="1097280" cy="640080"/>
+            <a:off x="3977640" y="1463040"/>
+            <a:ext cx="1188720" cy="640080"/>
           </a:xfrm>
           <a:prstGeom prst="rect">
             <a:avLst/>
@@ -3613,14 +3619,16 @@
           <a:ln/>
         </p:spPr>
         <p:txBody>
-          <a:bodyPr wrap="square" lIns="0" tIns="0" rIns="0" bIns="0" rtlCol="0" anchor="ctr"/>
+          <a:bodyPr wrap="square" lIns="0" tIns="0" rIns="0" bIns="0" rtlCol="0" anchor="ctr">
+            <a:normAutofit/>
+          </a:bodyPr>
           <a:lstStyle/>
           <a:p>
             <a:pPr algn="ctr" indent="0" marL="0">
               <a:buNone/>
             </a:pPr>
             <a:r>
-              <a:rPr lang="en-US" sz="1200" b="1" dirty="0">
+              <a:rPr lang="en-US" sz="1100" b="1" dirty="0">
                 <a:solidFill>
                   <a:srgbClr val="8B95A5"/>
                 </a:solidFill>
@@ -3630,7 +3638,7 @@
               </a:rPr>
               <a:t>Strategist</a:t>
             </a:r>
-            <a:endParaRPr lang="en-US" sz="1200" dirty="0"/>
+            <a:endParaRPr lang="en-US" sz="1100" dirty="0"/>
           </a:p>
         </p:txBody>
       </p:sp>
@@ -3642,8 +3650,8 @@
         </p:nvSpPr>
         <p:spPr>
           <a:xfrm>
-            <a:off x="5120640" y="1463040"/>
-            <a:ext cx="91440" cy="640080"/>
+            <a:off x="5166360" y="1463040"/>
+            <a:ext cx="73152" cy="640080"/>
           </a:xfrm>
           <a:prstGeom prst="rect">
             <a:avLst/>
@@ -3681,8 +3689,8 @@
         </p:nvSpPr>
         <p:spPr>
           <a:xfrm>
-            <a:off x="5212080" y="1463040"/>
-            <a:ext cx="1097280" cy="640080"/>
+            <a:off x="5239512" y="1463040"/>
+            <a:ext cx="1188720" cy="640080"/>
           </a:xfrm>
           <a:prstGeom prst="roundRect">
             <a:avLst>
@@ -3694,7 +3702,7 @@
               <a:alpha val="50000"/>
             </a:srgbClr>
           </a:solidFill>
-          <a:ln w="12700">
+          <a:ln w="19050">
             <a:solidFill>
               <a:srgbClr val="8B95A5"/>
             </a:solidFill>
@@ -3710,8 +3718,8 @@
         </p:nvSpPr>
         <p:spPr>
           <a:xfrm>
-            <a:off x="5212080" y="1463040"/>
-            <a:ext cx="1097280" cy="640080"/>
+            <a:off x="5239512" y="1463040"/>
+            <a:ext cx="1188720" cy="640080"/>
           </a:xfrm>
           <a:prstGeom prst="rect">
             <a:avLst/>
@@ -3720,14 +3728,16 @@
           <a:ln/>
         </p:spPr>
         <p:txBody>
-          <a:bodyPr wrap="square" lIns="0" tIns="0" rIns="0" bIns="0" rtlCol="0" anchor="ctr"/>
+          <a:bodyPr wrap="square" lIns="0" tIns="0" rIns="0" bIns="0" rtlCol="0" anchor="ctr">
+            <a:normAutofit/>
+          </a:bodyPr>
           <a:lstStyle/>
           <a:p>
             <a:pPr algn="ctr" indent="0" marL="0">
               <a:buNone/>
             </a:pPr>
             <a:r>
-              <a:rPr lang="en-US" sz="1200" b="1" dirty="0">
+              <a:rPr lang="en-US" sz="1100" b="1" dirty="0">
                 <a:solidFill>
                   <a:srgbClr val="8B95A5"/>
                 </a:solidFill>
@@ -3737,7 +3747,7 @@
               </a:rPr>
               <a:t>Operator</a:t>
             </a:r>
-            <a:endParaRPr lang="en-US" sz="1200" dirty="0"/>
+            <a:endParaRPr lang="en-US" sz="1100" dirty="0"/>
           </a:p>
         </p:txBody>
       </p:sp>
@@ -3749,8 +3759,8 @@
         </p:nvSpPr>
         <p:spPr>
           <a:xfrm>
-            <a:off x="6309360" y="1463040"/>
-            <a:ext cx="91440" cy="640080"/>
+            <a:off x="6428232" y="1463040"/>
+            <a:ext cx="73152" cy="640080"/>
           </a:xfrm>
           <a:prstGeom prst="rect">
             <a:avLst/>
@@ -3788,8 +3798,8 @@
         </p:nvSpPr>
         <p:spPr>
           <a:xfrm>
-            <a:off x="6400800" y="1463040"/>
-            <a:ext cx="1097280" cy="640080"/>
+            <a:off x="6501384" y="1463040"/>
+            <a:ext cx="1188720" cy="640080"/>
           </a:xfrm>
           <a:prstGeom prst="roundRect">
             <a:avLst>
@@ -3801,7 +3811,7 @@
               <a:alpha val="50000"/>
             </a:srgbClr>
           </a:solidFill>
-          <a:ln w="25400">
+          <a:ln w="19050">
             <a:solidFill>
               <a:srgbClr val="635BFF"/>
             </a:solidFill>
@@ -3817,8 +3827,8 @@
         </p:nvSpPr>
         <p:spPr>
           <a:xfrm>
-            <a:off x="6400800" y="1463040"/>
-            <a:ext cx="1097280" cy="640080"/>
+            <a:off x="6501384" y="1463040"/>
+            <a:ext cx="1188720" cy="640080"/>
           </a:xfrm>
           <a:prstGeom prst="rect">
             <a:avLst/>
@@ -3827,14 +3837,16 @@
           <a:ln/>
         </p:spPr>
         <p:txBody>
-          <a:bodyPr wrap="square" lIns="0" tIns="0" rIns="0" bIns="0" rtlCol="0" anchor="ctr"/>
+          <a:bodyPr wrap="square" lIns="0" tIns="0" rIns="0" bIns="0" rtlCol="0" anchor="ctr">
+            <a:normAutofit/>
+          </a:bodyPr>
           <a:lstStyle/>
           <a:p>
             <a:pPr algn="ctr" indent="0" marL="0">
               <a:buNone/>
             </a:pPr>
             <a:r>
-              <a:rPr lang="en-US" sz="1200" b="1" dirty="0">
+              <a:rPr lang="en-US" sz="1100" b="1" dirty="0">
                 <a:solidFill>
                   <a:srgbClr val="635BFF"/>
                 </a:solidFill>
@@ -3844,7 +3856,7 @@
               </a:rPr>
               <a:t>Orchestrator</a:t>
             </a:r>
-            <a:endParaRPr lang="en-US" sz="1200" dirty="0"/>
+            <a:endParaRPr lang="en-US" sz="1100" dirty="0"/>
           </a:p>
         </p:txBody>
       </p:sp>
@@ -3856,8 +3868,8 @@
         </p:nvSpPr>
         <p:spPr>
           <a:xfrm>
-            <a:off x="7498080" y="1463040"/>
-            <a:ext cx="91440" cy="640080"/>
+            <a:off x="7690104" y="1463040"/>
+            <a:ext cx="73152" cy="640080"/>
           </a:xfrm>
           <a:prstGeom prst="rect">
             <a:avLst/>
@@ -3895,8 +3907,8 @@
         </p:nvSpPr>
         <p:spPr>
           <a:xfrm>
-            <a:off x="7589520" y="1463040"/>
-            <a:ext cx="1097280" cy="640080"/>
+            <a:off x="7763256" y="1463040"/>
+            <a:ext cx="1188720" cy="640080"/>
           </a:xfrm>
           <a:prstGeom prst="roundRect">
             <a:avLst>
@@ -3908,7 +3920,7 @@
               <a:alpha val="50000"/>
             </a:srgbClr>
           </a:solidFill>
-          <a:ln w="12700">
+          <a:ln w="19050">
             <a:solidFill>
               <a:srgbClr val="8B95A5"/>
             </a:solidFill>
@@ -3924,8 +3936,8 @@
         </p:nvSpPr>
         <p:spPr>
           <a:xfrm>
-            <a:off x="7589520" y="1463040"/>
-            <a:ext cx="1097280" cy="640080"/>
+            <a:off x="7763256" y="1463040"/>
+            <a:ext cx="1188720" cy="640080"/>
           </a:xfrm>
           <a:prstGeom prst="rect">
             <a:avLst/>
@@ -3934,14 +3946,16 @@
           <a:ln/>
         </p:spPr>
         <p:txBody>
-          <a:bodyPr wrap="square" lIns="0" tIns="0" rIns="0" bIns="0" rtlCol="0" anchor="ctr"/>
+          <a:bodyPr wrap="square" lIns="0" tIns="0" rIns="0" bIns="0" rtlCol="0" anchor="ctr">
+            <a:normAutofit/>
+          </a:bodyPr>
           <a:lstStyle/>
           <a:p>
             <a:pPr algn="ctr" indent="0" marL="0">
               <a:buNone/>
             </a:pPr>
             <a:r>
-              <a:rPr lang="en-US" sz="1200" b="1" dirty="0">
+              <a:rPr lang="en-US" sz="1100" b="1" dirty="0">
                 <a:solidFill>
                   <a:srgbClr val="8B95A5"/>
                 </a:solidFill>
@@ -3951,7 +3965,7 @@
               </a:rPr>
               <a:t>Builder</a:t>
             </a:r>
-            <a:endParaRPr lang="en-US" sz="1200" dirty="0"/>
+            <a:endParaRPr lang="en-US" sz="1100" dirty="0"/>
           </a:p>
         </p:txBody>
       </p:sp>
@@ -3980,7 +3994,7 @@
               <a:buNone/>
             </a:pPr>
             <a:r>
-              <a:rPr lang="en-US" sz="2800" b="1" dirty="0">
+              <a:rPr lang="en-US" sz="2400" b="1" dirty="0">
                 <a:solidFill>
                   <a:srgbClr val="635BFF"/>
                 </a:solidFill>
@@ -3990,7 +4004,7 @@
               </a:rPr>
               <a:t>Most of us are here.</a:t>
             </a:r>
-            <a:endParaRPr lang="en-US" sz="2800" dirty="0"/>
+            <a:endParaRPr lang="en-US" sz="2400" dirty="0"/>
           </a:p>
         </p:txBody>
       </p:sp>
@@ -4019,7 +4033,7 @@
               <a:buNone/>
             </a:pPr>
             <a:r>
-              <a:rPr lang="en-US" sz="2800" b="1" dirty="0">
+              <a:rPr lang="en-US" sz="2400" b="1" dirty="0">
                 <a:solidFill>
                   <a:srgbClr val="635BFF"/>
                 </a:solidFill>
@@ -4029,7 +4043,7 @@
               </a:rPr>
               <a:t>The AI Academy takes you here.</a:t>
             </a:r>
-            <a:endParaRPr lang="en-US" sz="2800" dirty="0"/>
+            <a:endParaRPr lang="en-US" sz="2400" dirty="0"/>
           </a:p>
         </p:txBody>
       </p:sp>

</xml_diff>